<commit_message>
docs(tcc): QR code da pagina do Mapill no slide de encerramento
</commit_message>
<xml_diff>
--- a/docs/tcc/apresentacao-mapill.pptx
+++ b/docs/tcc/apresentacao-mapill.pptx
@@ -1094,7 +1094,7 @@
           </a:p>
           <a:p>
             <a:r>
-              <a:t>Encerro por aqui. Obrigado pela atenção, e fico à disposição para as perguntas.</a:t>
+              <a:t>Encerro por aqui. Quem quiser conhecer o Mapill pode usar o QR code, que leva à página do aplicativo, onde também está o APK para instalar no Android. Obrigado pela atenção, e fico à disposição para as perguntas.</a:t>
             </a:r>
           </a:p>
         </p:txBody>
@@ -9809,9 +9809,59 @@
           <a:p/>
         </p:txBody>
       </p:sp>
+      <p:sp>
+        <p:nvSpPr>
+          <p:cNvPr id="3" name="Rounded Rectangle 2"/>
+          <p:cNvSpPr/>
+          <p:nvPr/>
+        </p:nvSpPr>
+        <p:spPr>
+          <a:xfrm>
+            <a:off x="8403336" y="1280160"/>
+            <a:ext cx="3200400" cy="4206240"/>
+          </a:xfrm>
+          <a:prstGeom prst="roundRect">
+            <a:avLst>
+              <a:gd name="adj" fmla="val 4000"/>
+            </a:avLst>
+          </a:prstGeom>
+          <a:solidFill>
+            <a:srgbClr val="FFFFFF"/>
+          </a:solidFill>
+          <a:ln>
+            <a:noFill/>
+          </a:ln>
+          <a:effectLst>
+            <a:outerShdw blurRad="127000" dist="25400" dir="5400000" algn="t" rotWithShape="0">
+              <a:srgbClr val="191C1E">
+                <a:alpha val="9000"/>
+              </a:srgbClr>
+            </a:outerShdw>
+          </a:effectLst>
+        </p:spPr>
+        <p:style>
+          <a:lnRef idx="1">
+            <a:schemeClr val="accent1"/>
+          </a:lnRef>
+          <a:fillRef idx="3">
+            <a:schemeClr val="accent1"/>
+          </a:fillRef>
+          <a:effectRef idx="2">
+            <a:schemeClr val="accent1"/>
+          </a:effectRef>
+          <a:fontRef idx="minor">
+            <a:schemeClr val="lt1"/>
+          </a:fontRef>
+        </p:style>
+        <p:txBody>
+          <a:bodyPr rtlCol="0" anchor="ctr"/>
+          <a:lstStyle/>
+          <a:p/>
+        </p:txBody>
+      </p:sp>
       <p:pic>
         <p:nvPicPr>
-          <p:cNvPr id="3" name="Picture 2" descr="p78_2.png"/>
+          <p:cNvPr id="4" name="Picture 3" descr="qr.png"/>
           <p:cNvPicPr>
             <a:picLocks noChangeAspect="1"/>
           </p:cNvPicPr>
@@ -9825,26 +9875,97 @@
         </p:blipFill>
         <p:spPr>
           <a:xfrm>
-            <a:off x="8732520" y="777240"/>
-            <a:ext cx="2365272" cy="5303520"/>
-          </a:xfrm>
-          <a:prstGeom prst="roundRect">
-            <a:avLst>
-              <a:gd name="adj" fmla="val 10824"/>
-            </a:avLst>
-          </a:prstGeom>
-          <a:effectLst>
-            <a:outerShdw blurRad="177800" dist="50800" dir="5400000" algn="t" rotWithShape="0">
-              <a:srgbClr val="191C1E">
-                <a:alpha val="14000"/>
-              </a:srgbClr>
-            </a:outerShdw>
-          </a:effectLst>
+            <a:off x="8769096" y="1645920"/>
+            <a:ext cx="2468880" cy="2468880"/>
+          </a:xfrm>
+          <a:prstGeom prst="rect">
+            <a:avLst/>
+          </a:prstGeom>
         </p:spPr>
       </p:pic>
+      <p:sp>
+        <p:nvSpPr>
+          <p:cNvPr id="5" name="TextBox 4"/>
+          <p:cNvSpPr txBox="1"/>
+          <p:nvPr/>
+        </p:nvSpPr>
+        <p:spPr>
+          <a:xfrm>
+            <a:off x="8403336" y="4343400"/>
+            <a:ext cx="3200400" cy="1097280"/>
+          </a:xfrm>
+          <a:prstGeom prst="rect">
+            <a:avLst/>
+          </a:prstGeom>
+          <a:noFill/>
+        </p:spPr>
+        <p:txBody>
+          <a:bodyPr wrap="square" lIns="0" rIns="0" tIns="0" bIns="0" anchor="t">
+            <a:spAutoFit/>
+          </a:bodyPr>
+          <a:lstStyle/>
+          <a:p>
+            <a:pPr algn="ctr">
+              <a:lnSpc>
+                <a:spcPct val="110000"/>
+              </a:lnSpc>
+              <a:spcAft>
+                <a:spcPts val="400"/>
+              </a:spcAft>
+            </a:pPr>
+            <a:r>
+              <a:rPr sz="1700" b="1">
+                <a:solidFill>
+                  <a:srgbClr val="191C1E"/>
+                </a:solidFill>
+                <a:latin typeface="Plus Jakarta Sans"/>
+              </a:rPr>
+              <a:t>Conheça o Mapill</a:t>
+            </a:r>
+          </a:p>
+          <a:p>
+            <a:pPr algn="ctr">
+              <a:lnSpc>
+                <a:spcPct val="110000"/>
+              </a:lnSpc>
+              <a:spcAft>
+                <a:spcPts val="400"/>
+              </a:spcAft>
+            </a:pPr>
+            <a:r>
+              <a:rPr sz="1300" b="0">
+                <a:solidFill>
+                  <a:srgbClr val="545F73"/>
+                </a:solidFill>
+                <a:latin typeface="Plus Jakarta Sans"/>
+              </a:rPr>
+              <a:t>Página do app, com o APK para Android</a:t>
+            </a:r>
+          </a:p>
+          <a:p>
+            <a:pPr algn="ctr">
+              <a:lnSpc>
+                <a:spcPct val="110000"/>
+              </a:lnSpc>
+              <a:spcAft>
+                <a:spcPts val="400"/>
+              </a:spcAft>
+            </a:pPr>
+            <a:r>
+              <a:rPr sz="1300" b="1">
+                <a:solidFill>
+                  <a:srgbClr val="0B5FD9"/>
+                </a:solidFill>
+                <a:latin typeface="Plus Jakarta Sans"/>
+              </a:rPr>
+              <a:t>mapill-website.vercel.app</a:t>
+            </a:r>
+          </a:p>
+        </p:txBody>
+      </p:sp>
       <p:pic>
         <p:nvPicPr>
-          <p:cNvPr id="4" name="Picture 3" descr="lockup-claro.png"/>
+          <p:cNvPr id="6" name="Picture 5" descr="lockup-claro.png"/>
           <p:cNvPicPr>
             <a:picLocks noChangeAspect="1"/>
           </p:cNvPicPr>
@@ -9868,7 +9989,7 @@
       </p:pic>
       <p:sp>
         <p:nvSpPr>
-          <p:cNvPr id="5" name="TextBox 4"/>
+          <p:cNvPr id="7" name="TextBox 6"/>
           <p:cNvSpPr txBox="1"/>
           <p:nvPr/>
         </p:nvSpPr>
@@ -9910,7 +10031,7 @@
       </p:sp>
       <p:sp>
         <p:nvSpPr>
-          <p:cNvPr id="6" name="TextBox 5"/>
+          <p:cNvPr id="8" name="TextBox 7"/>
           <p:cNvSpPr txBox="1"/>
           <p:nvPr/>
         </p:nvSpPr>
@@ -10009,7 +10130,7 @@
       </p:sp>
       <p:pic>
         <p:nvPicPr>
-          <p:cNvPr id="7" name="Picture 6" descr="unidavi.png"/>
+          <p:cNvPr id="9" name="Picture 8" descr="unidavi.png"/>
           <p:cNvPicPr>
             <a:picLocks noChangeAspect="1"/>
           </p:cNvPicPr>

</xml_diff>

<commit_message>
docs(tcc): justificativa foca na rotina do paciente, nao em agravamentos
</commit_message>
<xml_diff>
--- a/docs/tcc/apresentacao-mapill.pptx
+++ b/docs/tcc/apresentacao-mapill.pptx
@@ -1395,7 +1395,7 @@
           </a:p>
           <a:p>
             <a:r>
-              <a:t>Essa frase abre o meu trabalho, e resume por que ele existe. Quando o paciente não segue o tratamento, o quadro piora de um jeito que poderia ser evitado, e isso acaba em atendimentos de emergência e internações. Além disso, o remédio depende do horário certo, porque fora do intervalo ele oscila entre não fazer efeito e se tornar tóxico. Por isso o Mapill não tenta ser um aplicativo de saúde completo. Ele atua no ponto exato da falha, que é lembrar da dose, registrar o que aconteceu e avisar antes de o remédio acabar.</a:t>
+              <a:t>Essa frase abre o meu trabalho, e resume por que ele existe. Quase nunca o paciente deixa de tomar o remédio por descuido. O lembrete que ele usa, como um bilhete na geladeira, só funciona se ele passar por ali na hora certa, e controlar de cabeça o estoque e os horários de vários remédios cansa. E o horário importa, porque fora do intervalo o remédio oscila entre não fazer efeito e se tornar tóxico. Por isso o Mapill não tenta ser um aplicativo de saúde completo. Ele atua no ponto exato da falha, que é lembrar da dose, registrar o que aconteceu e avisar antes de o remédio acabar.</a:t>
             </a:r>
           </a:p>
         </p:txBody>
@@ -10227,6 +10227,43 @@
                 </a:solidFill>
                 <a:latin typeface="Plus Jakarta Sans"/>
               </a:rPr>
+              <a:t>NORMAN, Donald A. </a:t>
+            </a:r>
+            <a:r>
+              <a:rPr sz="1100" b="1">
+                <a:solidFill>
+                  <a:srgbClr val="191C1E"/>
+                </a:solidFill>
+                <a:latin typeface="Plus Jakarta Sans"/>
+              </a:rPr>
+              <a:t>The design of everyday things</a:t>
+            </a:r>
+            <a:r>
+              <a:rPr sz="1100" b="0">
+                <a:solidFill>
+                  <a:srgbClr val="191C1E"/>
+                </a:solidFill>
+                <a:latin typeface="Plus Jakarta Sans"/>
+              </a:rPr>
+              <a:t>. Revised and expanded edition. New York: Basic Books, 2013.</a:t>
+            </a:r>
+          </a:p>
+          <a:p>
+            <a:pPr algn="l">
+              <a:lnSpc>
+                <a:spcPct val="105000"/>
+              </a:lnSpc>
+              <a:spcAft>
+                <a:spcPts val="900"/>
+              </a:spcAft>
+            </a:pPr>
+            <a:r>
+              <a:rPr sz="1100" b="0">
+                <a:solidFill>
+                  <a:srgbClr val="191C1E"/>
+                </a:solidFill>
+                <a:latin typeface="Plus Jakarta Sans"/>
+              </a:rPr>
               <a:t>RISKO, Evan F.; GILBERT, Sam J. Cognitive offloading. </a:t>
             </a:r>
             <a:r>
@@ -11759,7 +11796,7 @@
             <a:avLst/>
           </a:prstGeom>
           <a:solidFill>
-            <a:srgbClr val="C90000"/>
+            <a:srgbClr val="0B5FD9"/>
           </a:solidFill>
           <a:ln>
             <a:noFill/>
@@ -11809,7 +11846,7 @@
                 </a:solidFill>
                 <a:latin typeface="Plus Jakarta Sans"/>
               </a:rPr>
-              <a:t>Agravamentos evitáveis</a:t>
+              <a:t>Lembrete preso ao lugar</a:t>
             </a:r>
           </a:p>
           <a:p>
@@ -11828,7 +11865,7 @@
                 </a:solidFill>
                 <a:latin typeface="Plus Jakarta Sans"/>
               </a:rPr>
-              <a:t>o quadro piora quando o tratamento é interrompido</a:t>
+              <a:t>o bilhete na geladeira só lembra quem passa por ela (Norman, 2013)</a:t>
             </a:r>
           </a:p>
         </p:txBody>
@@ -11878,7 +11915,7 @@
             <a:avLst/>
           </a:prstGeom>
           <a:solidFill>
-            <a:srgbClr val="C90000"/>
+            <a:srgbClr val="0B5FD9"/>
           </a:solidFill>
           <a:ln>
             <a:noFill/>
@@ -11928,7 +11965,7 @@
                 </a:solidFill>
                 <a:latin typeface="Plus Jakarta Sans"/>
               </a:rPr>
-              <a:t>Emergências e internações</a:t>
+              <a:t>Tudo de cabeça</a:t>
             </a:r>
           </a:p>
           <a:p>
@@ -11947,7 +11984,7 @@
                 </a:solidFill>
                 <a:latin typeface="Plus Jakarta Sans"/>
               </a:rPr>
-              <a:t>que o controle adequado da medicação evitaria</a:t>
+              <a:t>controlar estoque e horários de vários remédios cansa</a:t>
             </a:r>
           </a:p>
         </p:txBody>
@@ -11997,7 +12034,7 @@
             <a:avLst/>
           </a:prstGeom>
           <a:solidFill>
-            <a:srgbClr val="C90000"/>
+            <a:srgbClr val="0B5FD9"/>
           </a:solidFill>
           <a:ln>
             <a:noFill/>

</xml_diff>

<commit_message>
docs(tcc): cartoes da justificativa sem citacao indevida ao Norman
</commit_message>
<xml_diff>
--- a/docs/tcc/apresentacao-mapill.pptx
+++ b/docs/tcc/apresentacao-mapill.pptx
@@ -1395,7 +1395,7 @@
           </a:p>
           <a:p>
             <a:r>
-              <a:t>Essa frase abre o meu trabalho, e resume por que ele existe. Quase nunca o paciente deixa de tomar o remédio por descuido. O lembrete que ele usa, como um bilhete na geladeira, só funciona se ele passar por ali na hora certa, e controlar de cabeça o estoque e os horários de vários remédios cansa. E o horário importa, porque fora do intervalo o remédio oscila entre não fazer efeito e se tornar tóxico. Por isso o Mapill não tenta ser um aplicativo de saúde completo. Ele atua no ponto exato da falha, que é lembrar da dose, registrar o que aconteceu e avisar antes de o remédio acabar.</a:t>
+              <a:t>Essa frase abre o meu trabalho, e resume por que ele existe. Quase nunca o paciente deixa de tomar o remédio por descuido. Muitas vezes o lembrete é um bilhete na geladeira, que só funciona se ele passar por ali na hora certa, e controlar de cabeça o estoque e os horários de vários remédios sobrecarrega a memória. E o horário importa, porque fora do intervalo o remédio oscila entre não fazer efeito e se tornar tóxico. Por isso o Mapill não tenta ser um aplicativo de saúde completo. Ele atua no ponto exato da falha, que é lembrar da dose, registrar o que aconteceu e avisar antes de o remédio acabar.</a:t>
             </a:r>
           </a:p>
         </p:txBody>
@@ -10227,43 +10227,6 @@
                 </a:solidFill>
                 <a:latin typeface="Plus Jakarta Sans"/>
               </a:rPr>
-              <a:t>NORMAN, Donald A. </a:t>
-            </a:r>
-            <a:r>
-              <a:rPr sz="1100" b="1">
-                <a:solidFill>
-                  <a:srgbClr val="191C1E"/>
-                </a:solidFill>
-                <a:latin typeface="Plus Jakarta Sans"/>
-              </a:rPr>
-              <a:t>The design of everyday things</a:t>
-            </a:r>
-            <a:r>
-              <a:rPr sz="1100" b="0">
-                <a:solidFill>
-                  <a:srgbClr val="191C1E"/>
-                </a:solidFill>
-                <a:latin typeface="Plus Jakarta Sans"/>
-              </a:rPr>
-              <a:t>. Revised and expanded edition. New York: Basic Books, 2013.</a:t>
-            </a:r>
-          </a:p>
-          <a:p>
-            <a:pPr algn="l">
-              <a:lnSpc>
-                <a:spcPct val="105000"/>
-              </a:lnSpc>
-              <a:spcAft>
-                <a:spcPts val="900"/>
-              </a:spcAft>
-            </a:pPr>
-            <a:r>
-              <a:rPr sz="1100" b="0">
-                <a:solidFill>
-                  <a:srgbClr val="191C1E"/>
-                </a:solidFill>
-                <a:latin typeface="Plus Jakarta Sans"/>
-              </a:rPr>
               <a:t>RISKO, Evan F.; GILBERT, Sam J. Cognitive offloading. </a:t>
             </a:r>
             <a:r>
@@ -11865,7 +11828,7 @@
                 </a:solidFill>
                 <a:latin typeface="Plus Jakarta Sans"/>
               </a:rPr>
-              <a:t>o bilhete na geladeira só lembra quem passa por ela (Norman, 2013)</a:t>
+              <a:t>só funciona se o paciente estiver ali na hora certa</a:t>
             </a:r>
           </a:p>
         </p:txBody>
@@ -11984,7 +11947,7 @@
                 </a:solidFill>
                 <a:latin typeface="Plus Jakarta Sans"/>
               </a:rPr>
-              <a:t>controlar estoque e horários de vários remédios cansa</a:t>
+              <a:t>lembrar horários e calcular o estoque de vários remédios sobrecarrega a memória</a:t>
             </a:r>
           </a:p>
         </p:txBody>

</xml_diff>

<commit_message>
docs(tcc): cartao 'falta um lembrete confiavel' na justificativa
</commit_message>
<xml_diff>
--- a/docs/tcc/apresentacao-mapill.pptx
+++ b/docs/tcc/apresentacao-mapill.pptx
@@ -11809,7 +11809,7 @@
                 </a:solidFill>
                 <a:latin typeface="Plus Jakarta Sans"/>
               </a:rPr>
-              <a:t>Lembrete preso ao lugar</a:t>
+              <a:t>Falta um lembrete confiável</a:t>
             </a:r>
           </a:p>
           <a:p>
@@ -11828,7 +11828,7 @@
                 </a:solidFill>
                 <a:latin typeface="Plus Jakarta Sans"/>
               </a:rPr>
-              <a:t>só funciona se o paciente estiver ali na hora certa</a:t>
+              <a:t>bilhetes e anotações só funcionam se o paciente olhar na hora certa</a:t>
             </a:r>
           </a:p>
         </p:txBody>

</xml_diff>

<commit_message>
docs(tcc): justificativa com exemplos de falha cognitiva e logistica
</commit_message>
<xml_diff>
--- a/docs/tcc/apresentacao-mapill.pptx
+++ b/docs/tcc/apresentacao-mapill.pptx
@@ -1395,7 +1395,7 @@
           </a:p>
           <a:p>
             <a:r>
-              <a:t>Essa frase abre o meu trabalho, e resume por que ele existe. Quase nunca o paciente deixa de tomar o remédio por descuido. Muitas vezes o lembrete é um bilhete na geladeira, que só funciona se ele passar por ali na hora certa, e controlar de cabeça o estoque e os horários de vários remédios sobrecarrega a memória. E o horário importa, porque fora do intervalo o remédio oscila entre não fazer efeito e se tornar tóxico. Por isso o Mapill não tenta ser um aplicativo de saúde completo. Ele atua no ponto exato da falha, que é lembrar da dose, registrar o que aconteceu e avisar antes de o remédio acabar.</a:t>
+              <a:t>Essa frase abre o meu trabalho, e resume por que ele existe. As duas falhas que eu comentei aparecem no dia a dia de formas bem concretas. Na cognitiva, o paciente esquece a dose, ou não lembra se já tomou. O Mapill avisa no horário, mesmo com o aplicativo fechado, e guarda cada resposta com data e hora. Na logística, o remédio acaba sem aviso, ou a consulta e a receita passam do prazo. O app desconta o estoque a cada dose e avisa antes de acabar, e lembra dos compromissos e da validade da receita.</a:t>
             </a:r>
           </a:p>
         </p:txBody>
@@ -9945,43 +9945,6 @@
                 </a:solidFill>
                 <a:latin typeface="Plus Jakarta Sans"/>
               </a:rPr>
-              <a:t>BRUNTON, Laurence L.; KNOLLMANN, Björn C. (ed.). </a:t>
-            </a:r>
-            <a:r>
-              <a:rPr sz="1100" b="1">
-                <a:solidFill>
-                  <a:srgbClr val="191C1E"/>
-                </a:solidFill>
-                <a:latin typeface="Plus Jakarta Sans"/>
-              </a:rPr>
-              <a:t>As bases farmacológicas da terapêutica de Goodman &amp; Gilman</a:t>
-            </a:r>
-            <a:r>
-              <a:rPr sz="1100" b="0">
-                <a:solidFill>
-                  <a:srgbClr val="191C1E"/>
-                </a:solidFill>
-                <a:latin typeface="Plus Jakarta Sans"/>
-              </a:rPr>
-              <a:t>. 14. ed. Porto Alegre: Artmed, 2024.</a:t>
-            </a:r>
-          </a:p>
-          <a:p>
-            <a:pPr algn="l">
-              <a:lnSpc>
-                <a:spcPct val="105000"/>
-              </a:lnSpc>
-              <a:spcAft>
-                <a:spcPts val="900"/>
-              </a:spcAft>
-            </a:pPr>
-            <a:r>
-              <a:rPr sz="1100" b="0">
-                <a:solidFill>
-                  <a:srgbClr val="191C1E"/>
-                </a:solidFill>
-                <a:latin typeface="Plus Jakarta Sans"/>
-              </a:rPr>
               <a:t>KLEPPMANN, Martin. </a:t>
             </a:r>
             <a:r>
@@ -11723,11 +11686,11 @@
         <p:spPr>
           <a:xfrm>
             <a:off x="685800" y="2377440"/>
-            <a:ext cx="3454298" cy="1920240"/>
+            <a:ext cx="5272887" cy="3429000"/>
           </a:xfrm>
           <a:prstGeom prst="roundRect">
             <a:avLst>
-              <a:gd name="adj" fmla="val 6666"/>
+              <a:gd name="adj" fmla="val 3733"/>
             </a:avLst>
           </a:prstGeom>
           <a:solidFill>
@@ -11746,20 +11709,132 @@
       </p:sp>
       <p:sp>
         <p:nvSpPr>
-          <p:cNvPr id="8" name="Rectangle 7"/>
+          <p:cNvPr id="8" name="TextBox 7"/>
+          <p:cNvSpPr txBox="1"/>
+          <p:nvPr/>
+        </p:nvSpPr>
+        <p:spPr>
+          <a:xfrm>
+            <a:off x="1051560" y="2606040"/>
+            <a:ext cx="4541367" cy="365760"/>
+          </a:xfrm>
+          <a:prstGeom prst="rect">
+            <a:avLst/>
+          </a:prstGeom>
+          <a:noFill/>
+        </p:spPr>
+        <p:txBody>
+          <a:bodyPr wrap="square" lIns="0" rIns="0" tIns="0" bIns="0" anchor="t">
+            <a:spAutoFit/>
+          </a:bodyPr>
+          <a:lstStyle/>
+          <a:p>
+            <a:pPr algn="l">
+              <a:lnSpc>
+                <a:spcPct val="110000"/>
+              </a:lnSpc>
+              <a:spcAft>
+                <a:spcPts val="600"/>
+              </a:spcAft>
+            </a:pPr>
+            <a:r>
+              <a:rPr sz="1200" b="1" spc="200">
+                <a:solidFill>
+                  <a:srgbClr val="0B5FD9"/>
+                </a:solidFill>
+                <a:latin typeface="Plus Jakarta Sans"/>
+              </a:rPr>
+              <a:t>FALHA COGNITIVA</a:t>
+            </a:r>
+          </a:p>
+        </p:txBody>
+      </p:sp>
+      <p:sp>
+        <p:nvSpPr>
+          <p:cNvPr id="9" name="TextBox 8"/>
+          <p:cNvSpPr txBox="1"/>
+          <p:nvPr/>
+        </p:nvSpPr>
+        <p:spPr>
+          <a:xfrm>
+            <a:off x="1051560" y="3108960"/>
+            <a:ext cx="4541367" cy="1097280"/>
+          </a:xfrm>
+          <a:prstGeom prst="rect">
+            <a:avLst/>
+          </a:prstGeom>
+          <a:noFill/>
+        </p:spPr>
+        <p:txBody>
+          <a:bodyPr wrap="square" lIns="0" rIns="0" tIns="0" bIns="0" anchor="t">
+            <a:spAutoFit/>
+          </a:bodyPr>
+          <a:lstStyle/>
+          <a:p>
+            <a:pPr algn="l">
+              <a:lnSpc>
+                <a:spcPct val="110000"/>
+              </a:lnSpc>
+              <a:spcAft>
+                <a:spcPts val="400"/>
+              </a:spcAft>
+            </a:pPr>
+            <a:r>
+              <a:rPr sz="1900" b="1">
+                <a:solidFill>
+                  <a:srgbClr val="191C1E"/>
+                </a:solidFill>
+                <a:latin typeface="Plus Jakarta Sans"/>
+              </a:rPr>
+              <a:t>Esqueceu a dose</a:t>
+            </a:r>
+          </a:p>
+          <a:p>
+            <a:pPr algn="l">
+              <a:lnSpc>
+                <a:spcPct val="110000"/>
+              </a:lnSpc>
+              <a:spcAft>
+                <a:spcPts val="400"/>
+              </a:spcAft>
+            </a:pPr>
+            <a:r>
+              <a:rPr sz="1500" b="1">
+                <a:solidFill>
+                  <a:srgbClr val="0B5FD9"/>
+                </a:solidFill>
+                <a:latin typeface="Plus Jakarta Sans"/>
+              </a:rPr>
+              <a:t>→  </a:t>
+            </a:r>
+            <a:r>
+              <a:rPr sz="1500" b="0">
+                <a:solidFill>
+                  <a:srgbClr val="545F73"/>
+                </a:solidFill>
+                <a:latin typeface="Plus Jakarta Sans"/>
+              </a:rPr>
+              <a:t>alarme no horário, mesmo com o app fechado</a:t>
+            </a:r>
+          </a:p>
+        </p:txBody>
+      </p:sp>
+      <p:sp>
+        <p:nvSpPr>
+          <p:cNvPr id="10" name="Rectangle 9"/>
           <p:cNvSpPr/>
           <p:nvPr/>
         </p:nvSpPr>
         <p:spPr>
           <a:xfrm>
-            <a:off x="685800" y="2377440"/>
-            <a:ext cx="3454298" cy="91440"/>
+            <a:off x="1051560" y="4206240"/>
+            <a:ext cx="4541367" cy="18288"/>
           </a:xfrm>
           <a:prstGeom prst="rect">
             <a:avLst/>
           </a:prstGeom>
           <a:solidFill>
-            <a:srgbClr val="0B5FD9"/>
+            <a:srgbClr val="E3E7EE"/>
           </a:solidFill>
           <a:ln>
             <a:noFill/>
@@ -11774,14 +11849,14 @@
       </p:sp>
       <p:sp>
         <p:nvSpPr>
-          <p:cNvPr id="9" name="TextBox 8"/>
-          <p:cNvSpPr txBox="1"/>
-          <p:nvPr/>
-        </p:nvSpPr>
-        <p:spPr>
-          <a:xfrm>
-            <a:off x="1005840" y="2697480"/>
-            <a:ext cx="2814218" cy="1554480"/>
+          <p:cNvPr id="11" name="TextBox 10"/>
+          <p:cNvSpPr txBox="1"/>
+          <p:nvPr/>
+        </p:nvSpPr>
+        <p:spPr>
+          <a:xfrm>
+            <a:off x="1051560" y="4389120"/>
+            <a:ext cx="4541367" cy="1097280"/>
           </a:xfrm>
           <a:prstGeom prst="rect">
             <a:avLst/>
@@ -11799,7 +11874,7 @@
                 <a:spcPct val="110000"/>
               </a:lnSpc>
               <a:spcAft>
-                <a:spcPts val="500"/>
+                <a:spcPts val="400"/>
               </a:spcAft>
             </a:pPr>
             <a:r>
@@ -11809,18 +11884,27 @@
                 </a:solidFill>
                 <a:latin typeface="Plus Jakarta Sans"/>
               </a:rPr>
-              <a:t>Falta um lembrete confiável</a:t>
-            </a:r>
-          </a:p>
-          <a:p>
-            <a:pPr algn="l">
-              <a:lnSpc>
-                <a:spcPct val="110000"/>
-              </a:lnSpc>
-              <a:spcAft>
-                <a:spcPts val="500"/>
-              </a:spcAft>
-            </a:pPr>
+              <a:t>Não lembra se já tomou</a:t>
+            </a:r>
+          </a:p>
+          <a:p>
+            <a:pPr algn="l">
+              <a:lnSpc>
+                <a:spcPct val="110000"/>
+              </a:lnSpc>
+              <a:spcAft>
+                <a:spcPts val="400"/>
+              </a:spcAft>
+            </a:pPr>
+            <a:r>
+              <a:rPr sz="1500" b="1">
+                <a:solidFill>
+                  <a:srgbClr val="0B5FD9"/>
+                </a:solidFill>
+                <a:latin typeface="Plus Jakarta Sans"/>
+              </a:rPr>
+              <a:t>→  </a:t>
+            </a:r>
             <a:r>
               <a:rPr sz="1500" b="0">
                 <a:solidFill>
@@ -11828,25 +11912,25 @@
                 </a:solidFill>
                 <a:latin typeface="Plus Jakarta Sans"/>
               </a:rPr>
-              <a:t>bilhetes e anotações só funcionam se o paciente olhar na hora certa</a:t>
-            </a:r>
-          </a:p>
-        </p:txBody>
-      </p:sp>
-      <p:sp>
-        <p:nvSpPr>
-          <p:cNvPr id="10" name="Rounded Rectangle 9"/>
+              <a:t>cada resposta fica registrada com data e hora</a:t>
+            </a:r>
+          </a:p>
+        </p:txBody>
+      </p:sp>
+      <p:sp>
+        <p:nvSpPr>
+          <p:cNvPr id="12" name="Rounded Rectangle 11"/>
           <p:cNvSpPr/>
           <p:nvPr/>
         </p:nvSpPr>
         <p:spPr>
           <a:xfrm>
-            <a:off x="4368698" y="2377440"/>
-            <a:ext cx="3454298" cy="1920240"/>
+            <a:off x="6233007" y="2377440"/>
+            <a:ext cx="5272887" cy="3429000"/>
           </a:xfrm>
           <a:prstGeom prst="roundRect">
             <a:avLst>
-              <a:gd name="adj" fmla="val 6666"/>
+              <a:gd name="adj" fmla="val 3733"/>
             </a:avLst>
           </a:prstGeom>
           <a:solidFill>
@@ -11865,20 +11949,132 @@
       </p:sp>
       <p:sp>
         <p:nvSpPr>
-          <p:cNvPr id="11" name="Rectangle 10"/>
+          <p:cNvPr id="13" name="TextBox 12"/>
+          <p:cNvSpPr txBox="1"/>
+          <p:nvPr/>
+        </p:nvSpPr>
+        <p:spPr>
+          <a:xfrm>
+            <a:off x="6598767" y="2606040"/>
+            <a:ext cx="4541367" cy="365760"/>
+          </a:xfrm>
+          <a:prstGeom prst="rect">
+            <a:avLst/>
+          </a:prstGeom>
+          <a:noFill/>
+        </p:spPr>
+        <p:txBody>
+          <a:bodyPr wrap="square" lIns="0" rIns="0" tIns="0" bIns="0" anchor="t">
+            <a:spAutoFit/>
+          </a:bodyPr>
+          <a:lstStyle/>
+          <a:p>
+            <a:pPr algn="l">
+              <a:lnSpc>
+                <a:spcPct val="110000"/>
+              </a:lnSpc>
+              <a:spcAft>
+                <a:spcPts val="600"/>
+              </a:spcAft>
+            </a:pPr>
+            <a:r>
+              <a:rPr sz="1200" b="1" spc="200">
+                <a:solidFill>
+                  <a:srgbClr val="0B5FD9"/>
+                </a:solidFill>
+                <a:latin typeface="Plus Jakarta Sans"/>
+              </a:rPr>
+              <a:t>FALHA LOGÍSTICA</a:t>
+            </a:r>
+          </a:p>
+        </p:txBody>
+      </p:sp>
+      <p:sp>
+        <p:nvSpPr>
+          <p:cNvPr id="14" name="TextBox 13"/>
+          <p:cNvSpPr txBox="1"/>
+          <p:nvPr/>
+        </p:nvSpPr>
+        <p:spPr>
+          <a:xfrm>
+            <a:off x="6598767" y="3108960"/>
+            <a:ext cx="4541367" cy="1097280"/>
+          </a:xfrm>
+          <a:prstGeom prst="rect">
+            <a:avLst/>
+          </a:prstGeom>
+          <a:noFill/>
+        </p:spPr>
+        <p:txBody>
+          <a:bodyPr wrap="square" lIns="0" rIns="0" tIns="0" bIns="0" anchor="t">
+            <a:spAutoFit/>
+          </a:bodyPr>
+          <a:lstStyle/>
+          <a:p>
+            <a:pPr algn="l">
+              <a:lnSpc>
+                <a:spcPct val="110000"/>
+              </a:lnSpc>
+              <a:spcAft>
+                <a:spcPts val="400"/>
+              </a:spcAft>
+            </a:pPr>
+            <a:r>
+              <a:rPr sz="1900" b="1">
+                <a:solidFill>
+                  <a:srgbClr val="191C1E"/>
+                </a:solidFill>
+                <a:latin typeface="Plus Jakarta Sans"/>
+              </a:rPr>
+              <a:t>O remédio acabou</a:t>
+            </a:r>
+          </a:p>
+          <a:p>
+            <a:pPr algn="l">
+              <a:lnSpc>
+                <a:spcPct val="110000"/>
+              </a:lnSpc>
+              <a:spcAft>
+                <a:spcPts val="400"/>
+              </a:spcAft>
+            </a:pPr>
+            <a:r>
+              <a:rPr sz="1500" b="1">
+                <a:solidFill>
+                  <a:srgbClr val="0B5FD9"/>
+                </a:solidFill>
+                <a:latin typeface="Plus Jakarta Sans"/>
+              </a:rPr>
+              <a:t>→  </a:t>
+            </a:r>
+            <a:r>
+              <a:rPr sz="1500" b="0">
+                <a:solidFill>
+                  <a:srgbClr val="545F73"/>
+                </a:solidFill>
+                <a:latin typeface="Plus Jakarta Sans"/>
+              </a:rPr>
+              <a:t>estoque descontado a cada dose, com aviso antes de acabar</a:t>
+            </a:r>
+          </a:p>
+        </p:txBody>
+      </p:sp>
+      <p:sp>
+        <p:nvSpPr>
+          <p:cNvPr id="15" name="Rectangle 14"/>
           <p:cNvSpPr/>
           <p:nvPr/>
         </p:nvSpPr>
         <p:spPr>
           <a:xfrm>
-            <a:off x="4368698" y="2377440"/>
-            <a:ext cx="3454298" cy="91440"/>
+            <a:off x="6598767" y="4206240"/>
+            <a:ext cx="4541367" cy="18288"/>
           </a:xfrm>
           <a:prstGeom prst="rect">
             <a:avLst/>
           </a:prstGeom>
           <a:solidFill>
-            <a:srgbClr val="0B5FD9"/>
+            <a:srgbClr val="E3E7EE"/>
           </a:solidFill>
           <a:ln>
             <a:noFill/>
@@ -11893,14 +12089,14 @@
       </p:sp>
       <p:sp>
         <p:nvSpPr>
-          <p:cNvPr id="12" name="TextBox 11"/>
-          <p:cNvSpPr txBox="1"/>
-          <p:nvPr/>
-        </p:nvSpPr>
-        <p:spPr>
-          <a:xfrm>
-            <a:off x="4688738" y="2697480"/>
-            <a:ext cx="2814218" cy="1554480"/>
+          <p:cNvPr id="16" name="TextBox 15"/>
+          <p:cNvSpPr txBox="1"/>
+          <p:nvPr/>
+        </p:nvSpPr>
+        <p:spPr>
+          <a:xfrm>
+            <a:off x="6598767" y="4389120"/>
+            <a:ext cx="4541367" cy="1097280"/>
           </a:xfrm>
           <a:prstGeom prst="rect">
             <a:avLst/>
@@ -11918,7 +12114,7 @@
                 <a:spcPct val="110000"/>
               </a:lnSpc>
               <a:spcAft>
-                <a:spcPts val="500"/>
+                <a:spcPts val="400"/>
               </a:spcAft>
             </a:pPr>
             <a:r>
@@ -11928,18 +12124,27 @@
                 </a:solidFill>
                 <a:latin typeface="Plus Jakarta Sans"/>
               </a:rPr>
-              <a:t>Tudo de cabeça</a:t>
-            </a:r>
-          </a:p>
-          <a:p>
-            <a:pPr algn="l">
-              <a:lnSpc>
-                <a:spcPct val="110000"/>
-              </a:lnSpc>
-              <a:spcAft>
-                <a:spcPts val="500"/>
-              </a:spcAft>
-            </a:pPr>
+              <a:t>A consulta ou a receita passou</a:t>
+            </a:r>
+          </a:p>
+          <a:p>
+            <a:pPr algn="l">
+              <a:lnSpc>
+                <a:spcPct val="110000"/>
+              </a:lnSpc>
+              <a:spcAft>
+                <a:spcPts val="400"/>
+              </a:spcAft>
+            </a:pPr>
+            <a:r>
+              <a:rPr sz="1500" b="1">
+                <a:solidFill>
+                  <a:srgbClr val="0B5FD9"/>
+                </a:solidFill>
+                <a:latin typeface="Plus Jakarta Sans"/>
+              </a:rPr>
+              <a:t>→  </a:t>
+            </a:r>
             <a:r>
               <a:rPr sz="1500" b="0">
                 <a:solidFill>
@@ -11947,217 +12152,7 @@
                 </a:solidFill>
                 <a:latin typeface="Plus Jakarta Sans"/>
               </a:rPr>
-              <a:t>lembrar horários e calcular o estoque de vários remédios sobrecarrega a memória</a:t>
-            </a:r>
-          </a:p>
-        </p:txBody>
-      </p:sp>
-      <p:sp>
-        <p:nvSpPr>
-          <p:cNvPr id="13" name="Rounded Rectangle 12"/>
-          <p:cNvSpPr/>
-          <p:nvPr/>
-        </p:nvSpPr>
-        <p:spPr>
-          <a:xfrm>
-            <a:off x="8051596" y="2377440"/>
-            <a:ext cx="3454298" cy="1920240"/>
-          </a:xfrm>
-          <a:prstGeom prst="roundRect">
-            <a:avLst>
-              <a:gd name="adj" fmla="val 6666"/>
-            </a:avLst>
-          </a:prstGeom>
-          <a:solidFill>
-            <a:srgbClr val="FFFFFF"/>
-          </a:solidFill>
-          <a:ln>
-            <a:noFill/>
-          </a:ln>
-          <a:effectLst/>
-        </p:spPr>
-        <p:txBody>
-          <a:bodyPr rtlCol="0" anchor="ctr"/>
-          <a:lstStyle/>
-          <a:p/>
-        </p:txBody>
-      </p:sp>
-      <p:sp>
-        <p:nvSpPr>
-          <p:cNvPr id="14" name="Rectangle 13"/>
-          <p:cNvSpPr/>
-          <p:nvPr/>
-        </p:nvSpPr>
-        <p:spPr>
-          <a:xfrm>
-            <a:off x="8051596" y="2377440"/>
-            <a:ext cx="3454298" cy="91440"/>
-          </a:xfrm>
-          <a:prstGeom prst="rect">
-            <a:avLst/>
-          </a:prstGeom>
-          <a:solidFill>
-            <a:srgbClr val="0B5FD9"/>
-          </a:solidFill>
-          <a:ln>
-            <a:noFill/>
-          </a:ln>
-          <a:effectLst/>
-        </p:spPr>
-        <p:txBody>
-          <a:bodyPr rtlCol="0" anchor="ctr"/>
-          <a:lstStyle/>
-          <a:p/>
-        </p:txBody>
-      </p:sp>
-      <p:sp>
-        <p:nvSpPr>
-          <p:cNvPr id="15" name="TextBox 14"/>
-          <p:cNvSpPr txBox="1"/>
-          <p:nvPr/>
-        </p:nvSpPr>
-        <p:spPr>
-          <a:xfrm>
-            <a:off x="8371636" y="2697480"/>
-            <a:ext cx="2814218" cy="1554480"/>
-          </a:xfrm>
-          <a:prstGeom prst="rect">
-            <a:avLst/>
-          </a:prstGeom>
-          <a:noFill/>
-        </p:spPr>
-        <p:txBody>
-          <a:bodyPr wrap="square" lIns="0" rIns="0" tIns="0" bIns="0" anchor="t">
-            <a:spAutoFit/>
-          </a:bodyPr>
-          <a:lstStyle/>
-          <a:p>
-            <a:pPr algn="l">
-              <a:lnSpc>
-                <a:spcPct val="110000"/>
-              </a:lnSpc>
-              <a:spcAft>
-                <a:spcPts val="500"/>
-              </a:spcAft>
-            </a:pPr>
-            <a:r>
-              <a:rPr sz="1900" b="1">
-                <a:solidFill>
-                  <a:srgbClr val="191C1E"/>
-                </a:solidFill>
-                <a:latin typeface="Plus Jakarta Sans"/>
-              </a:rPr>
-              <a:t>Horário importa</a:t>
-            </a:r>
-          </a:p>
-          <a:p>
-            <a:pPr algn="l">
-              <a:lnSpc>
-                <a:spcPct val="110000"/>
-              </a:lnSpc>
-              <a:spcAft>
-                <a:spcPts val="500"/>
-              </a:spcAft>
-            </a:pPr>
-            <a:r>
-              <a:rPr sz="1500" b="0">
-                <a:solidFill>
-                  <a:srgbClr val="545F73"/>
-                </a:solidFill>
-                <a:latin typeface="Plus Jakarta Sans"/>
-              </a:rPr>
-              <a:t>fora do intervalo, o remédio oscila entre ineficácia e toxicidade (Brunton; Knollmann, 2024)</a:t>
-            </a:r>
-          </a:p>
-        </p:txBody>
-      </p:sp>
-      <p:sp>
-        <p:nvSpPr>
-          <p:cNvPr id="16" name="Rounded Rectangle 15"/>
-          <p:cNvSpPr/>
-          <p:nvPr/>
-        </p:nvSpPr>
-        <p:spPr>
-          <a:xfrm>
-            <a:off x="685800" y="4572000"/>
-            <a:ext cx="10820095" cy="1234440"/>
-          </a:xfrm>
-          <a:prstGeom prst="roundRect">
-            <a:avLst>
-              <a:gd name="adj" fmla="val 10370"/>
-            </a:avLst>
-          </a:prstGeom>
-          <a:solidFill>
-            <a:srgbClr val="EAF1FE"/>
-          </a:solidFill>
-          <a:ln>
-            <a:noFill/>
-          </a:ln>
-          <a:effectLst/>
-        </p:spPr>
-        <p:txBody>
-          <a:bodyPr rtlCol="0" anchor="ctr"/>
-          <a:lstStyle/>
-          <a:p/>
-        </p:txBody>
-      </p:sp>
-      <p:sp>
-        <p:nvSpPr>
-          <p:cNvPr id="17" name="TextBox 16"/>
-          <p:cNvSpPr txBox="1"/>
-          <p:nvPr/>
-        </p:nvSpPr>
-        <p:spPr>
-          <a:xfrm>
-            <a:off x="1051560" y="4572000"/>
-            <a:ext cx="10088575" cy="1234440"/>
-          </a:xfrm>
-          <a:prstGeom prst="rect">
-            <a:avLst/>
-          </a:prstGeom>
-          <a:noFill/>
-        </p:spPr>
-        <p:txBody>
-          <a:bodyPr wrap="square" lIns="0" rIns="0" tIns="0" bIns="0" anchor="ctr">
-            <a:spAutoFit/>
-          </a:bodyPr>
-          <a:lstStyle/>
-          <a:p>
-            <a:pPr algn="l">
-              <a:lnSpc>
-                <a:spcPct val="110000"/>
-              </a:lnSpc>
-              <a:spcAft>
-                <a:spcPts val="400"/>
-              </a:spcAft>
-            </a:pPr>
-            <a:r>
-              <a:rPr sz="1100" b="1" spc="200">
-                <a:solidFill>
-                  <a:srgbClr val="0A3F8F"/>
-                </a:solidFill>
-                <a:latin typeface="Plus Jakarta Sans"/>
-              </a:rPr>
-              <a:t>O MAPILL ATUA NO PONTO DA FALHA</a:t>
-            </a:r>
-          </a:p>
-          <a:p>
-            <a:pPr algn="l">
-              <a:lnSpc>
-                <a:spcPct val="110000"/>
-              </a:lnSpc>
-              <a:spcAft>
-                <a:spcPts val="400"/>
-              </a:spcAft>
-            </a:pPr>
-            <a:r>
-              <a:rPr sz="2000" b="1">
-                <a:solidFill>
-                  <a:srgbClr val="0A3F8F"/>
-                </a:solidFill>
-                <a:latin typeface="Plus Jakarta Sans"/>
-              </a:rPr>
-              <a:t>Lembrar a dose  ·  registrar o que aconteceu  ·  avisar antes de o remédio acabar</a:t>
+              <a:t>compromissos e validade da receita com lembrete</a:t>
             </a:r>
           </a:p>
         </p:txBody>

</xml_diff>

<commit_message>
docs(tcc): fundamentacao explica cada conceito em linguagem simples
</commit_message>
<xml_diff>
--- a/docs/tcc/apresentacao-mapill.pptx
+++ b/docs/tcc/apresentacao-mapill.pptx
@@ -3309,36 +3309,14 @@
           </a:bodyPr>
           <a:lstStyle/>
           <a:p>
-            <a:pPr indent="0" lvl="0" marL="0" rtl="0" algn="l">
-              <a:spcBef>
-                <a:spcPts val="0"/>
-              </a:spcBef>
-              <a:spcAft>
-                <a:spcPts val="0"/>
-              </a:spcAft>
-              <a:buNone/>
-            </a:pPr>
-            <a:r>
-              <a:rPr lang="en-US"/>
-              <a:t>[1 min]</a:t>
-            </a:r>
-            <a:endParaRPr/>
-          </a:p>
-          <a:p>
-            <a:pPr indent="0" lvl="0" marL="0" rtl="0" algn="l">
-              <a:spcBef>
-                <a:spcPts val="0"/>
-              </a:spcBef>
-              <a:spcAft>
-                <a:spcPts val="0"/>
-              </a:spcAft>
-              <a:buNone/>
-            </a:pPr>
-            <a:r>
-              <a:rPr lang="en-US"/>
-              <a:t>Vou passar rápido pela fundamentação, só pelo que justifica as principais decisões do projeto. Esquecer a dose é uma falha da memória prospectiva, que é lembrar de fazer algo no futuro, e por isso o centro do app é um alarme. A desoneração cognitiva explica por que o app deve calcular estoque e horários pelo paciente. O conceito de fonte única de verdade justifica juntar tudo num só lugar. O paradigma offline-first e o critério Last-Write-Wins sustentam o funcionamento sem internet e a sincronização. E as heurísticas de Nielsen, as diretrizes de acessibilidade da WCAG e a LGPD orientam a interface e o tratamento dos dados de saúde.</a:t>
-            </a:r>
-            <a:endParaRPr/>
+            <a:r>
+              <a:t>[1 min 10 s]</a:t>
+            </a:r>
+          </a:p>
+          <a:p>
+            <a:r>
+              <a:t>Vou passar rápido pela fundamentação, só pelo que sustenta as decisões do projeto. A memória prospectiva é a que usamos para lembrar de fazer algo no futuro, como tomar o remédio às oito horas, e é justamente ela que falha quando a dose é esquecida. Por isso o centro do app é um alarme, que lembra pelo paciente. A desoneração cognitiva é passar para uma ferramenta aquilo que a cabeça teria de guardar ou calcular, e é o que o app faz com o estoque e os horários. A fonte única de verdade é ter um só lugar com a informação certa, por isso remédios, estoque e consultas ficam no mesmo aplicativo. O offline-first é o app funcionar sem internet, e o Last-Write-Wins define que, num conflito entre duas edições, vence a mais recente. E as heurísticas de Nielsen, a WCAG e a LGPD orientam a interface, a acessibilidade e a proteção dos dados.</a:t>
+            </a:r>
           </a:p>
         </p:txBody>
       </p:sp>
@@ -27065,18 +27043,144 @@
       </p:sp>
       <p:sp>
         <p:nvSpPr>
-          <p:cNvPr id="216" name="Google Shape;216;p7"/>
+          <p:cNvPr id="216" name="TextBox 215"/>
+          <p:cNvSpPr txBox="1"/>
+          <p:nvPr/>
+        </p:nvSpPr>
+        <p:spPr>
+          <a:xfrm>
+            <a:off x="1005840" y="1572768"/>
+            <a:ext cx="3017520" cy="274320"/>
+          </a:xfrm>
+          <a:prstGeom prst="rect">
+            <a:avLst/>
+          </a:prstGeom>
+          <a:noFill/>
+        </p:spPr>
+        <p:txBody>
+          <a:bodyPr wrap="square" lIns="0" rIns="0" tIns="0" bIns="0" anchor="t">
+            <a:spAutoFit/>
+          </a:bodyPr>
+          <a:lstStyle/>
+          <a:p>
+            <a:pPr algn="l">
+              <a:lnSpc>
+                <a:spcPct val="110000"/>
+              </a:lnSpc>
+              <a:spcAft>
+                <a:spcPts val="600"/>
+              </a:spcAft>
+            </a:pPr>
+            <a:r>
+              <a:rPr sz="1100" b="1" spc="200">
+                <a:solidFill>
+                  <a:srgbClr val="545F73"/>
+                </a:solidFill>
+                <a:latin typeface="Plus Jakarta Sans"/>
+              </a:rPr>
+              <a:t>CONCEITO</a:t>
+            </a:r>
+          </a:p>
+        </p:txBody>
+      </p:sp>
+      <p:sp>
+        <p:nvSpPr>
+          <p:cNvPr id="217" name="TextBox 216"/>
+          <p:cNvSpPr txBox="1"/>
+          <p:nvPr/>
+        </p:nvSpPr>
+        <p:spPr>
+          <a:xfrm>
+            <a:off x="4297680" y="1572768"/>
+            <a:ext cx="4160520" cy="274320"/>
+          </a:xfrm>
+          <a:prstGeom prst="rect">
+            <a:avLst/>
+          </a:prstGeom>
+          <a:noFill/>
+        </p:spPr>
+        <p:txBody>
+          <a:bodyPr wrap="square" lIns="0" rIns="0" tIns="0" bIns="0" anchor="t">
+            <a:spAutoFit/>
+          </a:bodyPr>
+          <a:lstStyle/>
+          <a:p>
+            <a:pPr algn="l">
+              <a:lnSpc>
+                <a:spcPct val="110000"/>
+              </a:lnSpc>
+              <a:spcAft>
+                <a:spcPts val="600"/>
+              </a:spcAft>
+            </a:pPr>
+            <a:r>
+              <a:rPr sz="1100" b="1" spc="200">
+                <a:solidFill>
+                  <a:srgbClr val="545F73"/>
+                </a:solidFill>
+                <a:latin typeface="Plus Jakarta Sans"/>
+              </a:rPr>
+              <a:t>O QUE É</a:t>
+            </a:r>
+          </a:p>
+        </p:txBody>
+      </p:sp>
+      <p:sp>
+        <p:nvSpPr>
+          <p:cNvPr id="218" name="TextBox 217"/>
+          <p:cNvSpPr txBox="1"/>
+          <p:nvPr/>
+        </p:nvSpPr>
+        <p:spPr>
+          <a:xfrm>
+            <a:off x="8778240" y="1572768"/>
+            <a:ext cx="2423160" cy="274320"/>
+          </a:xfrm>
+          <a:prstGeom prst="rect">
+            <a:avLst/>
+          </a:prstGeom>
+          <a:noFill/>
+        </p:spPr>
+        <p:txBody>
+          <a:bodyPr wrap="square" lIns="0" rIns="0" tIns="0" bIns="0" anchor="t">
+            <a:spAutoFit/>
+          </a:bodyPr>
+          <a:lstStyle/>
+          <a:p>
+            <a:pPr algn="l">
+              <a:lnSpc>
+                <a:spcPct val="110000"/>
+              </a:lnSpc>
+              <a:spcAft>
+                <a:spcPts val="600"/>
+              </a:spcAft>
+            </a:pPr>
+            <a:r>
+              <a:rPr sz="1100" b="1" spc="200">
+                <a:solidFill>
+                  <a:srgbClr val="545F73"/>
+                </a:solidFill>
+                <a:latin typeface="Plus Jakarta Sans"/>
+              </a:rPr>
+              <a:t>NO MAPILL</a:t>
+            </a:r>
+          </a:p>
+        </p:txBody>
+      </p:sp>
+      <p:sp>
+        <p:nvSpPr>
+          <p:cNvPr id="219" name="Rounded Rectangle 218"/>
           <p:cNvSpPr/>
           <p:nvPr/>
         </p:nvSpPr>
         <p:spPr>
           <a:xfrm>
-            <a:off x="685800" y="1783080"/>
-            <a:ext cx="10820095" cy="713232"/>
+            <a:off x="685800" y="1901952"/>
+            <a:ext cx="10820095" cy="749808"/>
           </a:xfrm>
           <a:prstGeom prst="roundRect">
             <a:avLst>
-              <a:gd fmla="val 17948" name="adj"/>
+              <a:gd name="adj" fmla="val 17073"/>
             </a:avLst>
           </a:prstGeom>
           <a:solidFill>
@@ -27085,237 +27189,207 @@
           <a:ln>
             <a:noFill/>
           </a:ln>
-        </p:spPr>
-        <p:txBody>
-          <a:bodyPr anchorCtr="0" anchor="ctr" bIns="45700" lIns="91425" spcFirstLastPara="1" rIns="91425" wrap="square" tIns="45700">
-            <a:noAutofit/>
-          </a:bodyPr>
+          <a:effectLst/>
+        </p:spPr>
+        <p:txBody>
+          <a:bodyPr rtlCol="0" anchor="ctr"/>
           <a:lstStyle/>
           <a:p>
-            <a:pPr indent="0" lvl="0" marL="0" marR="0" rtl="0" algn="l">
-              <a:spcBef>
-                <a:spcPts val="0"/>
-              </a:spcBef>
-              <a:spcAft>
-                <a:spcPts val="0"/>
-              </a:spcAft>
-              <a:buNone/>
-            </a:pPr>
-            <a:r>
-              <a:t/>
-            </a:r>
-            <a:endParaRPr sz="1800">
-              <a:solidFill>
-                <a:schemeClr val="dk1"/>
-              </a:solidFill>
-              <a:latin typeface="Calibri"/>
-              <a:ea typeface="Calibri"/>
-              <a:cs typeface="Calibri"/>
-              <a:sym typeface="Calibri"/>
-            </a:endParaRPr>
-          </a:p>
-        </p:txBody>
-      </p:sp>
-      <p:sp>
-        <p:nvSpPr>
-          <p:cNvPr id="217" name="Google Shape;217;p7"/>
+            <a:pPr algn="ctr"/>
+          </a:p>
+        </p:txBody>
+      </p:sp>
+      <p:sp>
+        <p:nvSpPr>
+          <p:cNvPr id="220" name="Rounded Rectangle 219"/>
+          <p:cNvSpPr/>
+          <p:nvPr/>
+        </p:nvSpPr>
+        <p:spPr>
+          <a:xfrm>
+            <a:off x="8549640" y="1901952"/>
+            <a:ext cx="2956255" cy="749808"/>
+          </a:xfrm>
+          <a:prstGeom prst="roundRect">
+            <a:avLst>
+              <a:gd name="adj" fmla="val 17073"/>
+            </a:avLst>
+          </a:prstGeom>
+          <a:solidFill>
+            <a:srgbClr val="EAF1FE"/>
+          </a:solidFill>
+          <a:ln>
+            <a:noFill/>
+          </a:ln>
+          <a:effectLst/>
+        </p:spPr>
+        <p:txBody>
+          <a:bodyPr rtlCol="0" anchor="ctr"/>
+          <a:lstStyle/>
+          <a:p>
+            <a:pPr algn="ctr"/>
+          </a:p>
+        </p:txBody>
+      </p:sp>
+      <p:sp>
+        <p:nvSpPr>
+          <p:cNvPr id="221" name="TextBox 220"/>
           <p:cNvSpPr txBox="1"/>
           <p:nvPr/>
         </p:nvSpPr>
         <p:spPr>
           <a:xfrm>
-            <a:off x="1005840" y="1783080"/>
-            <a:ext cx="5120640" cy="713232"/>
+            <a:off x="1005840" y="1901952"/>
+            <a:ext cx="3017520" cy="749808"/>
           </a:xfrm>
           <a:prstGeom prst="rect">
             <a:avLst/>
           </a:prstGeom>
           <a:noFill/>
-          <a:ln>
-            <a:noFill/>
-          </a:ln>
-        </p:spPr>
-        <p:txBody>
-          <a:bodyPr anchorCtr="0" anchor="ctr" bIns="0" lIns="0" spcFirstLastPara="1" rIns="0" wrap="square" tIns="0">
+        </p:spPr>
+        <p:txBody>
+          <a:bodyPr wrap="square" lIns="0" rIns="0" tIns="0" bIns="0" anchor="ctr">
             <a:spAutoFit/>
           </a:bodyPr>
           <a:lstStyle/>
           <a:p>
-            <a:pPr indent="0" lvl="0" marL="0" marR="0" rtl="0" algn="l">
+            <a:pPr algn="l">
               <a:lnSpc>
-                <a:spcPct val="110000"/>
+                <a:spcPct val="100000"/>
               </a:lnSpc>
-              <a:spcBef>
-                <a:spcPts val="0"/>
-              </a:spcBef>
-              <a:spcAft>
-                <a:spcPts val="0"/>
-              </a:spcAft>
-              <a:buNone/>
-            </a:pPr>
-            <a:r>
-              <a:rPr b="1" lang="en-US" sz="1700">
+              <a:spcAft>
+                <a:spcPts val="100"/>
+              </a:spcAft>
+            </a:pPr>
+            <a:r>
+              <a:rPr sz="1500" b="1">
                 <a:solidFill>
                   <a:srgbClr val="191C1E"/>
                 </a:solidFill>
                 <a:latin typeface="Plus Jakarta Sans"/>
-                <a:ea typeface="Plus Jakarta Sans"/>
-                <a:cs typeface="Plus Jakarta Sans"/>
-                <a:sym typeface="Plus Jakarta Sans"/>
               </a:rPr>
               <a:t>Memória prospectiva</a:t>
             </a:r>
-            <a:endParaRPr/>
-          </a:p>
-          <a:p>
-            <a:pPr indent="0" lvl="0" marL="0" marR="0" rtl="0" algn="l">
+          </a:p>
+          <a:p>
+            <a:pPr algn="l">
               <a:lnSpc>
-                <a:spcPct val="110000"/>
+                <a:spcPct val="100000"/>
               </a:lnSpc>
-              <a:spcBef>
-                <a:spcPts val="0"/>
-              </a:spcBef>
-              <a:spcAft>
-                <a:spcPts val="0"/>
-              </a:spcAft>
-              <a:buNone/>
-            </a:pPr>
-            <a:r>
-              <a:rPr b="0" lang="en-US" sz="1200">
+              <a:spcAft>
+                <a:spcPts val="100"/>
+              </a:spcAft>
+            </a:pPr>
+            <a:r>
+              <a:rPr sz="1000" b="0">
                 <a:solidFill>
                   <a:srgbClr val="545F73"/>
                 </a:solidFill>
                 <a:latin typeface="Plus Jakarta Sans"/>
-                <a:ea typeface="Plus Jakarta Sans"/>
-                <a:cs typeface="Plus Jakarta Sans"/>
-                <a:sym typeface="Plus Jakarta Sans"/>
               </a:rPr>
               <a:t>Baddeley; Eysenck; Anderson, 2010</a:t>
             </a:r>
-            <a:endParaRPr/>
-          </a:p>
-        </p:txBody>
-      </p:sp>
-      <p:sp>
-        <p:nvSpPr>
-          <p:cNvPr id="218" name="Google Shape;218;p7"/>
+          </a:p>
+        </p:txBody>
+      </p:sp>
+      <p:sp>
+        <p:nvSpPr>
+          <p:cNvPr id="222" name="TextBox 221"/>
           <p:cNvSpPr txBox="1"/>
           <p:nvPr/>
         </p:nvSpPr>
         <p:spPr>
           <a:xfrm>
-            <a:off x="5989320" y="1783080"/>
-            <a:ext cx="457200" cy="713232"/>
+            <a:off x="4297680" y="1901952"/>
+            <a:ext cx="4160520" cy="749808"/>
           </a:xfrm>
           <a:prstGeom prst="rect">
             <a:avLst/>
           </a:prstGeom>
           <a:noFill/>
-          <a:ln>
-            <a:noFill/>
-          </a:ln>
-        </p:spPr>
-        <p:txBody>
-          <a:bodyPr anchorCtr="0" anchor="ctr" bIns="0" lIns="0" spcFirstLastPara="1" rIns="0" wrap="square" tIns="0">
+        </p:spPr>
+        <p:txBody>
+          <a:bodyPr wrap="square" lIns="0" rIns="0" tIns="0" bIns="0" anchor="ctr">
             <a:spAutoFit/>
           </a:bodyPr>
           <a:lstStyle/>
           <a:p>
-            <a:pPr indent="0" lvl="0" marL="0" marR="0" rtl="0" algn="l">
+            <a:pPr algn="l">
               <a:lnSpc>
-                <a:spcPct val="110000"/>
+                <a:spcPct val="105000"/>
               </a:lnSpc>
-              <a:spcBef>
-                <a:spcPts val="0"/>
-              </a:spcBef>
-              <a:spcAft>
-                <a:spcPts val="0"/>
-              </a:spcAft>
-              <a:buNone/>
-            </a:pPr>
-            <a:r>
-              <a:rPr b="1" lang="en-US" sz="2000">
-                <a:solidFill>
-                  <a:srgbClr val="0B5FD9"/>
+              <a:spcAft>
+                <a:spcPts val="600"/>
+              </a:spcAft>
+            </a:pPr>
+            <a:r>
+              <a:rPr sz="1300" b="0">
+                <a:solidFill>
+                  <a:srgbClr val="191C1E"/>
                 </a:solidFill>
                 <a:latin typeface="Plus Jakarta Sans"/>
-                <a:ea typeface="Plus Jakarta Sans"/>
-                <a:cs typeface="Plus Jakarta Sans"/>
-                <a:sym typeface="Plus Jakarta Sans"/>
               </a:rPr>
-              <a:t>→</a:t>
-            </a:r>
-            <a:endParaRPr/>
-          </a:p>
-        </p:txBody>
-      </p:sp>
-      <p:sp>
-        <p:nvSpPr>
-          <p:cNvPr id="219" name="Google Shape;219;p7"/>
+              <a:t>lembrar de fazer algo no futuro, como tomar o remédio às 8h</a:t>
+            </a:r>
+          </a:p>
+        </p:txBody>
+      </p:sp>
+      <p:sp>
+        <p:nvSpPr>
+          <p:cNvPr id="223" name="TextBox 222"/>
           <p:cNvSpPr txBox="1"/>
           <p:nvPr/>
         </p:nvSpPr>
         <p:spPr>
           <a:xfrm>
-            <a:off x="6537960" y="1783080"/>
-            <a:ext cx="4754880" cy="713232"/>
+            <a:off x="8778240" y="1901952"/>
+            <a:ext cx="2423160" cy="749808"/>
           </a:xfrm>
           <a:prstGeom prst="rect">
             <a:avLst/>
           </a:prstGeom>
           <a:noFill/>
-          <a:ln>
-            <a:noFill/>
-          </a:ln>
-        </p:spPr>
-        <p:txBody>
-          <a:bodyPr anchorCtr="0" anchor="ctr" bIns="0" lIns="0" spcFirstLastPara="1" rIns="0" wrap="square" tIns="0">
+        </p:spPr>
+        <p:txBody>
+          <a:bodyPr wrap="square" lIns="0" rIns="0" tIns="0" bIns="0" anchor="ctr">
             <a:spAutoFit/>
           </a:bodyPr>
           <a:lstStyle/>
           <a:p>
-            <a:pPr indent="0" lvl="0" marL="0" marR="0" rtl="0" algn="l">
+            <a:pPr algn="l">
               <a:lnSpc>
-                <a:spcPct val="110000"/>
+                <a:spcPct val="105000"/>
               </a:lnSpc>
-              <a:spcBef>
-                <a:spcPts val="0"/>
-              </a:spcBef>
-              <a:spcAft>
-                <a:spcPts val="0"/>
-              </a:spcAft>
-              <a:buNone/>
-            </a:pPr>
-            <a:r>
-              <a:rPr b="0" lang="en-US" sz="1700">
-                <a:solidFill>
-                  <a:srgbClr val="191C1E"/>
+              <a:spcAft>
+                <a:spcPts val="600"/>
+              </a:spcAft>
+            </a:pPr>
+            <a:r>
+              <a:rPr sz="1300" b="1">
+                <a:solidFill>
+                  <a:srgbClr val="0A3F8F"/>
                 </a:solidFill>
                 <a:latin typeface="Plus Jakarta Sans"/>
-                <a:ea typeface="Plus Jakarta Sans"/>
-                <a:cs typeface="Plus Jakarta Sans"/>
-                <a:sym typeface="Plus Jakarta Sans"/>
               </a:rPr>
-              <a:t>O alarme é a pista externa</a:t>
-            </a:r>
-            <a:endParaRPr/>
-          </a:p>
-        </p:txBody>
-      </p:sp>
-      <p:sp>
-        <p:nvSpPr>
-          <p:cNvPr id="220" name="Google Shape;220;p7"/>
+              <a:t>o alarme lembra pelo paciente</a:t>
+            </a:r>
+          </a:p>
+        </p:txBody>
+      </p:sp>
+      <p:sp>
+        <p:nvSpPr>
+          <p:cNvPr id="224" name="Rounded Rectangle 223"/>
           <p:cNvSpPr/>
           <p:nvPr/>
         </p:nvSpPr>
         <p:spPr>
           <a:xfrm>
-            <a:off x="685800" y="2633472"/>
-            <a:ext cx="10820095" cy="713232"/>
+            <a:off x="685800" y="2743200"/>
+            <a:ext cx="10820095" cy="749808"/>
           </a:xfrm>
           <a:prstGeom prst="roundRect">
             <a:avLst>
-              <a:gd fmla="val 17948" name="adj"/>
+              <a:gd name="adj" fmla="val 17073"/>
             </a:avLst>
           </a:prstGeom>
           <a:solidFill>
@@ -27324,237 +27398,207 @@
           <a:ln>
             <a:noFill/>
           </a:ln>
-        </p:spPr>
-        <p:txBody>
-          <a:bodyPr anchorCtr="0" anchor="ctr" bIns="45700" lIns="91425" spcFirstLastPara="1" rIns="91425" wrap="square" tIns="45700">
-            <a:noAutofit/>
-          </a:bodyPr>
+          <a:effectLst/>
+        </p:spPr>
+        <p:txBody>
+          <a:bodyPr rtlCol="0" anchor="ctr"/>
           <a:lstStyle/>
           <a:p>
-            <a:pPr indent="0" lvl="0" marL="0" marR="0" rtl="0" algn="l">
-              <a:spcBef>
-                <a:spcPts val="0"/>
-              </a:spcBef>
-              <a:spcAft>
-                <a:spcPts val="0"/>
-              </a:spcAft>
-              <a:buNone/>
-            </a:pPr>
-            <a:r>
-              <a:t/>
-            </a:r>
-            <a:endParaRPr sz="1800">
-              <a:solidFill>
-                <a:schemeClr val="dk1"/>
-              </a:solidFill>
-              <a:latin typeface="Calibri"/>
-              <a:ea typeface="Calibri"/>
-              <a:cs typeface="Calibri"/>
-              <a:sym typeface="Calibri"/>
-            </a:endParaRPr>
-          </a:p>
-        </p:txBody>
-      </p:sp>
-      <p:sp>
-        <p:nvSpPr>
-          <p:cNvPr id="221" name="Google Shape;221;p7"/>
+            <a:pPr algn="ctr"/>
+          </a:p>
+        </p:txBody>
+      </p:sp>
+      <p:sp>
+        <p:nvSpPr>
+          <p:cNvPr id="225" name="Rounded Rectangle 224"/>
+          <p:cNvSpPr/>
+          <p:nvPr/>
+        </p:nvSpPr>
+        <p:spPr>
+          <a:xfrm>
+            <a:off x="8549640" y="2743200"/>
+            <a:ext cx="2956255" cy="749808"/>
+          </a:xfrm>
+          <a:prstGeom prst="roundRect">
+            <a:avLst>
+              <a:gd name="adj" fmla="val 17073"/>
+            </a:avLst>
+          </a:prstGeom>
+          <a:solidFill>
+            <a:srgbClr val="EAF1FE"/>
+          </a:solidFill>
+          <a:ln>
+            <a:noFill/>
+          </a:ln>
+          <a:effectLst/>
+        </p:spPr>
+        <p:txBody>
+          <a:bodyPr rtlCol="0" anchor="ctr"/>
+          <a:lstStyle/>
+          <a:p>
+            <a:pPr algn="ctr"/>
+          </a:p>
+        </p:txBody>
+      </p:sp>
+      <p:sp>
+        <p:nvSpPr>
+          <p:cNvPr id="226" name="TextBox 225"/>
           <p:cNvSpPr txBox="1"/>
           <p:nvPr/>
         </p:nvSpPr>
         <p:spPr>
           <a:xfrm>
-            <a:off x="1005840" y="2633472"/>
-            <a:ext cx="5120640" cy="713232"/>
+            <a:off x="1005840" y="2743200"/>
+            <a:ext cx="3017520" cy="749808"/>
           </a:xfrm>
           <a:prstGeom prst="rect">
             <a:avLst/>
           </a:prstGeom>
           <a:noFill/>
-          <a:ln>
-            <a:noFill/>
-          </a:ln>
-        </p:spPr>
-        <p:txBody>
-          <a:bodyPr anchorCtr="0" anchor="ctr" bIns="0" lIns="0" spcFirstLastPara="1" rIns="0" wrap="square" tIns="0">
+        </p:spPr>
+        <p:txBody>
+          <a:bodyPr wrap="square" lIns="0" rIns="0" tIns="0" bIns="0" anchor="ctr">
             <a:spAutoFit/>
           </a:bodyPr>
           <a:lstStyle/>
           <a:p>
-            <a:pPr indent="0" lvl="0" marL="0" marR="0" rtl="0" algn="l">
+            <a:pPr algn="l">
               <a:lnSpc>
-                <a:spcPct val="110000"/>
+                <a:spcPct val="100000"/>
               </a:lnSpc>
-              <a:spcBef>
-                <a:spcPts val="0"/>
-              </a:spcBef>
-              <a:spcAft>
-                <a:spcPts val="0"/>
-              </a:spcAft>
-              <a:buNone/>
-            </a:pPr>
-            <a:r>
-              <a:rPr b="1" lang="en-US" sz="1700">
+              <a:spcAft>
+                <a:spcPts val="100"/>
+              </a:spcAft>
+            </a:pPr>
+            <a:r>
+              <a:rPr sz="1500" b="1">
                 <a:solidFill>
                   <a:srgbClr val="191C1E"/>
                 </a:solidFill>
                 <a:latin typeface="Plus Jakarta Sans"/>
-                <a:ea typeface="Plus Jakarta Sans"/>
-                <a:cs typeface="Plus Jakarta Sans"/>
-                <a:sym typeface="Plus Jakarta Sans"/>
               </a:rPr>
               <a:t>Desoneração cognitiva</a:t>
             </a:r>
-            <a:endParaRPr/>
-          </a:p>
-          <a:p>
-            <a:pPr indent="0" lvl="0" marL="0" marR="0" rtl="0" algn="l">
+          </a:p>
+          <a:p>
+            <a:pPr algn="l">
               <a:lnSpc>
-                <a:spcPct val="110000"/>
+                <a:spcPct val="100000"/>
               </a:lnSpc>
-              <a:spcBef>
-                <a:spcPts val="0"/>
-              </a:spcBef>
-              <a:spcAft>
-                <a:spcPts val="0"/>
-              </a:spcAft>
-              <a:buNone/>
-            </a:pPr>
-            <a:r>
-              <a:rPr b="0" lang="en-US" sz="1200">
+              <a:spcAft>
+                <a:spcPts val="100"/>
+              </a:spcAft>
+            </a:pPr>
+            <a:r>
+              <a:rPr sz="1000" b="0">
                 <a:solidFill>
                   <a:srgbClr val="545F73"/>
                 </a:solidFill>
                 <a:latin typeface="Plus Jakarta Sans"/>
-                <a:ea typeface="Plus Jakarta Sans"/>
-                <a:cs typeface="Plus Jakarta Sans"/>
-                <a:sym typeface="Plus Jakarta Sans"/>
               </a:rPr>
               <a:t>Risko; Gilbert, 2016</a:t>
             </a:r>
-            <a:endParaRPr/>
-          </a:p>
-        </p:txBody>
-      </p:sp>
-      <p:sp>
-        <p:nvSpPr>
-          <p:cNvPr id="222" name="Google Shape;222;p7"/>
+          </a:p>
+        </p:txBody>
+      </p:sp>
+      <p:sp>
+        <p:nvSpPr>
+          <p:cNvPr id="227" name="TextBox 226"/>
           <p:cNvSpPr txBox="1"/>
           <p:nvPr/>
         </p:nvSpPr>
         <p:spPr>
           <a:xfrm>
-            <a:off x="5989320" y="2633472"/>
-            <a:ext cx="457200" cy="713232"/>
+            <a:off x="4297680" y="2743200"/>
+            <a:ext cx="4160520" cy="749808"/>
           </a:xfrm>
           <a:prstGeom prst="rect">
             <a:avLst/>
           </a:prstGeom>
           <a:noFill/>
-          <a:ln>
-            <a:noFill/>
-          </a:ln>
-        </p:spPr>
-        <p:txBody>
-          <a:bodyPr anchorCtr="0" anchor="ctr" bIns="0" lIns="0" spcFirstLastPara="1" rIns="0" wrap="square" tIns="0">
+        </p:spPr>
+        <p:txBody>
+          <a:bodyPr wrap="square" lIns="0" rIns="0" tIns="0" bIns="0" anchor="ctr">
             <a:spAutoFit/>
           </a:bodyPr>
           <a:lstStyle/>
           <a:p>
-            <a:pPr indent="0" lvl="0" marL="0" marR="0" rtl="0" algn="l">
+            <a:pPr algn="l">
               <a:lnSpc>
-                <a:spcPct val="110000"/>
+                <a:spcPct val="105000"/>
               </a:lnSpc>
-              <a:spcBef>
-                <a:spcPts val="0"/>
-              </a:spcBef>
-              <a:spcAft>
-                <a:spcPts val="0"/>
-              </a:spcAft>
-              <a:buNone/>
-            </a:pPr>
-            <a:r>
-              <a:rPr b="1" lang="en-US" sz="2000">
-                <a:solidFill>
-                  <a:srgbClr val="0B5FD9"/>
+              <a:spcAft>
+                <a:spcPts val="600"/>
+              </a:spcAft>
+            </a:pPr>
+            <a:r>
+              <a:rPr sz="1300" b="0">
+                <a:solidFill>
+                  <a:srgbClr val="191C1E"/>
                 </a:solidFill>
                 <a:latin typeface="Plus Jakarta Sans"/>
-                <a:ea typeface="Plus Jakarta Sans"/>
-                <a:cs typeface="Plus Jakarta Sans"/>
-                <a:sym typeface="Plus Jakarta Sans"/>
               </a:rPr>
-              <a:t>→</a:t>
-            </a:r>
-            <a:endParaRPr/>
-          </a:p>
-        </p:txBody>
-      </p:sp>
-      <p:sp>
-        <p:nvSpPr>
-          <p:cNvPr id="223" name="Google Shape;223;p7"/>
+              <a:t>passar para uma ferramenta o que a cabeça teria de guardar ou calcular</a:t>
+            </a:r>
+          </a:p>
+        </p:txBody>
+      </p:sp>
+      <p:sp>
+        <p:nvSpPr>
+          <p:cNvPr id="228" name="TextBox 227"/>
           <p:cNvSpPr txBox="1"/>
           <p:nvPr/>
         </p:nvSpPr>
         <p:spPr>
           <a:xfrm>
-            <a:off x="6537960" y="2633472"/>
-            <a:ext cx="4754880" cy="713232"/>
+            <a:off x="8778240" y="2743200"/>
+            <a:ext cx="2423160" cy="749808"/>
           </a:xfrm>
           <a:prstGeom prst="rect">
             <a:avLst/>
           </a:prstGeom>
           <a:noFill/>
-          <a:ln>
-            <a:noFill/>
-          </a:ln>
-        </p:spPr>
-        <p:txBody>
-          <a:bodyPr anchorCtr="0" anchor="ctr" bIns="0" lIns="0" spcFirstLastPara="1" rIns="0" wrap="square" tIns="0">
+        </p:spPr>
+        <p:txBody>
+          <a:bodyPr wrap="square" lIns="0" rIns="0" tIns="0" bIns="0" anchor="ctr">
             <a:spAutoFit/>
           </a:bodyPr>
           <a:lstStyle/>
           <a:p>
-            <a:pPr indent="0" lvl="0" marL="0" marR="0" rtl="0" algn="l">
+            <a:pPr algn="l">
               <a:lnSpc>
-                <a:spcPct val="110000"/>
+                <a:spcPct val="105000"/>
               </a:lnSpc>
-              <a:spcBef>
-                <a:spcPts val="0"/>
-              </a:spcBef>
-              <a:spcAft>
-                <a:spcPts val="0"/>
-              </a:spcAft>
-              <a:buNone/>
-            </a:pPr>
-            <a:r>
-              <a:rPr b="0" lang="en-US" sz="1700">
-                <a:solidFill>
-                  <a:srgbClr val="191C1E"/>
+              <a:spcAft>
+                <a:spcPts val="600"/>
+              </a:spcAft>
+            </a:pPr>
+            <a:r>
+              <a:rPr sz="1300" b="1">
+                <a:solidFill>
+                  <a:srgbClr val="0A3F8F"/>
                 </a:solidFill>
                 <a:latin typeface="Plus Jakarta Sans"/>
-                <a:ea typeface="Plus Jakarta Sans"/>
-                <a:cs typeface="Plus Jakarta Sans"/>
-                <a:sym typeface="Plus Jakarta Sans"/>
               </a:rPr>
-              <a:t>O app calcula estoque e horários</a:t>
-            </a:r>
-            <a:endParaRPr/>
-          </a:p>
-        </p:txBody>
-      </p:sp>
-      <p:sp>
-        <p:nvSpPr>
-          <p:cNvPr id="224" name="Google Shape;224;p7"/>
+              <a:t>o app calcula estoque e horários</a:t>
+            </a:r>
+          </a:p>
+        </p:txBody>
+      </p:sp>
+      <p:sp>
+        <p:nvSpPr>
+          <p:cNvPr id="229" name="Rounded Rectangle 228"/>
           <p:cNvSpPr/>
           <p:nvPr/>
         </p:nvSpPr>
         <p:spPr>
           <a:xfrm>
-            <a:off x="685800" y="3483864"/>
-            <a:ext cx="10820095" cy="713232"/>
+            <a:off x="685800" y="3584448"/>
+            <a:ext cx="10820095" cy="749808"/>
           </a:xfrm>
           <a:prstGeom prst="roundRect">
             <a:avLst>
-              <a:gd fmla="val 17948" name="adj"/>
+              <a:gd name="adj" fmla="val 17073"/>
             </a:avLst>
           </a:prstGeom>
           <a:solidFill>
@@ -27563,237 +27607,207 @@
           <a:ln>
             <a:noFill/>
           </a:ln>
-        </p:spPr>
-        <p:txBody>
-          <a:bodyPr anchorCtr="0" anchor="ctr" bIns="45700" lIns="91425" spcFirstLastPara="1" rIns="91425" wrap="square" tIns="45700">
-            <a:noAutofit/>
-          </a:bodyPr>
+          <a:effectLst/>
+        </p:spPr>
+        <p:txBody>
+          <a:bodyPr rtlCol="0" anchor="ctr"/>
           <a:lstStyle/>
           <a:p>
-            <a:pPr indent="0" lvl="0" marL="0" marR="0" rtl="0" algn="l">
-              <a:spcBef>
-                <a:spcPts val="0"/>
-              </a:spcBef>
-              <a:spcAft>
-                <a:spcPts val="0"/>
-              </a:spcAft>
-              <a:buNone/>
-            </a:pPr>
-            <a:r>
-              <a:t/>
-            </a:r>
-            <a:endParaRPr sz="1800">
-              <a:solidFill>
-                <a:schemeClr val="dk1"/>
-              </a:solidFill>
-              <a:latin typeface="Calibri"/>
-              <a:ea typeface="Calibri"/>
-              <a:cs typeface="Calibri"/>
-              <a:sym typeface="Calibri"/>
-            </a:endParaRPr>
-          </a:p>
-        </p:txBody>
-      </p:sp>
-      <p:sp>
-        <p:nvSpPr>
-          <p:cNvPr id="225" name="Google Shape;225;p7"/>
+            <a:pPr algn="ctr"/>
+          </a:p>
+        </p:txBody>
+      </p:sp>
+      <p:sp>
+        <p:nvSpPr>
+          <p:cNvPr id="230" name="Rounded Rectangle 229"/>
+          <p:cNvSpPr/>
+          <p:nvPr/>
+        </p:nvSpPr>
+        <p:spPr>
+          <a:xfrm>
+            <a:off x="8549640" y="3584448"/>
+            <a:ext cx="2956255" cy="749808"/>
+          </a:xfrm>
+          <a:prstGeom prst="roundRect">
+            <a:avLst>
+              <a:gd name="adj" fmla="val 17073"/>
+            </a:avLst>
+          </a:prstGeom>
+          <a:solidFill>
+            <a:srgbClr val="EAF1FE"/>
+          </a:solidFill>
+          <a:ln>
+            <a:noFill/>
+          </a:ln>
+          <a:effectLst/>
+        </p:spPr>
+        <p:txBody>
+          <a:bodyPr rtlCol="0" anchor="ctr"/>
+          <a:lstStyle/>
+          <a:p>
+            <a:pPr algn="ctr"/>
+          </a:p>
+        </p:txBody>
+      </p:sp>
+      <p:sp>
+        <p:nvSpPr>
+          <p:cNvPr id="231" name="TextBox 230"/>
           <p:cNvSpPr txBox="1"/>
           <p:nvPr/>
         </p:nvSpPr>
         <p:spPr>
           <a:xfrm>
-            <a:off x="1005840" y="3483864"/>
-            <a:ext cx="5120640" cy="713232"/>
+            <a:off x="1005840" y="3584448"/>
+            <a:ext cx="3017520" cy="749808"/>
           </a:xfrm>
           <a:prstGeom prst="rect">
             <a:avLst/>
           </a:prstGeom>
           <a:noFill/>
-          <a:ln>
-            <a:noFill/>
-          </a:ln>
-        </p:spPr>
-        <p:txBody>
-          <a:bodyPr anchorCtr="0" anchor="ctr" bIns="0" lIns="0" spcFirstLastPara="1" rIns="0" wrap="square" tIns="0">
+        </p:spPr>
+        <p:txBody>
+          <a:bodyPr wrap="square" lIns="0" rIns="0" tIns="0" bIns="0" anchor="ctr">
             <a:spAutoFit/>
           </a:bodyPr>
           <a:lstStyle/>
           <a:p>
-            <a:pPr indent="0" lvl="0" marL="0" marR="0" rtl="0" algn="l">
+            <a:pPr algn="l">
               <a:lnSpc>
-                <a:spcPct val="110000"/>
+                <a:spcPct val="100000"/>
               </a:lnSpc>
-              <a:spcBef>
-                <a:spcPts val="0"/>
-              </a:spcBef>
-              <a:spcAft>
-                <a:spcPts val="0"/>
-              </a:spcAft>
-              <a:buNone/>
-            </a:pPr>
-            <a:r>
-              <a:rPr b="1" lang="en-US" sz="1700">
+              <a:spcAft>
+                <a:spcPts val="100"/>
+              </a:spcAft>
+            </a:pPr>
+            <a:r>
+              <a:rPr sz="1500" b="1">
                 <a:solidFill>
                   <a:srgbClr val="191C1E"/>
                 </a:solidFill>
                 <a:latin typeface="Plus Jakarta Sans"/>
-                <a:ea typeface="Plus Jakarta Sans"/>
-                <a:cs typeface="Plus Jakarta Sans"/>
-                <a:sym typeface="Plus Jakarta Sans"/>
               </a:rPr>
               <a:t>Fonte única de verdade</a:t>
             </a:r>
-            <a:endParaRPr/>
-          </a:p>
-          <a:p>
-            <a:pPr indent="0" lvl="0" marL="0" marR="0" rtl="0" algn="l">
+          </a:p>
+          <a:p>
+            <a:pPr algn="l">
               <a:lnSpc>
-                <a:spcPct val="110000"/>
+                <a:spcPct val="100000"/>
               </a:lnSpc>
-              <a:spcBef>
-                <a:spcPts val="0"/>
-              </a:spcBef>
-              <a:spcAft>
-                <a:spcPts val="0"/>
-              </a:spcAft>
-              <a:buNone/>
-            </a:pPr>
-            <a:r>
-              <a:rPr b="0" lang="en-US" sz="1200">
+              <a:spcAft>
+                <a:spcPts val="100"/>
+              </a:spcAft>
+            </a:pPr>
+            <a:r>
+              <a:rPr sz="1000" b="0">
                 <a:solidFill>
                   <a:srgbClr val="545F73"/>
                 </a:solidFill>
                 <a:latin typeface="Plus Jakarta Sans"/>
-                <a:ea typeface="Plus Jakarta Sans"/>
-                <a:cs typeface="Plus Jakarta Sans"/>
-                <a:sym typeface="Plus Jakarta Sans"/>
               </a:rPr>
               <a:t>Loshin, 2010</a:t>
             </a:r>
-            <a:endParaRPr/>
-          </a:p>
-        </p:txBody>
-      </p:sp>
-      <p:sp>
-        <p:nvSpPr>
-          <p:cNvPr id="226" name="Google Shape;226;p7"/>
+          </a:p>
+        </p:txBody>
+      </p:sp>
+      <p:sp>
+        <p:nvSpPr>
+          <p:cNvPr id="232" name="TextBox 231"/>
           <p:cNvSpPr txBox="1"/>
           <p:nvPr/>
         </p:nvSpPr>
         <p:spPr>
           <a:xfrm>
-            <a:off x="5989320" y="3483864"/>
-            <a:ext cx="457200" cy="713232"/>
+            <a:off x="4297680" y="3584448"/>
+            <a:ext cx="4160520" cy="749808"/>
           </a:xfrm>
           <a:prstGeom prst="rect">
             <a:avLst/>
           </a:prstGeom>
           <a:noFill/>
-          <a:ln>
-            <a:noFill/>
-          </a:ln>
-        </p:spPr>
-        <p:txBody>
-          <a:bodyPr anchorCtr="0" anchor="ctr" bIns="0" lIns="0" spcFirstLastPara="1" rIns="0" wrap="square" tIns="0">
+        </p:spPr>
+        <p:txBody>
+          <a:bodyPr wrap="square" lIns="0" rIns="0" tIns="0" bIns="0" anchor="ctr">
             <a:spAutoFit/>
           </a:bodyPr>
           <a:lstStyle/>
           <a:p>
-            <a:pPr indent="0" lvl="0" marL="0" marR="0" rtl="0" algn="l">
+            <a:pPr algn="l">
               <a:lnSpc>
-                <a:spcPct val="110000"/>
+                <a:spcPct val="105000"/>
               </a:lnSpc>
-              <a:spcBef>
-                <a:spcPts val="0"/>
-              </a:spcBef>
-              <a:spcAft>
-                <a:spcPts val="0"/>
-              </a:spcAft>
-              <a:buNone/>
-            </a:pPr>
-            <a:r>
-              <a:rPr b="1" lang="en-US" sz="2000">
-                <a:solidFill>
-                  <a:srgbClr val="0B5FD9"/>
+              <a:spcAft>
+                <a:spcPts val="600"/>
+              </a:spcAft>
+            </a:pPr>
+            <a:r>
+              <a:rPr sz="1300" b="0">
+                <a:solidFill>
+                  <a:srgbClr val="191C1E"/>
                 </a:solidFill>
                 <a:latin typeface="Plus Jakarta Sans"/>
-                <a:ea typeface="Plus Jakarta Sans"/>
-                <a:cs typeface="Plus Jakarta Sans"/>
-                <a:sym typeface="Plus Jakarta Sans"/>
               </a:rPr>
-              <a:t>→</a:t>
-            </a:r>
-            <a:endParaRPr/>
-          </a:p>
-        </p:txBody>
-      </p:sp>
-      <p:sp>
-        <p:nvSpPr>
-          <p:cNvPr id="227" name="Google Shape;227;p7"/>
+              <a:t>um só lugar com a versão certa da informação, sem cópias desencontradas</a:t>
+            </a:r>
+          </a:p>
+        </p:txBody>
+      </p:sp>
+      <p:sp>
+        <p:nvSpPr>
+          <p:cNvPr id="233" name="TextBox 232"/>
           <p:cNvSpPr txBox="1"/>
           <p:nvPr/>
         </p:nvSpPr>
         <p:spPr>
           <a:xfrm>
-            <a:off x="6537960" y="3483864"/>
-            <a:ext cx="4754880" cy="713232"/>
+            <a:off x="8778240" y="3584448"/>
+            <a:ext cx="2423160" cy="749808"/>
           </a:xfrm>
           <a:prstGeom prst="rect">
             <a:avLst/>
           </a:prstGeom>
           <a:noFill/>
-          <a:ln>
-            <a:noFill/>
-          </a:ln>
-        </p:spPr>
-        <p:txBody>
-          <a:bodyPr anchorCtr="0" anchor="ctr" bIns="0" lIns="0" spcFirstLastPara="1" rIns="0" wrap="square" tIns="0">
+        </p:spPr>
+        <p:txBody>
+          <a:bodyPr wrap="square" lIns="0" rIns="0" tIns="0" bIns="0" anchor="ctr">
             <a:spAutoFit/>
           </a:bodyPr>
           <a:lstStyle/>
           <a:p>
-            <a:pPr indent="0" lvl="0" marL="0" marR="0" rtl="0" algn="l">
+            <a:pPr algn="l">
               <a:lnSpc>
-                <a:spcPct val="110000"/>
+                <a:spcPct val="105000"/>
               </a:lnSpc>
-              <a:spcBef>
-                <a:spcPts val="0"/>
-              </a:spcBef>
-              <a:spcAft>
-                <a:spcPts val="0"/>
-              </a:spcAft>
-              <a:buNone/>
-            </a:pPr>
-            <a:r>
-              <a:rPr b="0" lang="en-US" sz="1700">
-                <a:solidFill>
-                  <a:srgbClr val="191C1E"/>
+              <a:spcAft>
+                <a:spcPts val="600"/>
+              </a:spcAft>
+            </a:pPr>
+            <a:r>
+              <a:rPr sz="1300" b="1">
+                <a:solidFill>
+                  <a:srgbClr val="0A3F8F"/>
                 </a:solidFill>
                 <a:latin typeface="Plus Jakarta Sans"/>
-                <a:ea typeface="Plus Jakarta Sans"/>
-                <a:cs typeface="Plus Jakarta Sans"/>
-                <a:sym typeface="Plus Jakarta Sans"/>
               </a:rPr>
-              <a:t>Remédios, estoque e consultas num lugar só</a:t>
-            </a:r>
-            <a:endParaRPr/>
-          </a:p>
-        </p:txBody>
-      </p:sp>
-      <p:sp>
-        <p:nvSpPr>
-          <p:cNvPr id="228" name="Google Shape;228;p7"/>
+              <a:t>remédios, estoque e consultas juntos</a:t>
+            </a:r>
+          </a:p>
+        </p:txBody>
+      </p:sp>
+      <p:sp>
+        <p:nvSpPr>
+          <p:cNvPr id="234" name="Rounded Rectangle 233"/>
           <p:cNvSpPr/>
           <p:nvPr/>
         </p:nvSpPr>
         <p:spPr>
           <a:xfrm>
-            <a:off x="685800" y="4334256"/>
-            <a:ext cx="10820095" cy="713232"/>
+            <a:off x="685800" y="4425696"/>
+            <a:ext cx="10820095" cy="749808"/>
           </a:xfrm>
           <a:prstGeom prst="roundRect">
             <a:avLst>
-              <a:gd fmla="val 17948" name="adj"/>
+              <a:gd name="adj" fmla="val 17073"/>
             </a:avLst>
           </a:prstGeom>
           <a:solidFill>
@@ -27802,237 +27816,207 @@
           <a:ln>
             <a:noFill/>
           </a:ln>
-        </p:spPr>
-        <p:txBody>
-          <a:bodyPr anchorCtr="0" anchor="ctr" bIns="45700" lIns="91425" spcFirstLastPara="1" rIns="91425" wrap="square" tIns="45700">
-            <a:noAutofit/>
-          </a:bodyPr>
+          <a:effectLst/>
+        </p:spPr>
+        <p:txBody>
+          <a:bodyPr rtlCol="0" anchor="ctr"/>
           <a:lstStyle/>
           <a:p>
-            <a:pPr indent="0" lvl="0" marL="0" marR="0" rtl="0" algn="l">
-              <a:spcBef>
-                <a:spcPts val="0"/>
-              </a:spcBef>
-              <a:spcAft>
-                <a:spcPts val="0"/>
-              </a:spcAft>
-              <a:buNone/>
-            </a:pPr>
-            <a:r>
-              <a:t/>
-            </a:r>
-            <a:endParaRPr sz="1800">
-              <a:solidFill>
-                <a:schemeClr val="dk1"/>
-              </a:solidFill>
-              <a:latin typeface="Calibri"/>
-              <a:ea typeface="Calibri"/>
-              <a:cs typeface="Calibri"/>
-              <a:sym typeface="Calibri"/>
-            </a:endParaRPr>
-          </a:p>
-        </p:txBody>
-      </p:sp>
-      <p:sp>
-        <p:nvSpPr>
-          <p:cNvPr id="229" name="Google Shape;229;p7"/>
+            <a:pPr algn="ctr"/>
+          </a:p>
+        </p:txBody>
+      </p:sp>
+      <p:sp>
+        <p:nvSpPr>
+          <p:cNvPr id="235" name="Rounded Rectangle 234"/>
+          <p:cNvSpPr/>
+          <p:nvPr/>
+        </p:nvSpPr>
+        <p:spPr>
+          <a:xfrm>
+            <a:off x="8549640" y="4425696"/>
+            <a:ext cx="2956255" cy="749808"/>
+          </a:xfrm>
+          <a:prstGeom prst="roundRect">
+            <a:avLst>
+              <a:gd name="adj" fmla="val 17073"/>
+            </a:avLst>
+          </a:prstGeom>
+          <a:solidFill>
+            <a:srgbClr val="EAF1FE"/>
+          </a:solidFill>
+          <a:ln>
+            <a:noFill/>
+          </a:ln>
+          <a:effectLst/>
+        </p:spPr>
+        <p:txBody>
+          <a:bodyPr rtlCol="0" anchor="ctr"/>
+          <a:lstStyle/>
+          <a:p>
+            <a:pPr algn="ctr"/>
+          </a:p>
+        </p:txBody>
+      </p:sp>
+      <p:sp>
+        <p:nvSpPr>
+          <p:cNvPr id="236" name="TextBox 235"/>
           <p:cNvSpPr txBox="1"/>
           <p:nvPr/>
         </p:nvSpPr>
         <p:spPr>
           <a:xfrm>
-            <a:off x="1005840" y="4334256"/>
-            <a:ext cx="5120640" cy="713232"/>
+            <a:off x="1005840" y="4425696"/>
+            <a:ext cx="3017520" cy="749808"/>
           </a:xfrm>
           <a:prstGeom prst="rect">
             <a:avLst/>
           </a:prstGeom>
           <a:noFill/>
-          <a:ln>
-            <a:noFill/>
-          </a:ln>
-        </p:spPr>
-        <p:txBody>
-          <a:bodyPr anchorCtr="0" anchor="ctr" bIns="0" lIns="0" spcFirstLastPara="1" rIns="0" wrap="square" tIns="0">
+        </p:spPr>
+        <p:txBody>
+          <a:bodyPr wrap="square" lIns="0" rIns="0" tIns="0" bIns="0" anchor="ctr">
             <a:spAutoFit/>
           </a:bodyPr>
           <a:lstStyle/>
           <a:p>
-            <a:pPr indent="0" lvl="0" marL="0" marR="0" rtl="0" algn="l">
+            <a:pPr algn="l">
               <a:lnSpc>
-                <a:spcPct val="110000"/>
+                <a:spcPct val="100000"/>
               </a:lnSpc>
-              <a:spcBef>
-                <a:spcPts val="0"/>
-              </a:spcBef>
-              <a:spcAft>
-                <a:spcPts val="0"/>
-              </a:spcAft>
-              <a:buNone/>
-            </a:pPr>
-            <a:r>
-              <a:rPr b="1" lang="en-US" sz="1700">
+              <a:spcAft>
+                <a:spcPts val="100"/>
+              </a:spcAft>
+            </a:pPr>
+            <a:r>
+              <a:rPr sz="1500" b="1">
                 <a:solidFill>
                   <a:srgbClr val="191C1E"/>
                 </a:solidFill>
                 <a:latin typeface="Plus Jakarta Sans"/>
-                <a:ea typeface="Plus Jakarta Sans"/>
-                <a:cs typeface="Plus Jakarta Sans"/>
-                <a:sym typeface="Plus Jakarta Sans"/>
               </a:rPr>
               <a:t>Offline-first e Last-Write-Wins</a:t>
             </a:r>
-            <a:endParaRPr/>
-          </a:p>
-          <a:p>
-            <a:pPr indent="0" lvl="0" marL="0" marR="0" rtl="0" algn="l">
+          </a:p>
+          <a:p>
+            <a:pPr algn="l">
               <a:lnSpc>
-                <a:spcPct val="110000"/>
+                <a:spcPct val="100000"/>
               </a:lnSpc>
-              <a:spcBef>
-                <a:spcPts val="0"/>
-              </a:spcBef>
-              <a:spcAft>
-                <a:spcPts val="0"/>
-              </a:spcAft>
-              <a:buNone/>
-            </a:pPr>
-            <a:r>
-              <a:rPr b="0" lang="en-US" sz="1200">
+              <a:spcAft>
+                <a:spcPts val="100"/>
+              </a:spcAft>
+            </a:pPr>
+            <a:r>
+              <a:rPr sz="1000" b="0">
                 <a:solidFill>
                   <a:srgbClr val="545F73"/>
                 </a:solidFill>
                 <a:latin typeface="Plus Jakarta Sans"/>
-                <a:ea typeface="Plus Jakarta Sans"/>
-                <a:cs typeface="Plus Jakarta Sans"/>
-                <a:sym typeface="Plus Jakarta Sans"/>
               </a:rPr>
               <a:t>Allsopp, 2014; Kleppmann, 2017</a:t>
             </a:r>
-            <a:endParaRPr/>
-          </a:p>
-        </p:txBody>
-      </p:sp>
-      <p:sp>
-        <p:nvSpPr>
-          <p:cNvPr id="230" name="Google Shape;230;p7"/>
+          </a:p>
+        </p:txBody>
+      </p:sp>
+      <p:sp>
+        <p:nvSpPr>
+          <p:cNvPr id="237" name="TextBox 236"/>
           <p:cNvSpPr txBox="1"/>
           <p:nvPr/>
         </p:nvSpPr>
         <p:spPr>
           <a:xfrm>
-            <a:off x="5989320" y="4334256"/>
-            <a:ext cx="457200" cy="713232"/>
+            <a:off x="4297680" y="4425696"/>
+            <a:ext cx="4160520" cy="749808"/>
           </a:xfrm>
           <a:prstGeom prst="rect">
             <a:avLst/>
           </a:prstGeom>
           <a:noFill/>
-          <a:ln>
-            <a:noFill/>
-          </a:ln>
-        </p:spPr>
-        <p:txBody>
-          <a:bodyPr anchorCtr="0" anchor="ctr" bIns="0" lIns="0" spcFirstLastPara="1" rIns="0" wrap="square" tIns="0">
+        </p:spPr>
+        <p:txBody>
+          <a:bodyPr wrap="square" lIns="0" rIns="0" tIns="0" bIns="0" anchor="ctr">
             <a:spAutoFit/>
           </a:bodyPr>
           <a:lstStyle/>
           <a:p>
-            <a:pPr indent="0" lvl="0" marL="0" marR="0" rtl="0" algn="l">
+            <a:pPr algn="l">
               <a:lnSpc>
-                <a:spcPct val="110000"/>
+                <a:spcPct val="105000"/>
               </a:lnSpc>
-              <a:spcBef>
-                <a:spcPts val="0"/>
-              </a:spcBef>
-              <a:spcAft>
-                <a:spcPts val="0"/>
-              </a:spcAft>
-              <a:buNone/>
-            </a:pPr>
-            <a:r>
-              <a:rPr b="1" lang="en-US" sz="2000">
-                <a:solidFill>
-                  <a:srgbClr val="0B5FD9"/>
+              <a:spcAft>
+                <a:spcPts val="600"/>
+              </a:spcAft>
+            </a:pPr>
+            <a:r>
+              <a:rPr sz="1300" b="0">
+                <a:solidFill>
+                  <a:srgbClr val="191C1E"/>
                 </a:solidFill>
                 <a:latin typeface="Plus Jakarta Sans"/>
-                <a:ea typeface="Plus Jakarta Sans"/>
-                <a:cs typeface="Plus Jakarta Sans"/>
-                <a:sym typeface="Plus Jakarta Sans"/>
               </a:rPr>
-              <a:t>→</a:t>
-            </a:r>
-            <a:endParaRPr/>
-          </a:p>
-        </p:txBody>
-      </p:sp>
-      <p:sp>
-        <p:nvSpPr>
-          <p:cNvPr id="231" name="Google Shape;231;p7"/>
+              <a:t>o app funciona sem internet e, num conflito, vence a edição mais recente</a:t>
+            </a:r>
+          </a:p>
+        </p:txBody>
+      </p:sp>
+      <p:sp>
+        <p:nvSpPr>
+          <p:cNvPr id="238" name="TextBox 237"/>
           <p:cNvSpPr txBox="1"/>
           <p:nvPr/>
         </p:nvSpPr>
         <p:spPr>
           <a:xfrm>
-            <a:off x="6537960" y="4334256"/>
-            <a:ext cx="4754880" cy="713232"/>
+            <a:off x="8778240" y="4425696"/>
+            <a:ext cx="2423160" cy="749808"/>
           </a:xfrm>
           <a:prstGeom prst="rect">
             <a:avLst/>
           </a:prstGeom>
           <a:noFill/>
-          <a:ln>
-            <a:noFill/>
-          </a:ln>
-        </p:spPr>
-        <p:txBody>
-          <a:bodyPr anchorCtr="0" anchor="ctr" bIns="0" lIns="0" spcFirstLastPara="1" rIns="0" wrap="square" tIns="0">
+        </p:spPr>
+        <p:txBody>
+          <a:bodyPr wrap="square" lIns="0" rIns="0" tIns="0" bIns="0" anchor="ctr">
             <a:spAutoFit/>
           </a:bodyPr>
           <a:lstStyle/>
           <a:p>
-            <a:pPr indent="0" lvl="0" marL="0" marR="0" rtl="0" algn="l">
+            <a:pPr algn="l">
               <a:lnSpc>
-                <a:spcPct val="110000"/>
+                <a:spcPct val="105000"/>
               </a:lnSpc>
-              <a:spcBef>
-                <a:spcPts val="0"/>
-              </a:spcBef>
-              <a:spcAft>
-                <a:spcPts val="0"/>
-              </a:spcAft>
-              <a:buNone/>
-            </a:pPr>
-            <a:r>
-              <a:rPr b="0" lang="en-US" sz="1700">
-                <a:solidFill>
-                  <a:srgbClr val="191C1E"/>
+              <a:spcAft>
+                <a:spcPts val="600"/>
+              </a:spcAft>
+            </a:pPr>
+            <a:r>
+              <a:rPr sz="1300" b="1">
+                <a:solidFill>
+                  <a:srgbClr val="0A3F8F"/>
                 </a:solidFill>
                 <a:latin typeface="Plus Jakarta Sans"/>
-                <a:ea typeface="Plus Jakarta Sans"/>
-                <a:cs typeface="Plus Jakarta Sans"/>
-                <a:sym typeface="Plus Jakarta Sans"/>
               </a:rPr>
-              <a:t>Funciona sem internet e sincroniza</a:t>
-            </a:r>
-            <a:endParaRPr/>
-          </a:p>
-        </p:txBody>
-      </p:sp>
-      <p:sp>
-        <p:nvSpPr>
-          <p:cNvPr id="232" name="Google Shape;232;p7"/>
+              <a:t>grava no aparelho e sincroniza depois</a:t>
+            </a:r>
+          </a:p>
+        </p:txBody>
+      </p:sp>
+      <p:sp>
+        <p:nvSpPr>
+          <p:cNvPr id="239" name="Rounded Rectangle 238"/>
           <p:cNvSpPr/>
           <p:nvPr/>
         </p:nvSpPr>
         <p:spPr>
           <a:xfrm>
-            <a:off x="685800" y="5184648"/>
-            <a:ext cx="10820095" cy="713232"/>
+            <a:off x="685800" y="5266944"/>
+            <a:ext cx="10820095" cy="749808"/>
           </a:xfrm>
           <a:prstGeom prst="roundRect">
             <a:avLst>
-              <a:gd fmla="val 17948" name="adj"/>
+              <a:gd name="adj" fmla="val 17073"/>
             </a:avLst>
           </a:prstGeom>
           <a:solidFill>
@@ -28041,220 +28025,190 @@
           <a:ln>
             <a:noFill/>
           </a:ln>
-        </p:spPr>
-        <p:txBody>
-          <a:bodyPr anchorCtr="0" anchor="ctr" bIns="45700" lIns="91425" spcFirstLastPara="1" rIns="91425" wrap="square" tIns="45700">
-            <a:noAutofit/>
-          </a:bodyPr>
+          <a:effectLst/>
+        </p:spPr>
+        <p:txBody>
+          <a:bodyPr rtlCol="0" anchor="ctr"/>
           <a:lstStyle/>
           <a:p>
-            <a:pPr indent="0" lvl="0" marL="0" marR="0" rtl="0" algn="l">
-              <a:spcBef>
-                <a:spcPts val="0"/>
-              </a:spcBef>
-              <a:spcAft>
-                <a:spcPts val="0"/>
-              </a:spcAft>
-              <a:buNone/>
-            </a:pPr>
-            <a:r>
-              <a:t/>
-            </a:r>
-            <a:endParaRPr sz="1800">
-              <a:solidFill>
-                <a:schemeClr val="dk1"/>
-              </a:solidFill>
-              <a:latin typeface="Calibri"/>
-              <a:ea typeface="Calibri"/>
-              <a:cs typeface="Calibri"/>
-              <a:sym typeface="Calibri"/>
-            </a:endParaRPr>
-          </a:p>
-        </p:txBody>
-      </p:sp>
-      <p:sp>
-        <p:nvSpPr>
-          <p:cNvPr id="233" name="Google Shape;233;p7"/>
+            <a:pPr algn="ctr"/>
+          </a:p>
+        </p:txBody>
+      </p:sp>
+      <p:sp>
+        <p:nvSpPr>
+          <p:cNvPr id="240" name="Rounded Rectangle 239"/>
+          <p:cNvSpPr/>
+          <p:nvPr/>
+        </p:nvSpPr>
+        <p:spPr>
+          <a:xfrm>
+            <a:off x="8549640" y="5266944"/>
+            <a:ext cx="2956255" cy="749808"/>
+          </a:xfrm>
+          <a:prstGeom prst="roundRect">
+            <a:avLst>
+              <a:gd name="adj" fmla="val 17073"/>
+            </a:avLst>
+          </a:prstGeom>
+          <a:solidFill>
+            <a:srgbClr val="EAF1FE"/>
+          </a:solidFill>
+          <a:ln>
+            <a:noFill/>
+          </a:ln>
+          <a:effectLst/>
+        </p:spPr>
+        <p:txBody>
+          <a:bodyPr rtlCol="0" anchor="ctr"/>
+          <a:lstStyle/>
+          <a:p>
+            <a:pPr algn="ctr"/>
+          </a:p>
+        </p:txBody>
+      </p:sp>
+      <p:sp>
+        <p:nvSpPr>
+          <p:cNvPr id="241" name="TextBox 240"/>
           <p:cNvSpPr txBox="1"/>
           <p:nvPr/>
         </p:nvSpPr>
         <p:spPr>
           <a:xfrm>
-            <a:off x="1005840" y="5184648"/>
-            <a:ext cx="5120640" cy="713232"/>
+            <a:off x="1005840" y="5266944"/>
+            <a:ext cx="3017520" cy="749808"/>
           </a:xfrm>
           <a:prstGeom prst="rect">
             <a:avLst/>
           </a:prstGeom>
           <a:noFill/>
-          <a:ln>
-            <a:noFill/>
-          </a:ln>
-        </p:spPr>
-        <p:txBody>
-          <a:bodyPr anchorCtr="0" anchor="ctr" bIns="0" lIns="0" spcFirstLastPara="1" rIns="0" wrap="square" tIns="0">
+        </p:spPr>
+        <p:txBody>
+          <a:bodyPr wrap="square" lIns="0" rIns="0" tIns="0" bIns="0" anchor="ctr">
             <a:spAutoFit/>
           </a:bodyPr>
           <a:lstStyle/>
           <a:p>
-            <a:pPr indent="0" lvl="0" marL="0" marR="0" rtl="0" algn="l">
+            <a:pPr algn="l">
               <a:lnSpc>
-                <a:spcPct val="110000"/>
+                <a:spcPct val="100000"/>
               </a:lnSpc>
-              <a:spcBef>
-                <a:spcPts val="0"/>
-              </a:spcBef>
-              <a:spcAft>
-                <a:spcPts val="0"/>
-              </a:spcAft>
-              <a:buNone/>
-            </a:pPr>
-            <a:r>
-              <a:rPr b="1" lang="en-US" sz="1700">
+              <a:spcAft>
+                <a:spcPts val="100"/>
+              </a:spcAft>
+            </a:pPr>
+            <a:r>
+              <a:rPr sz="1500" b="1">
                 <a:solidFill>
                   <a:srgbClr val="191C1E"/>
                 </a:solidFill>
                 <a:latin typeface="Plus Jakarta Sans"/>
-                <a:ea typeface="Plus Jakarta Sans"/>
-                <a:cs typeface="Plus Jakarta Sans"/>
-                <a:sym typeface="Plus Jakarta Sans"/>
               </a:rPr>
-              <a:t>Usabilidade, acessibilidade e LGPD</a:t>
-            </a:r>
-            <a:endParaRPr/>
-          </a:p>
-          <a:p>
-            <a:pPr indent="0" lvl="0" marL="0" marR="0" rtl="0" algn="l">
+              <a:t>Nielsen, WCAG e LGPD</a:t>
+            </a:r>
+          </a:p>
+          <a:p>
+            <a:pPr algn="l">
               <a:lnSpc>
-                <a:spcPct val="110000"/>
+                <a:spcPct val="100000"/>
               </a:lnSpc>
-              <a:spcBef>
-                <a:spcPts val="0"/>
-              </a:spcBef>
-              <a:spcAft>
-                <a:spcPts val="0"/>
-              </a:spcAft>
-              <a:buNone/>
-            </a:pPr>
-            <a:r>
-              <a:rPr b="0" lang="en-US" sz="1200">
+              <a:spcAft>
+                <a:spcPts val="100"/>
+              </a:spcAft>
+            </a:pPr>
+            <a:r>
+              <a:rPr sz="1000" b="0">
                 <a:solidFill>
                   <a:srgbClr val="545F73"/>
                 </a:solidFill>
                 <a:latin typeface="Plus Jakarta Sans"/>
-                <a:ea typeface="Plus Jakarta Sans"/>
-                <a:cs typeface="Plus Jakarta Sans"/>
-                <a:sym typeface="Plus Jakarta Sans"/>
               </a:rPr>
               <a:t>Nielsen, 1994; W3C, 2018; Brasil, 2018</a:t>
             </a:r>
-            <a:endParaRPr/>
-          </a:p>
-        </p:txBody>
-      </p:sp>
-      <p:sp>
-        <p:nvSpPr>
-          <p:cNvPr id="234" name="Google Shape;234;p7"/>
+          </a:p>
+        </p:txBody>
+      </p:sp>
+      <p:sp>
+        <p:nvSpPr>
+          <p:cNvPr id="242" name="TextBox 241"/>
           <p:cNvSpPr txBox="1"/>
           <p:nvPr/>
         </p:nvSpPr>
         <p:spPr>
           <a:xfrm>
-            <a:off x="5989320" y="5184648"/>
-            <a:ext cx="457200" cy="713232"/>
+            <a:off x="4297680" y="5266944"/>
+            <a:ext cx="4160520" cy="749808"/>
           </a:xfrm>
           <a:prstGeom prst="rect">
             <a:avLst/>
           </a:prstGeom>
           <a:noFill/>
-          <a:ln>
-            <a:noFill/>
-          </a:ln>
-        </p:spPr>
-        <p:txBody>
-          <a:bodyPr anchorCtr="0" anchor="ctr" bIns="0" lIns="0" spcFirstLastPara="1" rIns="0" wrap="square" tIns="0">
+        </p:spPr>
+        <p:txBody>
+          <a:bodyPr wrap="square" lIns="0" rIns="0" tIns="0" bIns="0" anchor="ctr">
             <a:spAutoFit/>
           </a:bodyPr>
           <a:lstStyle/>
           <a:p>
-            <a:pPr indent="0" lvl="0" marL="0" marR="0" rtl="0" algn="l">
+            <a:pPr algn="l">
               <a:lnSpc>
-                <a:spcPct val="110000"/>
+                <a:spcPct val="105000"/>
               </a:lnSpc>
-              <a:spcBef>
-                <a:spcPts val="0"/>
-              </a:spcBef>
-              <a:spcAft>
-                <a:spcPts val="0"/>
-              </a:spcAft>
-              <a:buNone/>
-            </a:pPr>
-            <a:r>
-              <a:rPr b="1" lang="en-US" sz="2000">
-                <a:solidFill>
-                  <a:srgbClr val="0B5FD9"/>
+              <a:spcAft>
+                <a:spcPts val="600"/>
+              </a:spcAft>
+            </a:pPr>
+            <a:r>
+              <a:rPr sz="1300" b="0">
+                <a:solidFill>
+                  <a:srgbClr val="191C1E"/>
                 </a:solidFill>
                 <a:latin typeface="Plus Jakarta Sans"/>
-                <a:ea typeface="Plus Jakarta Sans"/>
-                <a:cs typeface="Plus Jakarta Sans"/>
-                <a:sym typeface="Plus Jakarta Sans"/>
               </a:rPr>
-              <a:t>→</a:t>
-            </a:r>
-            <a:endParaRPr/>
-          </a:p>
-        </p:txBody>
-      </p:sp>
-      <p:sp>
-        <p:nvSpPr>
-          <p:cNvPr id="235" name="Google Shape;235;p7"/>
+              <a:t>regras de usabilidade, de acessibilidade e de proteção de dados pessoais</a:t>
+            </a:r>
+          </a:p>
+        </p:txBody>
+      </p:sp>
+      <p:sp>
+        <p:nvSpPr>
+          <p:cNvPr id="243" name="TextBox 242"/>
           <p:cNvSpPr txBox="1"/>
           <p:nvPr/>
         </p:nvSpPr>
         <p:spPr>
           <a:xfrm>
-            <a:off x="6537960" y="5184648"/>
-            <a:ext cx="4754880" cy="713232"/>
+            <a:off x="8778240" y="5266944"/>
+            <a:ext cx="2423160" cy="749808"/>
           </a:xfrm>
           <a:prstGeom prst="rect">
             <a:avLst/>
           </a:prstGeom>
           <a:noFill/>
-          <a:ln>
-            <a:noFill/>
-          </a:ln>
-        </p:spPr>
-        <p:txBody>
-          <a:bodyPr anchorCtr="0" anchor="ctr" bIns="0" lIns="0" spcFirstLastPara="1" rIns="0" wrap="square" tIns="0">
+        </p:spPr>
+        <p:txBody>
+          <a:bodyPr wrap="square" lIns="0" rIns="0" tIns="0" bIns="0" anchor="ctr">
             <a:spAutoFit/>
           </a:bodyPr>
           <a:lstStyle/>
           <a:p>
-            <a:pPr indent="0" lvl="0" marL="0" marR="0" rtl="0" algn="l">
+            <a:pPr algn="l">
               <a:lnSpc>
-                <a:spcPct val="110000"/>
+                <a:spcPct val="105000"/>
               </a:lnSpc>
-              <a:spcBef>
-                <a:spcPts val="0"/>
-              </a:spcBef>
-              <a:spcAft>
-                <a:spcPts val="0"/>
-              </a:spcAft>
-              <a:buNone/>
-            </a:pPr>
-            <a:r>
-              <a:rPr b="0" lang="en-US" sz="1700">
-                <a:solidFill>
-                  <a:srgbClr val="191C1E"/>
+              <a:spcAft>
+                <a:spcPts val="600"/>
+              </a:spcAft>
+            </a:pPr>
+            <a:r>
+              <a:rPr sz="1300" b="1">
+                <a:solidFill>
+                  <a:srgbClr val="0A3F8F"/>
                 </a:solidFill>
                 <a:latin typeface="Plus Jakarta Sans"/>
-                <a:ea typeface="Plus Jakarta Sans"/>
-                <a:cs typeface="Plus Jakarta Sans"/>
-                <a:sym typeface="Plus Jakarta Sans"/>
               </a:rPr>
-              <a:t>Interface segura e dados protegidos</a:t>
-            </a:r>
-            <a:endParaRPr/>
+              <a:t>interface segura e dados protegidos</a:t>
+            </a:r>
           </a:p>
         </p:txBody>
       </p:sp>

</xml_diff>

<commit_message>
docs(tcc): justificativa destaca a adesao como desafio reconhecido pela OMS
</commit_message>
<xml_diff>
--- a/docs/tcc/apresentacao-mapill.pptx
+++ b/docs/tcc/apresentacao-mapill.pptx
@@ -3429,44 +3429,14 @@
           </a:bodyPr>
           <a:lstStyle/>
           <a:p>
-            <a:pPr indent="0" lvl="0" marL="0" rtl="0" algn="l">
-              <a:lnSpc>
-                <a:spcPct val="100000"/>
-              </a:lnSpc>
-              <a:spcBef>
-                <a:spcPts val="0"/>
-              </a:spcBef>
-              <a:spcAft>
-                <a:spcPts val="0"/>
-              </a:spcAft>
-              <a:buSzPts val="1100"/>
-              <a:buNone/>
-            </a:pPr>
-            <a:r>
-              <a:rPr lang="en-US"/>
+            <a:r>
               <a:t>[45 s]</a:t>
             </a:r>
-            <a:endParaRPr/>
-          </a:p>
-          <a:p>
-            <a:pPr indent="0" lvl="0" marL="0" rtl="0" algn="l">
-              <a:lnSpc>
-                <a:spcPct val="100000"/>
-              </a:lnSpc>
-              <a:spcBef>
-                <a:spcPts val="0"/>
-              </a:spcBef>
-              <a:spcAft>
-                <a:spcPts val="0"/>
-              </a:spcAft>
-              <a:buSzPts val="1100"/>
-              <a:buNone/>
-            </a:pPr>
-            <a:r>
-              <a:rPr lang="en-US"/>
-              <a:t>Essa frase abre o meu trabalho, e resume por que ele existe. As duas falhas que eu comentei aparecem no dia a dia de formas bem concretas. Na cognitiva, o paciente esquece a dose, ou não lembra se já tomou. O Mapill avisa no horário, mesmo com o aplicativo fechado, e guarda cada resposta com data e hora. Na logística, o remédio acaba sem aviso, ou a consulta e a receita passam do prazo. O app desconta o estoque a cada dose e avisa antes de acabar, e lembra dos compromissos e da validade da receita.</a:t>
-            </a:r>
-            <a:endParaRPr/>
+          </a:p>
+          <a:p>
+            <a:r>
+              <a:t>Essa frase abre o meu trabalho, e resume por que ele existe. E não é um problema pequeno, a Organização Mundial da Saúde reconhece a baixa adesão ao tratamento como um dos maiores desafios da saúde pública. As duas falhas que eu comentei aparecem no dia a dia de formas bem concretas. Na cognitiva, o paciente esquece a dose, ou não lembra se já tomou. O Mapill avisa no horário, mesmo com o aplicativo fechado, e guarda cada resposta com data e hora. Na logística, o remédio acaba sem aviso, ou a consulta e a receita passam do prazo. O app desconta o estoque a cada dose e avisa antes de acabar, e lembra dos compromissos e da validade da receita.</a:t>
+            </a:r>
           </a:p>
         </p:txBody>
       </p:sp>
@@ -28483,7 +28453,7 @@
         <p:spPr>
           <a:xfrm>
             <a:off x="685800" y="2377440"/>
-            <a:ext cx="5272887" cy="3429000"/>
+            <a:ext cx="5272887" cy="3017520"/>
           </a:xfrm>
           <a:prstGeom prst="roundRect">
             <a:avLst>
@@ -28905,7 +28875,7 @@
         <p:spPr>
           <a:xfrm>
             <a:off x="6233007" y="2377440"/>
-            <a:ext cx="5272887" cy="3429000"/>
+            <a:ext cx="5272887" cy="3017520"/>
           </a:xfrm>
           <a:prstGeom prst="roundRect">
             <a:avLst>
@@ -29305,6 +29275,145 @@
                 <a:sym typeface="Plus Jakarta Sans"/>
               </a:rPr>
               <a:t>compromissos e validade da receita com lembrete</a:t>
+            </a:r>
+            <a:endParaRPr b="0" i="0" spc="0" sz="1400" u="none" cap="none" strike="noStrike">
+              <a:solidFill>
+                <a:srgbClr val="000000"/>
+              </a:solidFill>
+              <a:latin typeface="Arial"/>
+              <a:ea typeface="Arial"/>
+              <a:cs typeface="Arial"/>
+              <a:sym typeface="Arial"/>
+            </a:endParaRPr>
+          </a:p>
+        </p:txBody>
+      </p:sp>
+      <p:sp>
+        <p:nvSpPr>
+          <p:cNvPr id="950" name="Mapill;950"/>
+          <p:cNvSpPr/>
+          <p:nvPr/>
+        </p:nvSpPr>
+        <p:spPr>
+          <a:xfrm>
+            <a:off x="685800" y="5577840"/>
+            <a:ext cx="10820095" cy="640080"/>
+          </a:xfrm>
+          <a:prstGeom prst="roundRect">
+            <a:avLst>
+              <a:gd name="adj" fmla="val 16470"/>
+            </a:avLst>
+          </a:prstGeom>
+          <a:solidFill>
+            <a:srgbClr val="E6EFFD"/>
+          </a:solidFill>
+          <a:ln>
+            <a:noFill/>
+          </a:ln>
+        </p:spPr>
+        <p:txBody>
+          <a:bodyPr anchorCtr="0" anchor="ctr" bIns="45700" lIns="91425" spcFirstLastPara="1" rIns="91425" wrap="square" tIns="45700">
+            <a:noAutofit/>
+          </a:bodyPr>
+          <a:lstStyle/>
+          <a:p>
+            <a:pPr indent="0" lvl="0" marL="0" marR="0" rtl="0" algn="l">
+              <a:lnSpc>
+                <a:spcPct val="100000"/>
+              </a:lnSpc>
+              <a:spcBef>
+                <a:spcPts val="0"/>
+              </a:spcBef>
+              <a:spcAft>
+                <a:spcPts val="0"/>
+              </a:spcAft>
+              <a:buClr>
+                <a:srgbClr val="000000"/>
+              </a:buClr>
+              <a:buSzPts val="1800"/>
+              <a:buFont typeface="Arial"/>
+              <a:buNone/>
+            </a:pPr>
+            <a:r>
+              <a:t/>
+            </a:r>
+            <a:endParaRPr b="0" i="0" spc="0" sz="1800" u="none" cap="none" strike="noStrike">
+              <a:solidFill>
+                <a:schemeClr val="dk1"/>
+              </a:solidFill>
+              <a:latin typeface="Calibri"/>
+              <a:ea typeface="Calibri"/>
+              <a:cs typeface="Calibri"/>
+              <a:sym typeface="Calibri"/>
+            </a:endParaRPr>
+          </a:p>
+        </p:txBody>
+      </p:sp>
+      <p:sp>
+        <p:nvSpPr>
+          <p:cNvPr id="951" name="Mapill;951"/>
+          <p:cNvSpPr txBox="1"/>
+          <p:nvPr/>
+        </p:nvSpPr>
+        <p:spPr>
+          <a:xfrm>
+            <a:off x="1051560" y="5577840"/>
+            <a:ext cx="10088700" cy="640080"/>
+          </a:xfrm>
+          <a:prstGeom prst="rect">
+            <a:avLst/>
+          </a:prstGeom>
+          <a:noFill/>
+          <a:ln>
+            <a:noFill/>
+          </a:ln>
+        </p:spPr>
+        <p:txBody>
+          <a:bodyPr anchorCtr="0" anchor="ctr" bIns="0" lIns="0" spcFirstLastPara="1" rIns="0" wrap="square" tIns="0">
+            <a:noAutofit/>
+          </a:bodyPr>
+          <a:lstStyle/>
+          <a:p>
+            <a:pPr indent="0" lvl="0" marL="0" marR="0" rtl="0" algn="l">
+              <a:lnSpc>
+                <a:spcPct val="110000"/>
+              </a:lnSpc>
+              <a:spcBef>
+                <a:spcPts val="0"/>
+              </a:spcBef>
+              <a:spcAft>
+                <a:spcPts val="0"/>
+              </a:spcAft>
+              <a:buClr>
+                <a:srgbClr val="000000"/>
+              </a:buClr>
+              <a:buSzPts val="1900"/>
+              <a:buFont typeface="Arial"/>
+              <a:buNone/>
+            </a:pPr>
+            <a:r>
+              <a:rPr b="1" i="0" lang="en-US" spc="0" sz="1900" u="none" cap="none" strike="noStrike">
+                <a:solidFill>
+                  <a:srgbClr val="0B5FD9"/>
+                </a:solidFill>
+                <a:latin typeface="Plus Jakarta Sans"/>
+                <a:ea typeface="Plus Jakarta Sans"/>
+                <a:cs typeface="Plus Jakarta Sans"/>
+                <a:sym typeface="Plus Jakarta Sans"/>
+              </a:rPr>
+              <a:t>Um dos maiores desafios da saúde pública</a:t>
+            </a:r>
+            <a:r>
+              <a:rPr b="0" i="0" lang="en-US" spc="0" sz="1700" u="none" cap="none" strike="noStrike">
+                <a:solidFill>
+                  <a:srgbClr val="545F73"/>
+                </a:solidFill>
+                <a:latin typeface="Plus Jakarta Sans"/>
+                <a:ea typeface="Plus Jakarta Sans"/>
+                <a:cs typeface="Plus Jakarta Sans"/>
+                <a:sym typeface="Plus Jakarta Sans"/>
+              </a:rPr>
+              <a:t>   ·   reconhecido pela OMS (WHO, 2003)</a:t>
             </a:r>
             <a:endParaRPr b="0" i="0" spc="0" sz="1400" u="none" cap="none" strike="noStrike">
               <a:solidFill>

</xml_diff>

<commit_message>
docs(tcc): resultados separados em offline-first e alarme, Martin citado na arquitetura
</commit_message>
<xml_diff>
--- a/docs/tcc/apresentacao-mapill.pptx
+++ b/docs/tcc/apresentacao-mapill.pptx
@@ -21,6 +21,7 @@
     <p:sldId id="266" r:id="rId16"/>
     <p:sldId id="267" r:id="rId17"/>
     <p:sldId id="268" r:id="rId18"/>
+    <p:sldId id="273" r:id="rId28"/>
     <p:sldId id="269" r:id="rId19"/>
     <p:sldId id="270" r:id="rId20"/>
     <p:sldId id="271" r:id="rId21"/>
@@ -2172,44 +2173,14 @@
           </a:bodyPr>
           <a:lstStyle/>
           <a:p>
-            <a:pPr indent="0" lvl="0" marL="0" rtl="0" algn="l">
-              <a:lnSpc>
-                <a:spcPct val="100000"/>
-              </a:lnSpc>
-              <a:spcBef>
-                <a:spcPts val="0"/>
-              </a:spcBef>
-              <a:spcAft>
-                <a:spcPts val="0"/>
-              </a:spcAft>
-              <a:buSzPts val="1100"/>
-              <a:buNone/>
-            </a:pPr>
-            <a:r>
-              <a:rPr lang="en-US"/>
+            <a:r>
               <a:t>[1 min]</a:t>
             </a:r>
-            <a:endParaRPr/>
-          </a:p>
-          <a:p>
-            <a:pPr indent="0" lvl="0" marL="0" rtl="0" algn="l">
-              <a:lnSpc>
-                <a:spcPct val="100000"/>
-              </a:lnSpc>
-              <a:spcBef>
-                <a:spcPts val="0"/>
-              </a:spcBef>
-              <a:spcAft>
-                <a:spcPts val="0"/>
-              </a:spcAft>
-              <a:buSzPts val="1100"/>
-              <a:buNone/>
-            </a:pPr>
-            <a:r>
-              <a:rPr lang="en-US"/>
-              <a:t>A validação foi feita por mim, num aparelho físico, seguindo um roteiro escrito em que cada passo tinha o resultado esperado. O segundo aparelho foi simulado direto na base remota. Os cinco cenários da arquitetura offline-first foram aprovados, três deles depois de ajustes que os próprios testes revelaram, como fazer a edição mais recente prevalecer também no servidor. O alarme funcionou nas quatro combinações de celular bloqueado ou em uso, com o app nos recentes ou fora deles. A limitação apareceu depois de reiniciar o celular. O alarme só tocou quando o aparelho foi desbloqueado, por uma restrição de inicialização automática que o fabricante aplica, e que o Android não deixa contornar. O app passou a orientar o paciente a liberar essa permissão.</a:t>
-            </a:r>
-            <a:endParaRPr/>
+          </a:p>
+          <a:p>
+            <a:r>
+              <a:t>A validação foi feita por mim, num aparelho físico, seguindo um roteiro escrito em que cada passo tinha o resultado esperado. O segundo aparelho foi simulado direto na base remota. Os cinco cenários da arquitetura offline-first foram aprovados, e três deles só depois de ajustes que os próprios testes revelaram. Na restauração, o app pedia de novo os termos e a ficha de saúde, porque olhava o banco local antes de receber os dados da nuvem. Doses futuras excluídas voltavam a aparecer, e a exclusão passou a ser lógica. Entre dois aparelhos, vencia a versão sincronizada por último, e não a mais recente, então o servidor passou a aplicar o mesmo critério. E as edições feitas sem conexão não chegavam ao outro aparelho, o que foi resolvido olhando o momento em que o dado chega à nuvem.</a:t>
+            </a:r>
           </a:p>
         </p:txBody>
       </p:sp>
@@ -3007,6 +2978,69 @@
               <a:cs typeface="Arial"/>
               <a:sym typeface="Arial"/>
             </a:endParaRPr>
+          </a:p>
+        </p:txBody>
+      </p:sp>
+    </p:spTree>
+  </p:cSld>
+  <p:clrMapOvr>
+    <a:masterClrMapping/>
+  </p:clrMapOvr>
+</p:notes>
+</file>
+
+<file path=ppt/notesSlides/notesSlide18.xml><?xml version="1.0" encoding="utf-8"?>
+<p:notes xmlns:a="http://schemas.openxmlformats.org/drawingml/2006/main" xmlns:p="http://schemas.openxmlformats.org/presentationml/2006/main" xmlns:r="http://schemas.openxmlformats.org/officeDocument/2006/relationships">
+  <p:cSld>
+    <p:spTree>
+      <p:nvGrpSpPr>
+        <p:cNvPr id="1" name=""/>
+        <p:cNvGrpSpPr/>
+        <p:nvPr/>
+      </p:nvGrpSpPr>
+      <p:grpSpPr>
+        <a:xfrm>
+          <a:off x="0" y="0"/>
+          <a:ext cx="0" cy="0"/>
+          <a:chOff x="0" y="0"/>
+          <a:chExt cx="0" cy="0"/>
+        </a:xfrm>
+      </p:grpSpPr>
+      <p:sp>
+        <p:nvSpPr>
+          <p:cNvPr id="2" name="Slide Image Placeholder 1"/>
+          <p:cNvSpPr>
+            <a:spLocks noGrp="1"/>
+          </p:cNvSpPr>
+          <p:nvPr>
+            <p:ph type="sldImg" idx="2"/>
+          </p:nvPr>
+        </p:nvSpPr>
+        <p:spPr/>
+      </p:sp>
+      <p:sp>
+        <p:nvSpPr>
+          <p:cNvPr id="3" name="Notes Placeholder 2"/>
+          <p:cNvSpPr>
+            <a:spLocks noGrp="1"/>
+          </p:cNvSpPr>
+          <p:nvPr>
+            <p:ph type="body" idx="1"/>
+          </p:nvPr>
+        </p:nvSpPr>
+        <p:spPr/>
+        <p:txBody>
+          <a:bodyPr/>
+          <a:lstStyle/>
+          <a:p>
+            <a:r>
+              <a:t>[1 min]</a:t>
+            </a:r>
+          </a:p>
+          <a:p>
+            <a:r>
+              <a:t>O alarme, que é o centro do app, foi testado nas quatro combinações de celular bloqueado ou em uso, com o app nos recentes ou fora deles. Com o celular bloqueado, a tela do alarme apareceu por cima da tela de bloqueio. Com o celular em uso, apareceu a notificação com os botões de tomar e pular. Nos testes, percebi que a tela do alarme herdava a permissão de aparecer sobre o bloqueio que era do app inteiro, então isolei essa tela, e ao fechar o alarme o celular volta a ficar bloqueado, sem expor os outros dados. A ressalva veio depois de reiniciar o celular. O alarme só tocou quando o aparelho foi desbloqueado, por uma restrição de inicialização automática que o fabricante aplica e que o Android não deixa contornar. O app passou a orientar o paciente a liberar essa permissão.</a:t>
+            </a:r>
           </a:p>
         </p:txBody>
       </p:sp>
@@ -21572,7 +21606,7 @@
         <p:spPr>
           <a:xfrm>
             <a:off x="7680960" y="1783080"/>
-            <a:ext cx="3822191" cy="1920240"/>
+            <a:ext cx="3822191" cy="4160400"/>
           </a:xfrm>
           <a:prstGeom prst="roundRect">
             <a:avLst>
@@ -21632,8 +21666,8 @@
         </p:nvSpPr>
         <p:spPr>
           <a:xfrm>
-            <a:off x="7946100" y="2163580"/>
-            <a:ext cx="3291900" cy="1262100"/>
+            <a:off x="7946100" y="1965960"/>
+            <a:ext cx="3291900" cy="3794760"/>
           </a:xfrm>
           <a:prstGeom prst="rect">
             <a:avLst/>
@@ -21676,7 +21710,7 @@
                 <a:cs typeface="Plus Jakarta Sans"/>
                 <a:sym typeface="Plus Jakarta Sans"/>
               </a:rPr>
-              <a:t>ALARME</a:t>
+              <a:t>O QUE OS TESTES CORRIGIRAM</a:t>
             </a:r>
             <a:endParaRPr b="1" i="0" spc="200" sz="1100" u="none" cap="none" strike="noStrike">
               <a:solidFill>
@@ -21707,6 +21741,15 @@
               <a:buNone/>
             </a:pPr>
             <a:r>
+              <a:rPr b="1" i="0" lang="en-US" spc="200" sz="800" u="none" cap="none" strike="noStrike">
+                <a:solidFill>
+                  <a:srgbClr val="11803E"/>
+                </a:solidFill>
+                <a:latin typeface="Plus Jakarta Sans"/>
+                <a:ea typeface="Plus Jakarta Sans"/>
+                <a:cs typeface="Plus Jakarta Sans"/>
+                <a:sym typeface="Plus Jakarta Sans"/>
+              </a:rPr>
               <a:t/>
             </a:r>
             <a:endParaRPr b="1" i="0" spc="200" sz="1100" u="none" cap="none" strike="noStrike">
@@ -21725,20 +21768,20 @@
                 <a:spcPct val="110000"/>
               </a:lnSpc>
               <a:spcBef>
-                <a:spcPts val="400"/>
-              </a:spcBef>
-              <a:spcAft>
-                <a:spcPts val="0"/>
-              </a:spcAft>
-              <a:buClr>
-                <a:srgbClr val="000000"/>
-              </a:buClr>
-              <a:buSzPts val="1800"/>
-              <a:buFont typeface="Arial"/>
-              <a:buNone/>
-            </a:pPr>
-            <a:r>
-              <a:rPr b="1" i="0" lang="en-US" spc="0" sz="1800" u="none" cap="none" strike="noStrike">
+                <a:spcPts val="0"/>
+              </a:spcBef>
+              <a:spcAft>
+                <a:spcPts val="0"/>
+              </a:spcAft>
+              <a:buClr>
+                <a:srgbClr val="000000"/>
+              </a:buClr>
+              <a:buSzPts val="1100"/>
+              <a:buFont typeface="Arial"/>
+              <a:buNone/>
+            </a:pPr>
+            <a:r>
+              <a:rPr b="1" i="0" lang="en-US" spc="0" sz="1400" u="none" cap="none" strike="noStrike">
                 <a:solidFill>
                   <a:srgbClr val="191C1E"/>
                 </a:solidFill>
@@ -21747,7 +21790,595 @@
                 <a:cs typeface="Plus Jakarta Sans"/>
                 <a:sym typeface="Plus Jakarta Sans"/>
               </a:rPr>
-              <a:t>Aprovado nas 4 combinações</a:t>
+              <a:t>Restauração pedia os termos de novo</a:t>
+            </a:r>
+            <a:endParaRPr b="1" i="0" spc="200" sz="1100" u="none" cap="none" strike="noStrike">
+              <a:solidFill>
+                <a:srgbClr val="11803E"/>
+              </a:solidFill>
+              <a:latin typeface="Plus Jakarta Sans"/>
+              <a:ea typeface="Plus Jakarta Sans"/>
+              <a:cs typeface="Plus Jakarta Sans"/>
+              <a:sym typeface="Plus Jakarta Sans"/>
+            </a:endParaRPr>
+          </a:p>
+          <a:p>
+            <a:pPr indent="0" lvl="0" marL="0" marR="0" rtl="0" algn="l">
+              <a:lnSpc>
+                <a:spcPct val="110000"/>
+              </a:lnSpc>
+              <a:spcBef>
+                <a:spcPts val="0"/>
+              </a:spcBef>
+              <a:spcAft>
+                <a:spcPts val="0"/>
+              </a:spcAft>
+              <a:buClr>
+                <a:srgbClr val="000000"/>
+              </a:buClr>
+              <a:buSzPts val="1100"/>
+              <a:buFont typeface="Arial"/>
+              <a:buNone/>
+            </a:pPr>
+            <a:r>
+              <a:rPr b="0" i="0" lang="en-US" spc="0" sz="1300" u="none" cap="none" strike="noStrike">
+                <a:solidFill>
+                  <a:srgbClr val="545F73"/>
+                </a:solidFill>
+                <a:latin typeface="Plus Jakarta Sans"/>
+                <a:ea typeface="Plus Jakarta Sans"/>
+                <a:cs typeface="Plus Jakarta Sans"/>
+                <a:sym typeface="Plus Jakarta Sans"/>
+              </a:rPr>
+              <a:t>agora espera os dados da nuvem</a:t>
+            </a:r>
+            <a:endParaRPr b="1" i="0" spc="200" sz="1100" u="none" cap="none" strike="noStrike">
+              <a:solidFill>
+                <a:srgbClr val="11803E"/>
+              </a:solidFill>
+              <a:latin typeface="Plus Jakarta Sans"/>
+              <a:ea typeface="Plus Jakarta Sans"/>
+              <a:cs typeface="Plus Jakarta Sans"/>
+              <a:sym typeface="Plus Jakarta Sans"/>
+            </a:endParaRPr>
+          </a:p>
+          <a:p>
+            <a:pPr indent="0" lvl="0" marL="0" marR="0" rtl="0" algn="l">
+              <a:lnSpc>
+                <a:spcPct val="110000"/>
+              </a:lnSpc>
+              <a:spcBef>
+                <a:spcPts val="0"/>
+              </a:spcBef>
+              <a:spcAft>
+                <a:spcPts val="0"/>
+              </a:spcAft>
+              <a:buClr>
+                <a:srgbClr val="000000"/>
+              </a:buClr>
+              <a:buSzPts val="1100"/>
+              <a:buFont typeface="Arial"/>
+              <a:buNone/>
+            </a:pPr>
+            <a:r>
+              <a:rPr b="1" i="0" lang="en-US" spc="200" sz="800" u="none" cap="none" strike="noStrike">
+                <a:solidFill>
+                  <a:srgbClr val="11803E"/>
+                </a:solidFill>
+                <a:latin typeface="Plus Jakarta Sans"/>
+                <a:ea typeface="Plus Jakarta Sans"/>
+                <a:cs typeface="Plus Jakarta Sans"/>
+                <a:sym typeface="Plus Jakarta Sans"/>
+              </a:rPr>
+              <a:t/>
+            </a:r>
+            <a:endParaRPr b="1" i="0" spc="200" sz="1100" u="none" cap="none" strike="noStrike">
+              <a:solidFill>
+                <a:srgbClr val="11803E"/>
+              </a:solidFill>
+              <a:latin typeface="Plus Jakarta Sans"/>
+              <a:ea typeface="Plus Jakarta Sans"/>
+              <a:cs typeface="Plus Jakarta Sans"/>
+              <a:sym typeface="Plus Jakarta Sans"/>
+            </a:endParaRPr>
+          </a:p>
+          <a:p>
+            <a:pPr indent="0" lvl="0" marL="0" marR="0" rtl="0" algn="l">
+              <a:lnSpc>
+                <a:spcPct val="110000"/>
+              </a:lnSpc>
+              <a:spcBef>
+                <a:spcPts val="0"/>
+              </a:spcBef>
+              <a:spcAft>
+                <a:spcPts val="0"/>
+              </a:spcAft>
+              <a:buClr>
+                <a:srgbClr val="000000"/>
+              </a:buClr>
+              <a:buSzPts val="1100"/>
+              <a:buFont typeface="Arial"/>
+              <a:buNone/>
+            </a:pPr>
+            <a:r>
+              <a:rPr b="1" i="0" lang="en-US" spc="0" sz="1400" u="none" cap="none" strike="noStrike">
+                <a:solidFill>
+                  <a:srgbClr val="191C1E"/>
+                </a:solidFill>
+                <a:latin typeface="Plus Jakarta Sans"/>
+                <a:ea typeface="Plus Jakarta Sans"/>
+                <a:cs typeface="Plus Jakarta Sans"/>
+                <a:sym typeface="Plus Jakarta Sans"/>
+              </a:rPr>
+              <a:t>Doses excluídas reapareciam</a:t>
+            </a:r>
+            <a:endParaRPr b="1" i="0" spc="200" sz="1100" u="none" cap="none" strike="noStrike">
+              <a:solidFill>
+                <a:srgbClr val="11803E"/>
+              </a:solidFill>
+              <a:latin typeface="Plus Jakarta Sans"/>
+              <a:ea typeface="Plus Jakarta Sans"/>
+              <a:cs typeface="Plus Jakarta Sans"/>
+              <a:sym typeface="Plus Jakarta Sans"/>
+            </a:endParaRPr>
+          </a:p>
+          <a:p>
+            <a:pPr indent="0" lvl="0" marL="0" marR="0" rtl="0" algn="l">
+              <a:lnSpc>
+                <a:spcPct val="110000"/>
+              </a:lnSpc>
+              <a:spcBef>
+                <a:spcPts val="0"/>
+              </a:spcBef>
+              <a:spcAft>
+                <a:spcPts val="0"/>
+              </a:spcAft>
+              <a:buClr>
+                <a:srgbClr val="000000"/>
+              </a:buClr>
+              <a:buSzPts val="1100"/>
+              <a:buFont typeface="Arial"/>
+              <a:buNone/>
+            </a:pPr>
+            <a:r>
+              <a:rPr b="0" i="0" lang="en-US" spc="0" sz="1300" u="none" cap="none" strike="noStrike">
+                <a:solidFill>
+                  <a:srgbClr val="545F73"/>
+                </a:solidFill>
+                <a:latin typeface="Plus Jakarta Sans"/>
+                <a:ea typeface="Plus Jakarta Sans"/>
+                <a:cs typeface="Plus Jakarta Sans"/>
+                <a:sym typeface="Plus Jakarta Sans"/>
+              </a:rPr>
+              <a:t>a exclusão passou a ser lógica</a:t>
+            </a:r>
+            <a:endParaRPr b="1" i="0" spc="200" sz="1100" u="none" cap="none" strike="noStrike">
+              <a:solidFill>
+                <a:srgbClr val="11803E"/>
+              </a:solidFill>
+              <a:latin typeface="Plus Jakarta Sans"/>
+              <a:ea typeface="Plus Jakarta Sans"/>
+              <a:cs typeface="Plus Jakarta Sans"/>
+              <a:sym typeface="Plus Jakarta Sans"/>
+            </a:endParaRPr>
+          </a:p>
+          <a:p>
+            <a:pPr indent="0" lvl="0" marL="0" marR="0" rtl="0" algn="l">
+              <a:lnSpc>
+                <a:spcPct val="110000"/>
+              </a:lnSpc>
+              <a:spcBef>
+                <a:spcPts val="0"/>
+              </a:spcBef>
+              <a:spcAft>
+                <a:spcPts val="0"/>
+              </a:spcAft>
+              <a:buClr>
+                <a:srgbClr val="000000"/>
+              </a:buClr>
+              <a:buSzPts val="1100"/>
+              <a:buFont typeface="Arial"/>
+              <a:buNone/>
+            </a:pPr>
+            <a:r>
+              <a:rPr b="1" i="0" lang="en-US" spc="200" sz="800" u="none" cap="none" strike="noStrike">
+                <a:solidFill>
+                  <a:srgbClr val="11803E"/>
+                </a:solidFill>
+                <a:latin typeface="Plus Jakarta Sans"/>
+                <a:ea typeface="Plus Jakarta Sans"/>
+                <a:cs typeface="Plus Jakarta Sans"/>
+                <a:sym typeface="Plus Jakarta Sans"/>
+              </a:rPr>
+              <a:t/>
+            </a:r>
+            <a:endParaRPr b="1" i="0" spc="200" sz="1100" u="none" cap="none" strike="noStrike">
+              <a:solidFill>
+                <a:srgbClr val="11803E"/>
+              </a:solidFill>
+              <a:latin typeface="Plus Jakarta Sans"/>
+              <a:ea typeface="Plus Jakarta Sans"/>
+              <a:cs typeface="Plus Jakarta Sans"/>
+              <a:sym typeface="Plus Jakarta Sans"/>
+            </a:endParaRPr>
+          </a:p>
+          <a:p>
+            <a:pPr indent="0" lvl="0" marL="0" marR="0" rtl="0" algn="l">
+              <a:lnSpc>
+                <a:spcPct val="110000"/>
+              </a:lnSpc>
+              <a:spcBef>
+                <a:spcPts val="0"/>
+              </a:spcBef>
+              <a:spcAft>
+                <a:spcPts val="0"/>
+              </a:spcAft>
+              <a:buClr>
+                <a:srgbClr val="000000"/>
+              </a:buClr>
+              <a:buSzPts val="1100"/>
+              <a:buFont typeface="Arial"/>
+              <a:buNone/>
+            </a:pPr>
+            <a:r>
+              <a:rPr b="1" i="0" lang="en-US" spc="0" sz="1400" u="none" cap="none" strike="noStrike">
+                <a:solidFill>
+                  <a:srgbClr val="191C1E"/>
+                </a:solidFill>
+                <a:latin typeface="Plus Jakarta Sans"/>
+                <a:ea typeface="Plus Jakarta Sans"/>
+                <a:cs typeface="Plus Jakarta Sans"/>
+                <a:sym typeface="Plus Jakarta Sans"/>
+              </a:rPr>
+              <a:t>Vencia a última sincronizada</a:t>
+            </a:r>
+            <a:endParaRPr b="1" i="0" spc="200" sz="1100" u="none" cap="none" strike="noStrike">
+              <a:solidFill>
+                <a:srgbClr val="11803E"/>
+              </a:solidFill>
+              <a:latin typeface="Plus Jakarta Sans"/>
+              <a:ea typeface="Plus Jakarta Sans"/>
+              <a:cs typeface="Plus Jakarta Sans"/>
+              <a:sym typeface="Plus Jakarta Sans"/>
+            </a:endParaRPr>
+          </a:p>
+          <a:p>
+            <a:pPr indent="0" lvl="0" marL="0" marR="0" rtl="0" algn="l">
+              <a:lnSpc>
+                <a:spcPct val="110000"/>
+              </a:lnSpc>
+              <a:spcBef>
+                <a:spcPts val="0"/>
+              </a:spcBef>
+              <a:spcAft>
+                <a:spcPts val="0"/>
+              </a:spcAft>
+              <a:buClr>
+                <a:srgbClr val="000000"/>
+              </a:buClr>
+              <a:buSzPts val="1100"/>
+              <a:buFont typeface="Arial"/>
+              <a:buNone/>
+            </a:pPr>
+            <a:r>
+              <a:rPr b="0" i="0" lang="en-US" spc="0" sz="1300" u="none" cap="none" strike="noStrike">
+                <a:solidFill>
+                  <a:srgbClr val="545F73"/>
+                </a:solidFill>
+                <a:latin typeface="Plus Jakarta Sans"/>
+                <a:ea typeface="Plus Jakarta Sans"/>
+                <a:cs typeface="Plus Jakarta Sans"/>
+                <a:sym typeface="Plus Jakarta Sans"/>
+              </a:rPr>
+              <a:t>o servidor passou a aplicar o LWW</a:t>
+            </a:r>
+            <a:endParaRPr b="1" i="0" spc="200" sz="1100" u="none" cap="none" strike="noStrike">
+              <a:solidFill>
+                <a:srgbClr val="11803E"/>
+              </a:solidFill>
+              <a:latin typeface="Plus Jakarta Sans"/>
+              <a:ea typeface="Plus Jakarta Sans"/>
+              <a:cs typeface="Plus Jakarta Sans"/>
+              <a:sym typeface="Plus Jakarta Sans"/>
+            </a:endParaRPr>
+          </a:p>
+          <a:p>
+            <a:pPr indent="0" lvl="0" marL="0" marR="0" rtl="0" algn="l">
+              <a:lnSpc>
+                <a:spcPct val="110000"/>
+              </a:lnSpc>
+              <a:spcBef>
+                <a:spcPts val="0"/>
+              </a:spcBef>
+              <a:spcAft>
+                <a:spcPts val="0"/>
+              </a:spcAft>
+              <a:buClr>
+                <a:srgbClr val="000000"/>
+              </a:buClr>
+              <a:buSzPts val="1100"/>
+              <a:buFont typeface="Arial"/>
+              <a:buNone/>
+            </a:pPr>
+            <a:r>
+              <a:rPr b="1" i="0" lang="en-US" spc="200" sz="800" u="none" cap="none" strike="noStrike">
+                <a:solidFill>
+                  <a:srgbClr val="11803E"/>
+                </a:solidFill>
+                <a:latin typeface="Plus Jakarta Sans"/>
+                <a:ea typeface="Plus Jakarta Sans"/>
+                <a:cs typeface="Plus Jakarta Sans"/>
+                <a:sym typeface="Plus Jakarta Sans"/>
+              </a:rPr>
+              <a:t/>
+            </a:r>
+            <a:endParaRPr b="1" i="0" spc="200" sz="1100" u="none" cap="none" strike="noStrike">
+              <a:solidFill>
+                <a:srgbClr val="11803E"/>
+              </a:solidFill>
+              <a:latin typeface="Plus Jakarta Sans"/>
+              <a:ea typeface="Plus Jakarta Sans"/>
+              <a:cs typeface="Plus Jakarta Sans"/>
+              <a:sym typeface="Plus Jakarta Sans"/>
+            </a:endParaRPr>
+          </a:p>
+          <a:p>
+            <a:pPr indent="0" lvl="0" marL="0" marR="0" rtl="0" algn="l">
+              <a:lnSpc>
+                <a:spcPct val="110000"/>
+              </a:lnSpc>
+              <a:spcBef>
+                <a:spcPts val="0"/>
+              </a:spcBef>
+              <a:spcAft>
+                <a:spcPts val="0"/>
+              </a:spcAft>
+              <a:buClr>
+                <a:srgbClr val="000000"/>
+              </a:buClr>
+              <a:buSzPts val="1100"/>
+              <a:buFont typeface="Arial"/>
+              <a:buNone/>
+            </a:pPr>
+            <a:r>
+              <a:rPr b="1" i="0" lang="en-US" spc="0" sz="1400" u="none" cap="none" strike="noStrike">
+                <a:solidFill>
+                  <a:srgbClr val="191C1E"/>
+                </a:solidFill>
+                <a:latin typeface="Plus Jakarta Sans"/>
+                <a:ea typeface="Plus Jakarta Sans"/>
+                <a:cs typeface="Plus Jakarta Sans"/>
+                <a:sym typeface="Plus Jakarta Sans"/>
+              </a:rPr>
+              <a:t>Edição offline não chegava ao outro aparelho</a:t>
+            </a:r>
+            <a:endParaRPr b="1" i="0" spc="200" sz="1100" u="none" cap="none" strike="noStrike">
+              <a:solidFill>
+                <a:srgbClr val="11803E"/>
+              </a:solidFill>
+              <a:latin typeface="Plus Jakarta Sans"/>
+              <a:ea typeface="Plus Jakarta Sans"/>
+              <a:cs typeface="Plus Jakarta Sans"/>
+              <a:sym typeface="Plus Jakarta Sans"/>
+            </a:endParaRPr>
+          </a:p>
+          <a:p>
+            <a:pPr indent="0" lvl="0" marL="0" marR="0" rtl="0" algn="l">
+              <a:lnSpc>
+                <a:spcPct val="110000"/>
+              </a:lnSpc>
+              <a:spcBef>
+                <a:spcPts val="0"/>
+              </a:spcBef>
+              <a:spcAft>
+                <a:spcPts val="0"/>
+              </a:spcAft>
+              <a:buClr>
+                <a:srgbClr val="000000"/>
+              </a:buClr>
+              <a:buSzPts val="1100"/>
+              <a:buFont typeface="Arial"/>
+              <a:buNone/>
+            </a:pPr>
+            <a:r>
+              <a:rPr b="0" i="0" lang="en-US" spc="0" sz="1300" u="none" cap="none" strike="noStrike">
+                <a:solidFill>
+                  <a:srgbClr val="545F73"/>
+                </a:solidFill>
+                <a:latin typeface="Plus Jakarta Sans"/>
+                <a:ea typeface="Plus Jakarta Sans"/>
+                <a:cs typeface="Plus Jakarta Sans"/>
+                <a:sym typeface="Plus Jakarta Sans"/>
+              </a:rPr>
+              <a:t>o recebimento usa a chegada à nuvem</a:t>
+            </a:r>
+            <a:endParaRPr b="1" i="0" spc="200" sz="1100" u="none" cap="none" strike="noStrike">
+              <a:solidFill>
+                <a:srgbClr val="11803E"/>
+              </a:solidFill>
+              <a:latin typeface="Plus Jakarta Sans"/>
+              <a:ea typeface="Plus Jakarta Sans"/>
+              <a:cs typeface="Plus Jakarta Sans"/>
+              <a:sym typeface="Plus Jakarta Sans"/>
+            </a:endParaRPr>
+          </a:p>
+        </p:txBody>
+      </p:sp>
+      <p:sp>
+        <p:nvSpPr>
+          <p:cNvPr id="373" name="Google Shape;373;p13"/>
+          <p:cNvSpPr/>
+          <p:nvPr/>
+        </p:nvSpPr>
+        <p:spPr>
+          <a:xfrm>
+            <a:off x="5852110" y="4333790"/>
+            <a:ext cx="1234500" cy="329100"/>
+          </a:xfrm>
+          <a:prstGeom prst="roundRect">
+            <a:avLst>
+              <a:gd fmla="val 50000" name="adj"/>
+            </a:avLst>
+          </a:prstGeom>
+          <a:solidFill>
+            <a:srgbClr val="E3F6EA"/>
+          </a:solidFill>
+          <a:ln>
+            <a:noFill/>
+          </a:ln>
+        </p:spPr>
+        <p:txBody>
+          <a:bodyPr anchorCtr="0" anchor="ctr" bIns="45700" lIns="91425" spcFirstLastPara="1" rIns="91425" wrap="square" tIns="45700">
+            <a:noAutofit/>
+          </a:bodyPr>
+          <a:lstStyle/>
+          <a:p>
+            <a:pPr indent="0" lvl="0" marL="0" marR="0" rtl="0" algn="l">
+              <a:lnSpc>
+                <a:spcPct val="100000"/>
+              </a:lnSpc>
+              <a:spcBef>
+                <a:spcPts val="0"/>
+              </a:spcBef>
+              <a:spcAft>
+                <a:spcPts val="0"/>
+              </a:spcAft>
+              <a:buClr>
+                <a:srgbClr val="000000"/>
+              </a:buClr>
+              <a:buSzPts val="1800"/>
+              <a:buFont typeface="Arial"/>
+              <a:buNone/>
+            </a:pPr>
+            <a:r>
+              <a:t/>
+            </a:r>
+            <a:endParaRPr b="0" i="0" spc="0" sz="1800" u="none" cap="none" strike="noStrike">
+              <a:solidFill>
+                <a:schemeClr val="dk1"/>
+              </a:solidFill>
+              <a:latin typeface="Calibri"/>
+              <a:ea typeface="Calibri"/>
+              <a:cs typeface="Calibri"/>
+              <a:sym typeface="Calibri"/>
+            </a:endParaRPr>
+          </a:p>
+        </p:txBody>
+      </p:sp>
+      <p:sp>
+        <p:nvSpPr>
+          <p:cNvPr id="374" name="Google Shape;374;p13"/>
+          <p:cNvSpPr/>
+          <p:nvPr/>
+        </p:nvSpPr>
+        <p:spPr>
+          <a:xfrm>
+            <a:off x="5852110" y="5119415"/>
+            <a:ext cx="1234500" cy="329100"/>
+          </a:xfrm>
+          <a:prstGeom prst="roundRect">
+            <a:avLst>
+              <a:gd fmla="val 50000" name="adj"/>
+            </a:avLst>
+          </a:prstGeom>
+          <a:solidFill>
+            <a:srgbClr val="E3F6EA"/>
+          </a:solidFill>
+          <a:ln>
+            <a:noFill/>
+          </a:ln>
+        </p:spPr>
+        <p:txBody>
+          <a:bodyPr anchorCtr="0" anchor="ctr" bIns="45700" lIns="91425" spcFirstLastPara="1" rIns="91425" wrap="square" tIns="45700">
+            <a:noAutofit/>
+          </a:bodyPr>
+          <a:lstStyle/>
+          <a:p>
+            <a:pPr indent="0" lvl="0" marL="0" marR="0" rtl="0" algn="l">
+              <a:lnSpc>
+                <a:spcPct val="100000"/>
+              </a:lnSpc>
+              <a:spcBef>
+                <a:spcPts val="0"/>
+              </a:spcBef>
+              <a:spcAft>
+                <a:spcPts val="0"/>
+              </a:spcAft>
+              <a:buClr>
+                <a:srgbClr val="000000"/>
+              </a:buClr>
+              <a:buSzPts val="1800"/>
+              <a:buFont typeface="Arial"/>
+              <a:buNone/>
+            </a:pPr>
+            <a:r>
+              <a:t/>
+            </a:r>
+            <a:endParaRPr b="0" i="0" spc="0" sz="1800" u="none" cap="none" strike="noStrike">
+              <a:solidFill>
+                <a:schemeClr val="dk1"/>
+              </a:solidFill>
+              <a:latin typeface="Calibri"/>
+              <a:ea typeface="Calibri"/>
+              <a:cs typeface="Calibri"/>
+              <a:sym typeface="Calibri"/>
+            </a:endParaRPr>
+          </a:p>
+        </p:txBody>
+      </p:sp>
+      <p:sp>
+        <p:nvSpPr>
+          <p:cNvPr id="375" name="Google Shape;375;p13"/>
+          <p:cNvSpPr txBox="1"/>
+          <p:nvPr/>
+        </p:nvSpPr>
+        <p:spPr>
+          <a:xfrm>
+            <a:off x="5852110" y="4405953"/>
+            <a:ext cx="1234500" cy="184800"/>
+          </a:xfrm>
+          <a:prstGeom prst="rect">
+            <a:avLst/>
+          </a:prstGeom>
+          <a:noFill/>
+          <a:ln>
+            <a:noFill/>
+          </a:ln>
+        </p:spPr>
+        <p:txBody>
+          <a:bodyPr anchorCtr="0" anchor="ctr" bIns="0" lIns="0" spcFirstLastPara="1" rIns="0" wrap="square" tIns="0">
+            <a:spAutoFit/>
+          </a:bodyPr>
+          <a:lstStyle/>
+          <a:p>
+            <a:pPr indent="0" lvl="0" marL="0" marR="0" rtl="0" algn="ctr">
+              <a:lnSpc>
+                <a:spcPct val="110000"/>
+              </a:lnSpc>
+              <a:spcBef>
+                <a:spcPts val="0"/>
+              </a:spcBef>
+              <a:spcAft>
+                <a:spcPts val="0"/>
+              </a:spcAft>
+              <a:buClr>
+                <a:srgbClr val="000000"/>
+              </a:buClr>
+              <a:buSzPts val="1200"/>
+              <a:buFont typeface="Arial"/>
+              <a:buNone/>
+            </a:pPr>
+            <a:r>
+              <a:rPr b="1" i="0" lang="en-US" spc="0" sz="1200" u="none" cap="none" strike="noStrike">
+                <a:solidFill>
+                  <a:srgbClr val="11803E"/>
+                </a:solidFill>
+                <a:latin typeface="Plus Jakarta Sans"/>
+                <a:ea typeface="Plus Jakarta Sans"/>
+                <a:cs typeface="Plus Jakarta Sans"/>
+                <a:sym typeface="Plus Jakarta Sans"/>
+              </a:rPr>
+              <a:t>Aprovado</a:t>
             </a:r>
             <a:endParaRPr b="0" i="0" spc="0" sz="1400" u="none" cap="none" strike="noStrike">
               <a:solidFill>
@@ -21759,39 +22390,1319 @@
               <a:sym typeface="Arial"/>
             </a:endParaRPr>
           </a:p>
+        </p:txBody>
+      </p:sp>
+      <p:sp>
+        <p:nvSpPr>
+          <p:cNvPr id="376" name="Google Shape;376;p13"/>
+          <p:cNvSpPr/>
+          <p:nvPr/>
+        </p:nvSpPr>
+        <p:spPr>
+          <a:xfrm>
+            <a:off x="5852135" y="3584253"/>
+            <a:ext cx="1234500" cy="329100"/>
+          </a:xfrm>
+          <a:prstGeom prst="roundRect">
+            <a:avLst>
+              <a:gd fmla="val 50000" name="adj"/>
+            </a:avLst>
+          </a:prstGeom>
+          <a:solidFill>
+            <a:srgbClr val="E3F6EA"/>
+          </a:solidFill>
+          <a:ln>
+            <a:noFill/>
+          </a:ln>
+        </p:spPr>
+        <p:txBody>
+          <a:bodyPr anchorCtr="0" anchor="ctr" bIns="45700" lIns="91425" spcFirstLastPara="1" rIns="91425" wrap="square" tIns="45700">
+            <a:noAutofit/>
+          </a:bodyPr>
+          <a:lstStyle/>
           <a:p>
             <a:pPr indent="0" lvl="0" marL="0" marR="0" rtl="0" algn="l">
               <a:lnSpc>
                 <a:spcPct val="100000"/>
               </a:lnSpc>
               <a:spcBef>
-                <a:spcPts val="400"/>
-              </a:spcBef>
-              <a:spcAft>
-                <a:spcPts val="0"/>
-              </a:spcAft>
-              <a:buClr>
-                <a:srgbClr val="000000"/>
-              </a:buClr>
-              <a:buSzPts val="1400"/>
-              <a:buFont typeface="Arial"/>
-              <a:buNone/>
-            </a:pPr>
-            <a:r>
-              <a:rPr b="0" i="0" lang="en-US" spc="0" sz="1400" u="none" cap="none" strike="noStrike">
-                <a:solidFill>
-                  <a:srgbClr val="545F73"/>
+                <a:spcPts val="0"/>
+              </a:spcBef>
+              <a:spcAft>
+                <a:spcPts val="0"/>
+              </a:spcAft>
+              <a:buClr>
+                <a:srgbClr val="000000"/>
+              </a:buClr>
+              <a:buSzPts val="1800"/>
+              <a:buFont typeface="Arial"/>
+              <a:buNone/>
+            </a:pPr>
+            <a:r>
+              <a:t/>
+            </a:r>
+            <a:endParaRPr b="0" i="0" spc="0" sz="1800" u="none" cap="none" strike="noStrike">
+              <a:solidFill>
+                <a:schemeClr val="dk1"/>
+              </a:solidFill>
+              <a:latin typeface="Calibri"/>
+              <a:ea typeface="Calibri"/>
+              <a:cs typeface="Calibri"/>
+              <a:sym typeface="Calibri"/>
+            </a:endParaRPr>
+          </a:p>
+        </p:txBody>
+      </p:sp>
+      <p:sp>
+        <p:nvSpPr>
+          <p:cNvPr id="377" name="Google Shape;377;p13"/>
+          <p:cNvSpPr txBox="1"/>
+          <p:nvPr/>
+        </p:nvSpPr>
+        <p:spPr>
+          <a:xfrm>
+            <a:off x="5852135" y="3656415"/>
+            <a:ext cx="1234500" cy="184800"/>
+          </a:xfrm>
+          <a:prstGeom prst="rect">
+            <a:avLst/>
+          </a:prstGeom>
+          <a:noFill/>
+          <a:ln>
+            <a:noFill/>
+          </a:ln>
+        </p:spPr>
+        <p:txBody>
+          <a:bodyPr anchorCtr="0" anchor="ctr" bIns="0" lIns="0" spcFirstLastPara="1" rIns="0" wrap="square" tIns="0">
+            <a:spAutoFit/>
+          </a:bodyPr>
+          <a:lstStyle/>
+          <a:p>
+            <a:pPr indent="0" lvl="0" marL="0" marR="0" rtl="0" algn="ctr">
+              <a:lnSpc>
+                <a:spcPct val="110000"/>
+              </a:lnSpc>
+              <a:spcBef>
+                <a:spcPts val="0"/>
+              </a:spcBef>
+              <a:spcAft>
+                <a:spcPts val="0"/>
+              </a:spcAft>
+              <a:buClr>
+                <a:srgbClr val="000000"/>
+              </a:buClr>
+              <a:buSzPts val="1200"/>
+              <a:buFont typeface="Arial"/>
+              <a:buNone/>
+            </a:pPr>
+            <a:r>
+              <a:rPr b="1" i="0" lang="en-US" spc="0" sz="1200" u="none" cap="none" strike="noStrike">
+                <a:solidFill>
+                  <a:srgbClr val="11803E"/>
                 </a:solidFill>
                 <a:latin typeface="Plus Jakarta Sans"/>
                 <a:ea typeface="Plus Jakarta Sans"/>
                 <a:cs typeface="Plus Jakarta Sans"/>
                 <a:sym typeface="Plus Jakarta Sans"/>
               </a:rPr>
-              <a:t>Bloqueado ou em uso / </a:t>
+              <a:t>Aprovado</a:t>
             </a:r>
             <a:endParaRPr b="0" i="0" spc="0" sz="1400" u="none" cap="none" strike="noStrike">
               <a:solidFill>
-                <a:srgbClr val="545F73"/>
+                <a:srgbClr val="000000"/>
+              </a:solidFill>
+              <a:latin typeface="Arial"/>
+              <a:ea typeface="Arial"/>
+              <a:cs typeface="Arial"/>
+              <a:sym typeface="Arial"/>
+            </a:endParaRPr>
+          </a:p>
+        </p:txBody>
+      </p:sp>
+      <p:sp>
+        <p:nvSpPr>
+          <p:cNvPr id="378" name="Google Shape;378;p13"/>
+          <p:cNvSpPr txBox="1"/>
+          <p:nvPr/>
+        </p:nvSpPr>
+        <p:spPr>
+          <a:xfrm>
+            <a:off x="5852110" y="5191578"/>
+            <a:ext cx="1234500" cy="184800"/>
+          </a:xfrm>
+          <a:prstGeom prst="rect">
+            <a:avLst/>
+          </a:prstGeom>
+          <a:noFill/>
+          <a:ln>
+            <a:noFill/>
+          </a:ln>
+        </p:spPr>
+        <p:txBody>
+          <a:bodyPr anchorCtr="0" anchor="ctr" bIns="0" lIns="0" spcFirstLastPara="1" rIns="0" wrap="square" tIns="0">
+            <a:spAutoFit/>
+          </a:bodyPr>
+          <a:lstStyle/>
+          <a:p>
+            <a:pPr indent="0" lvl="0" marL="0" marR="0" rtl="0" algn="ctr">
+              <a:lnSpc>
+                <a:spcPct val="110000"/>
+              </a:lnSpc>
+              <a:spcBef>
+                <a:spcPts val="0"/>
+              </a:spcBef>
+              <a:spcAft>
+                <a:spcPts val="0"/>
+              </a:spcAft>
+              <a:buClr>
+                <a:srgbClr val="000000"/>
+              </a:buClr>
+              <a:buSzPts val="1200"/>
+              <a:buFont typeface="Arial"/>
+              <a:buNone/>
+            </a:pPr>
+            <a:r>
+              <a:rPr b="1" i="0" lang="en-US" spc="0" sz="1200" u="none" cap="none" strike="noStrike">
+                <a:solidFill>
+                  <a:srgbClr val="11803E"/>
+                </a:solidFill>
+                <a:latin typeface="Plus Jakarta Sans"/>
+                <a:ea typeface="Plus Jakarta Sans"/>
+                <a:cs typeface="Plus Jakarta Sans"/>
+                <a:sym typeface="Plus Jakarta Sans"/>
+              </a:rPr>
+              <a:t>Aprovado</a:t>
+            </a:r>
+            <a:endParaRPr b="0" i="0" spc="0" sz="1400" u="none" cap="none" strike="noStrike">
+              <a:solidFill>
+                <a:srgbClr val="000000"/>
+              </a:solidFill>
+              <a:latin typeface="Arial"/>
+              <a:ea typeface="Arial"/>
+              <a:cs typeface="Arial"/>
+              <a:sym typeface="Arial"/>
+            </a:endParaRPr>
+          </a:p>
+        </p:txBody>
+      </p:sp>
+    </p:spTree>
+  </p:cSld>
+  <p:clrMapOvr>
+    <a:masterClrMapping/>
+  </p:clrMapOvr>
+</p:sld>
+</file>
+
+<file path=ppt/slides/slide14.xml><?xml version="1.0" encoding="utf-8"?>
+<p:sld xmlns:a="http://schemas.openxmlformats.org/drawingml/2006/main" xmlns:p="http://schemas.openxmlformats.org/presentationml/2006/main" xmlns:r="http://schemas.openxmlformats.org/officeDocument/2006/relationships">
+  <p:cSld>
+    <p:bg>
+      <p:bgPr>
+        <a:solidFill>
+          <a:srgbClr val="F5F7FA"/>
+        </a:solidFill>
+      </p:bgPr>
+    </p:bg>
+    <p:spTree>
+      <p:nvGrpSpPr>
+        <p:cNvPr id="1" name=""/>
+        <p:cNvGrpSpPr/>
+        <p:nvPr/>
+      </p:nvGrpSpPr>
+      <p:grpSpPr/>
+      <p:sp>
+        <p:nvSpPr>
+          <p:cNvPr id="354" name="Google Shape;354;p13"/>
+          <p:cNvSpPr txBox="1"/>
+          <p:nvPr/>
+        </p:nvSpPr>
+        <p:spPr>
+          <a:xfrm>
+            <a:off x="685800" y="502920"/>
+            <a:ext cx="8229600" cy="274320"/>
+          </a:xfrm>
+          <a:prstGeom prst="rect">
+            <a:avLst/>
+          </a:prstGeom>
+          <a:noFill/>
+          <a:ln>
+            <a:noFill/>
+          </a:ln>
+        </p:spPr>
+        <p:txBody>
+          <a:bodyPr anchorCtr="0" anchor="t" bIns="0" lIns="0" spcFirstLastPara="1" rIns="0" wrap="square" tIns="0">
+            <a:spAutoFit/>
+          </a:bodyPr>
+          <a:lstStyle/>
+          <a:p>
+            <a:pPr indent="0" lvl="0" marL="0" marR="0" rtl="0" algn="l">
+              <a:lnSpc>
+                <a:spcPct val="110000"/>
+              </a:lnSpc>
+              <a:spcBef>
+                <a:spcPts val="0"/>
+              </a:spcBef>
+              <a:spcAft>
+                <a:spcPts val="0"/>
+              </a:spcAft>
+              <a:buClr>
+                <a:srgbClr val="000000"/>
+              </a:buClr>
+              <a:buSzPts val="1200"/>
+              <a:buFont typeface="Arial"/>
+              <a:buNone/>
+            </a:pPr>
+            <a:r>
+              <a:rPr b="1" i="0" lang="en-US" spc="200" sz="1200" u="none" cap="none" strike="noStrike">
+                <a:solidFill>
+                  <a:srgbClr val="0B5FD9"/>
+                </a:solidFill>
+                <a:latin typeface="Plus Jakarta Sans"/>
+                <a:ea typeface="Plus Jakarta Sans"/>
+                <a:cs typeface="Plus Jakarta Sans"/>
+                <a:sym typeface="Plus Jakarta Sans"/>
+              </a:rPr>
+              <a:t>RESULTADOS · ALARME</a:t>
+            </a:r>
+            <a:endParaRPr b="0" i="0" spc="0" sz="1400" u="none" cap="none" strike="noStrike">
+              <a:solidFill>
+                <a:srgbClr val="000000"/>
+              </a:solidFill>
+              <a:latin typeface="Arial"/>
+              <a:ea typeface="Arial"/>
+              <a:cs typeface="Arial"/>
+              <a:sym typeface="Arial"/>
+            </a:endParaRPr>
+          </a:p>
+        </p:txBody>
+      </p:sp>
+      <p:sp>
+        <p:nvSpPr>
+          <p:cNvPr id="355" name="Google Shape;355;p13"/>
+          <p:cNvSpPr txBox="1"/>
+          <p:nvPr/>
+        </p:nvSpPr>
+        <p:spPr>
+          <a:xfrm>
+            <a:off x="685800" y="804672"/>
+            <a:ext cx="10820095" cy="822960"/>
+          </a:xfrm>
+          <a:prstGeom prst="rect">
+            <a:avLst/>
+          </a:prstGeom>
+          <a:noFill/>
+          <a:ln>
+            <a:noFill/>
+          </a:ln>
+        </p:spPr>
+        <p:txBody>
+          <a:bodyPr anchorCtr="0" anchor="t" bIns="0" lIns="0" spcFirstLastPara="1" rIns="0" wrap="square" tIns="0">
+            <a:spAutoFit/>
+          </a:bodyPr>
+          <a:lstStyle/>
+          <a:p>
+            <a:pPr indent="0" lvl="0" marL="0" marR="0" rtl="0" algn="l">
+              <a:lnSpc>
+                <a:spcPct val="100000"/>
+              </a:lnSpc>
+              <a:spcBef>
+                <a:spcPts val="0"/>
+              </a:spcBef>
+              <a:spcAft>
+                <a:spcPts val="0"/>
+              </a:spcAft>
+              <a:buClr>
+                <a:srgbClr val="000000"/>
+              </a:buClr>
+              <a:buSzPts val="2800"/>
+              <a:buFont typeface="Arial"/>
+              <a:buNone/>
+            </a:pPr>
+            <a:r>
+              <a:rPr b="1" i="0" lang="en-US" spc="0" sz="2800" u="none" cap="none" strike="noStrike">
+                <a:solidFill>
+                  <a:srgbClr val="191C1E"/>
+                </a:solidFill>
+                <a:latin typeface="Plus Jakarta Sans"/>
+                <a:ea typeface="Plus Jakarta Sans"/>
+                <a:cs typeface="Plus Jakarta Sans"/>
+                <a:sym typeface="Plus Jakarta Sans"/>
+              </a:rPr>
+              <a:t>O alarme tocou nas quatro situações testadas</a:t>
+            </a:r>
+            <a:endParaRPr b="0" i="0" spc="0" sz="1400" u="none" cap="none" strike="noStrike">
+              <a:solidFill>
+                <a:srgbClr val="000000"/>
+              </a:solidFill>
+              <a:latin typeface="Arial"/>
+              <a:ea typeface="Arial"/>
+              <a:cs typeface="Arial"/>
+              <a:sym typeface="Arial"/>
+            </a:endParaRPr>
+          </a:p>
+        </p:txBody>
+      </p:sp>
+      <p:sp>
+        <p:nvSpPr>
+          <p:cNvPr id="356" name="Google Shape;356;p13"/>
+          <p:cNvSpPr txBox="1"/>
+          <p:nvPr/>
+        </p:nvSpPr>
+        <p:spPr>
+          <a:xfrm>
+            <a:off x="685800" y="6419088"/>
+            <a:ext cx="7315200" cy="228600"/>
+          </a:xfrm>
+          <a:prstGeom prst="rect">
+            <a:avLst/>
+          </a:prstGeom>
+          <a:noFill/>
+          <a:ln>
+            <a:noFill/>
+          </a:ln>
+        </p:spPr>
+        <p:txBody>
+          <a:bodyPr anchorCtr="0" anchor="t" bIns="0" lIns="0" spcFirstLastPara="1" rIns="0" wrap="square" tIns="0">
+            <a:spAutoFit/>
+          </a:bodyPr>
+          <a:lstStyle/>
+          <a:p>
+            <a:pPr indent="0" lvl="0" marL="0" marR="0" rtl="0" algn="l">
+              <a:lnSpc>
+                <a:spcPct val="110000"/>
+              </a:lnSpc>
+              <a:spcBef>
+                <a:spcPts val="0"/>
+              </a:spcBef>
+              <a:spcAft>
+                <a:spcPts val="0"/>
+              </a:spcAft>
+              <a:buClr>
+                <a:srgbClr val="000000"/>
+              </a:buClr>
+              <a:buSzPts val="1000"/>
+              <a:buFont typeface="Arial"/>
+              <a:buNone/>
+            </a:pPr>
+            <a:r>
+              <a:rPr b="0" i="0" lang="en-US" spc="0" sz="1000" u="none" cap="none" strike="noStrike">
+                <a:solidFill>
+                  <a:srgbClr val="545F73"/>
+                </a:solidFill>
+                <a:latin typeface="Plus Jakarta Sans"/>
+                <a:ea typeface="Plus Jakarta Sans"/>
+                <a:cs typeface="Plus Jakarta Sans"/>
+                <a:sym typeface="Plus Jakarta Sans"/>
+              </a:rPr>
+              <a:t>Mapill  ·  Gabriel Steffens  ·  Sistemas de Informação, UNIDAVI</a:t>
+            </a:r>
+            <a:endParaRPr b="0" i="0" spc="0" sz="1400" u="none" cap="none" strike="noStrike">
+              <a:solidFill>
+                <a:srgbClr val="000000"/>
+              </a:solidFill>
+              <a:latin typeface="Arial"/>
+              <a:ea typeface="Arial"/>
+              <a:cs typeface="Arial"/>
+              <a:sym typeface="Arial"/>
+            </a:endParaRPr>
+          </a:p>
+        </p:txBody>
+      </p:sp>
+      <p:sp>
+        <p:nvSpPr>
+          <p:cNvPr id="357" name="Google Shape;357;p13"/>
+          <p:cNvSpPr txBox="1"/>
+          <p:nvPr/>
+        </p:nvSpPr>
+        <p:spPr>
+          <a:xfrm>
+            <a:off x="10591495" y="6419088"/>
+            <a:ext cx="914400" cy="228600"/>
+          </a:xfrm>
+          <a:prstGeom prst="rect">
+            <a:avLst/>
+          </a:prstGeom>
+          <a:noFill/>
+          <a:ln>
+            <a:noFill/>
+          </a:ln>
+        </p:spPr>
+        <p:txBody>
+          <a:bodyPr anchorCtr="0" anchor="t" bIns="0" lIns="0" spcFirstLastPara="1" rIns="0" wrap="square" tIns="0">
+            <a:spAutoFit/>
+          </a:bodyPr>
+          <a:lstStyle/>
+          <a:p>
+            <a:pPr indent="0" lvl="0" marL="0" marR="0" rtl="0" algn="r">
+              <a:lnSpc>
+                <a:spcPct val="110000"/>
+              </a:lnSpc>
+              <a:spcBef>
+                <a:spcPts val="0"/>
+              </a:spcBef>
+              <a:spcAft>
+                <a:spcPts val="0"/>
+              </a:spcAft>
+              <a:buClr>
+                <a:srgbClr val="000000"/>
+              </a:buClr>
+              <a:buSzPts val="1000"/>
+              <a:buFont typeface="Arial"/>
+              <a:buNone/>
+            </a:pPr>
+            <a:r>
+              <a:rPr b="1" i="0" lang="en-US" spc="0" sz="1000" u="none" cap="none" strike="noStrike">
+                <a:solidFill>
+                  <a:srgbClr val="545F73"/>
+                </a:solidFill>
+                <a:latin typeface="Plus Jakarta Sans"/>
+                <a:ea typeface="Plus Jakarta Sans"/>
+                <a:cs typeface="Plus Jakarta Sans"/>
+                <a:sym typeface="Plus Jakarta Sans"/>
+              </a:rPr>
+              <a:t>14</a:t>
+            </a:r>
+            <a:endParaRPr b="0" i="0" spc="0" sz="1400" u="none" cap="none" strike="noStrike">
+              <a:solidFill>
+                <a:srgbClr val="000000"/>
+              </a:solidFill>
+              <a:latin typeface="Arial"/>
+              <a:ea typeface="Arial"/>
+              <a:cs typeface="Arial"/>
+              <a:sym typeface="Arial"/>
+            </a:endParaRPr>
+          </a:p>
+        </p:txBody>
+      </p:sp>
+      <p:sp>
+        <p:nvSpPr>
+          <p:cNvPr id="358" name="Google Shape;358;p13"/>
+          <p:cNvSpPr/>
+          <p:nvPr/>
+        </p:nvSpPr>
+        <p:spPr>
+          <a:xfrm>
+            <a:off x="685800" y="1783080"/>
+            <a:ext cx="6675000" cy="4160400"/>
+          </a:xfrm>
+          <a:prstGeom prst="roundRect">
+            <a:avLst>
+              <a:gd fmla="val 3076" name="adj"/>
+            </a:avLst>
+          </a:prstGeom>
+          <a:solidFill>
+            <a:srgbClr val="FFFFFF"/>
+          </a:solidFill>
+          <a:ln>
+            <a:noFill/>
+          </a:ln>
+        </p:spPr>
+        <p:txBody>
+          <a:bodyPr anchorCtr="0" anchor="ctr" bIns="45700" lIns="91425" spcFirstLastPara="1" rIns="91425" wrap="square" tIns="45700">
+            <a:noAutofit/>
+          </a:bodyPr>
+          <a:lstStyle/>
+          <a:p>
+            <a:pPr indent="0" lvl="0" marL="0" marR="0" rtl="0" algn="l">
+              <a:lnSpc>
+                <a:spcPct val="100000"/>
+              </a:lnSpc>
+              <a:spcBef>
+                <a:spcPts val="0"/>
+              </a:spcBef>
+              <a:spcAft>
+                <a:spcPts val="0"/>
+              </a:spcAft>
+              <a:buClr>
+                <a:srgbClr val="000000"/>
+              </a:buClr>
+              <a:buSzPts val="1800"/>
+              <a:buFont typeface="Arial"/>
+              <a:buNone/>
+            </a:pPr>
+            <a:r>
+              <a:t/>
+            </a:r>
+            <a:endParaRPr b="0" i="0" spc="0" sz="1800" u="none" cap="none" strike="noStrike">
+              <a:solidFill>
+                <a:schemeClr val="dk1"/>
+              </a:solidFill>
+              <a:latin typeface="Calibri"/>
+              <a:ea typeface="Calibri"/>
+              <a:cs typeface="Calibri"/>
+              <a:sym typeface="Calibri"/>
+            </a:endParaRPr>
+          </a:p>
+        </p:txBody>
+      </p:sp>
+      <p:sp>
+        <p:nvSpPr>
+          <p:cNvPr id="359" name="Google Shape;359;p13"/>
+          <p:cNvSpPr txBox="1"/>
+          <p:nvPr/>
+        </p:nvSpPr>
+        <p:spPr>
+          <a:xfrm>
+            <a:off x="1005840" y="1965960"/>
+            <a:ext cx="3931920" cy="548640"/>
+          </a:xfrm>
+          <a:prstGeom prst="rect">
+            <a:avLst/>
+          </a:prstGeom>
+          <a:noFill/>
+          <a:ln>
+            <a:noFill/>
+          </a:ln>
+        </p:spPr>
+        <p:txBody>
+          <a:bodyPr anchorCtr="0" anchor="ctr" bIns="0" lIns="0" spcFirstLastPara="1" rIns="0" wrap="square" tIns="0">
+            <a:spAutoFit/>
+          </a:bodyPr>
+          <a:lstStyle/>
+          <a:p>
+            <a:pPr indent="0" lvl="0" marL="0" marR="0" rtl="0" algn="l">
+              <a:lnSpc>
+                <a:spcPct val="110000"/>
+              </a:lnSpc>
+              <a:spcBef>
+                <a:spcPts val="0"/>
+              </a:spcBef>
+              <a:spcAft>
+                <a:spcPts val="0"/>
+              </a:spcAft>
+              <a:buClr>
+                <a:srgbClr val="000000"/>
+              </a:buClr>
+              <a:buSzPts val="1600"/>
+              <a:buFont typeface="Arial"/>
+              <a:buNone/>
+            </a:pPr>
+            <a:r>
+              <a:rPr b="0" i="0" lang="en-US" spc="0" sz="1600" u="none" cap="none" strike="noStrike">
+                <a:solidFill>
+                  <a:srgbClr val="191C1E"/>
+                </a:solidFill>
+                <a:latin typeface="Plus Jakarta Sans"/>
+                <a:ea typeface="Plus Jakarta Sans"/>
+                <a:cs typeface="Plus Jakarta Sans"/>
+                <a:sym typeface="Plus Jakarta Sans"/>
+              </a:rPr>
+              <a:t>Bloqueado, app nos recentes</a:t>
+            </a:r>
+            <a:endParaRPr b="0" i="0" spc="0" sz="1400" u="none" cap="none" strike="noStrike">
+              <a:solidFill>
+                <a:srgbClr val="000000"/>
+              </a:solidFill>
+              <a:latin typeface="Arial"/>
+              <a:ea typeface="Arial"/>
+              <a:cs typeface="Arial"/>
+              <a:sym typeface="Arial"/>
+            </a:endParaRPr>
+          </a:p>
+        </p:txBody>
+      </p:sp>
+      <p:sp>
+        <p:nvSpPr>
+          <p:cNvPr id="360" name="Google Shape;360;p13"/>
+          <p:cNvSpPr/>
+          <p:nvPr/>
+        </p:nvSpPr>
+        <p:spPr>
+          <a:xfrm>
+            <a:off x="5852160" y="2075688"/>
+            <a:ext cx="1234440" cy="329184"/>
+          </a:xfrm>
+          <a:prstGeom prst="roundRect">
+            <a:avLst>
+              <a:gd fmla="val 50000" name="adj"/>
+            </a:avLst>
+          </a:prstGeom>
+          <a:solidFill>
+            <a:srgbClr val="E3F6EA"/>
+          </a:solidFill>
+          <a:ln>
+            <a:noFill/>
+          </a:ln>
+        </p:spPr>
+        <p:txBody>
+          <a:bodyPr anchorCtr="0" anchor="ctr" bIns="45700" lIns="91425" spcFirstLastPara="1" rIns="91425" wrap="square" tIns="45700">
+            <a:noAutofit/>
+          </a:bodyPr>
+          <a:lstStyle/>
+          <a:p>
+            <a:pPr indent="0" lvl="0" marL="0" marR="0" rtl="0" algn="l">
+              <a:lnSpc>
+                <a:spcPct val="100000"/>
+              </a:lnSpc>
+              <a:spcBef>
+                <a:spcPts val="0"/>
+              </a:spcBef>
+              <a:spcAft>
+                <a:spcPts val="0"/>
+              </a:spcAft>
+              <a:buClr>
+                <a:srgbClr val="000000"/>
+              </a:buClr>
+              <a:buSzPts val="1800"/>
+              <a:buFont typeface="Arial"/>
+              <a:buNone/>
+            </a:pPr>
+            <a:r>
+              <a:t/>
+            </a:r>
+            <a:endParaRPr b="0" i="0" spc="0" sz="1800" u="none" cap="none" strike="noStrike">
+              <a:solidFill>
+                <a:schemeClr val="dk1"/>
+              </a:solidFill>
+              <a:latin typeface="Calibri"/>
+              <a:ea typeface="Calibri"/>
+              <a:cs typeface="Calibri"/>
+              <a:sym typeface="Calibri"/>
+            </a:endParaRPr>
+          </a:p>
+        </p:txBody>
+      </p:sp>
+      <p:sp>
+        <p:nvSpPr>
+          <p:cNvPr id="361" name="Google Shape;361;p13"/>
+          <p:cNvSpPr txBox="1"/>
+          <p:nvPr/>
+        </p:nvSpPr>
+        <p:spPr>
+          <a:xfrm>
+            <a:off x="5852160" y="2075688"/>
+            <a:ext cx="1234440" cy="329184"/>
+          </a:xfrm>
+          <a:prstGeom prst="rect">
+            <a:avLst/>
+          </a:prstGeom>
+          <a:noFill/>
+          <a:ln>
+            <a:noFill/>
+          </a:ln>
+        </p:spPr>
+        <p:txBody>
+          <a:bodyPr anchorCtr="0" anchor="ctr" bIns="0" lIns="0" spcFirstLastPara="1" rIns="0" wrap="square" tIns="0">
+            <a:spAutoFit/>
+          </a:bodyPr>
+          <a:lstStyle/>
+          <a:p>
+            <a:pPr indent="0" lvl="0" marL="0" marR="0" rtl="0" algn="ctr">
+              <a:lnSpc>
+                <a:spcPct val="110000"/>
+              </a:lnSpc>
+              <a:spcBef>
+                <a:spcPts val="0"/>
+              </a:spcBef>
+              <a:spcAft>
+                <a:spcPts val="0"/>
+              </a:spcAft>
+              <a:buClr>
+                <a:srgbClr val="000000"/>
+              </a:buClr>
+              <a:buSzPts val="1200"/>
+              <a:buFont typeface="Arial"/>
+              <a:buNone/>
+            </a:pPr>
+            <a:r>
+              <a:rPr b="1" i="0" lang="en-US" spc="0" sz="1200" u="none" cap="none" strike="noStrike">
+                <a:solidFill>
+                  <a:srgbClr val="11803E"/>
+                </a:solidFill>
+                <a:latin typeface="Plus Jakarta Sans"/>
+                <a:ea typeface="Plus Jakarta Sans"/>
+                <a:cs typeface="Plus Jakarta Sans"/>
+                <a:sym typeface="Plus Jakarta Sans"/>
+              </a:rPr>
+              <a:t>Aprovado</a:t>
+            </a:r>
+            <a:endParaRPr b="0" i="0" spc="0" sz="1400" u="none" cap="none" strike="noStrike">
+              <a:solidFill>
+                <a:srgbClr val="000000"/>
+              </a:solidFill>
+              <a:latin typeface="Arial"/>
+              <a:ea typeface="Arial"/>
+              <a:cs typeface="Arial"/>
+              <a:sym typeface="Arial"/>
+            </a:endParaRPr>
+          </a:p>
+        </p:txBody>
+      </p:sp>
+      <p:sp>
+        <p:nvSpPr>
+          <p:cNvPr id="362" name="Google Shape;362;p13"/>
+          <p:cNvSpPr txBox="1"/>
+          <p:nvPr/>
+        </p:nvSpPr>
+        <p:spPr>
+          <a:xfrm>
+            <a:off x="1005840" y="2724912"/>
+            <a:ext cx="3931920" cy="548640"/>
+          </a:xfrm>
+          <a:prstGeom prst="rect">
+            <a:avLst/>
+          </a:prstGeom>
+          <a:noFill/>
+          <a:ln>
+            <a:noFill/>
+          </a:ln>
+        </p:spPr>
+        <p:txBody>
+          <a:bodyPr anchorCtr="0" anchor="ctr" bIns="0" lIns="0" spcFirstLastPara="1" rIns="0" wrap="square" tIns="0">
+            <a:spAutoFit/>
+          </a:bodyPr>
+          <a:lstStyle/>
+          <a:p>
+            <a:pPr indent="0" lvl="0" marL="0" marR="0" rtl="0" algn="l">
+              <a:lnSpc>
+                <a:spcPct val="110000"/>
+              </a:lnSpc>
+              <a:spcBef>
+                <a:spcPts val="0"/>
+              </a:spcBef>
+              <a:spcAft>
+                <a:spcPts val="0"/>
+              </a:spcAft>
+              <a:buClr>
+                <a:srgbClr val="000000"/>
+              </a:buClr>
+              <a:buSzPts val="1600"/>
+              <a:buFont typeface="Arial"/>
+              <a:buNone/>
+            </a:pPr>
+            <a:r>
+              <a:rPr b="0" i="0" lang="en-US" spc="0" sz="1600" u="none" cap="none" strike="noStrike">
+                <a:solidFill>
+                  <a:srgbClr val="191C1E"/>
+                </a:solidFill>
+                <a:latin typeface="Plus Jakarta Sans"/>
+                <a:ea typeface="Plus Jakarta Sans"/>
+                <a:cs typeface="Plus Jakarta Sans"/>
+                <a:sym typeface="Plus Jakarta Sans"/>
+              </a:rPr>
+              <a:t>Bloqueado, fora dos recentes</a:t>
+            </a:r>
+            <a:endParaRPr b="0" i="0" spc="0" sz="1400" u="none" cap="none" strike="noStrike">
+              <a:solidFill>
+                <a:srgbClr val="000000"/>
+              </a:solidFill>
+              <a:latin typeface="Arial"/>
+              <a:ea typeface="Arial"/>
+              <a:cs typeface="Arial"/>
+              <a:sym typeface="Arial"/>
+            </a:endParaRPr>
+          </a:p>
+        </p:txBody>
+      </p:sp>
+      <p:sp>
+        <p:nvSpPr>
+          <p:cNvPr id="363" name="Google Shape;363;p13"/>
+          <p:cNvSpPr/>
+          <p:nvPr/>
+        </p:nvSpPr>
+        <p:spPr>
+          <a:xfrm>
+            <a:off x="5852160" y="2834640"/>
+            <a:ext cx="1234440" cy="329184"/>
+          </a:xfrm>
+          <a:prstGeom prst="roundRect">
+            <a:avLst>
+              <a:gd fmla="val 50000" name="adj"/>
+            </a:avLst>
+          </a:prstGeom>
+          <a:solidFill>
+            <a:srgbClr val="E3F6EA"/>
+          </a:solidFill>
+          <a:ln>
+            <a:noFill/>
+          </a:ln>
+        </p:spPr>
+        <p:txBody>
+          <a:bodyPr anchorCtr="0" anchor="ctr" bIns="45700" lIns="91425" spcFirstLastPara="1" rIns="91425" wrap="square" tIns="45700">
+            <a:noAutofit/>
+          </a:bodyPr>
+          <a:lstStyle/>
+          <a:p>
+            <a:pPr indent="0" lvl="0" marL="0" marR="0" rtl="0" algn="l">
+              <a:lnSpc>
+                <a:spcPct val="100000"/>
+              </a:lnSpc>
+              <a:spcBef>
+                <a:spcPts val="0"/>
+              </a:spcBef>
+              <a:spcAft>
+                <a:spcPts val="0"/>
+              </a:spcAft>
+              <a:buClr>
+                <a:srgbClr val="000000"/>
+              </a:buClr>
+              <a:buSzPts val="1800"/>
+              <a:buFont typeface="Arial"/>
+              <a:buNone/>
+            </a:pPr>
+            <a:r>
+              <a:t/>
+            </a:r>
+            <a:endParaRPr b="0" i="0" spc="0" sz="1800" u="none" cap="none" strike="noStrike">
+              <a:solidFill>
+                <a:schemeClr val="dk1"/>
+              </a:solidFill>
+              <a:latin typeface="Calibri"/>
+              <a:ea typeface="Calibri"/>
+              <a:cs typeface="Calibri"/>
+              <a:sym typeface="Calibri"/>
+            </a:endParaRPr>
+          </a:p>
+        </p:txBody>
+      </p:sp>
+      <p:sp>
+        <p:nvSpPr>
+          <p:cNvPr id="364" name="Google Shape;364;p13"/>
+          <p:cNvSpPr txBox="1"/>
+          <p:nvPr/>
+        </p:nvSpPr>
+        <p:spPr>
+          <a:xfrm>
+            <a:off x="5852135" y="2906840"/>
+            <a:ext cx="1234500" cy="184800"/>
+          </a:xfrm>
+          <a:prstGeom prst="rect">
+            <a:avLst/>
+          </a:prstGeom>
+          <a:noFill/>
+          <a:ln>
+            <a:noFill/>
+          </a:ln>
+        </p:spPr>
+        <p:txBody>
+          <a:bodyPr anchorCtr="0" anchor="ctr" bIns="0" lIns="0" spcFirstLastPara="1" rIns="0" wrap="square" tIns="0">
+            <a:spAutoFit/>
+          </a:bodyPr>
+          <a:lstStyle/>
+          <a:p>
+            <a:pPr indent="0" lvl="0" marL="0" marR="0" rtl="0" algn="ctr">
+              <a:lnSpc>
+                <a:spcPct val="110000"/>
+              </a:lnSpc>
+              <a:spcBef>
+                <a:spcPts val="0"/>
+              </a:spcBef>
+              <a:spcAft>
+                <a:spcPts val="0"/>
+              </a:spcAft>
+              <a:buClr>
+                <a:srgbClr val="000000"/>
+              </a:buClr>
+              <a:buSzPts val="1200"/>
+              <a:buFont typeface="Arial"/>
+              <a:buNone/>
+            </a:pPr>
+            <a:r>
+              <a:rPr b="1" i="0" lang="en-US" spc="0" sz="1200" u="none" cap="none" strike="noStrike">
+                <a:solidFill>
+                  <a:srgbClr val="11803E"/>
+                </a:solidFill>
+                <a:latin typeface="Plus Jakarta Sans"/>
+                <a:ea typeface="Plus Jakarta Sans"/>
+                <a:cs typeface="Plus Jakarta Sans"/>
+                <a:sym typeface="Plus Jakarta Sans"/>
+              </a:rPr>
+              <a:t>Aprovado</a:t>
+            </a:r>
+            <a:endParaRPr b="0" i="0" spc="0" sz="1400" u="none" cap="none" strike="noStrike">
+              <a:solidFill>
+                <a:srgbClr val="000000"/>
+              </a:solidFill>
+              <a:latin typeface="Arial"/>
+              <a:ea typeface="Arial"/>
+              <a:cs typeface="Arial"/>
+              <a:sym typeface="Arial"/>
+            </a:endParaRPr>
+          </a:p>
+        </p:txBody>
+      </p:sp>
+      <p:sp>
+        <p:nvSpPr>
+          <p:cNvPr id="365" name="Google Shape;365;p13"/>
+          <p:cNvSpPr txBox="1"/>
+          <p:nvPr/>
+        </p:nvSpPr>
+        <p:spPr>
+          <a:xfrm>
+            <a:off x="1005840" y="3483863"/>
+            <a:ext cx="3931920" cy="548640"/>
+          </a:xfrm>
+          <a:prstGeom prst="rect">
+            <a:avLst/>
+          </a:prstGeom>
+          <a:noFill/>
+          <a:ln>
+            <a:noFill/>
+          </a:ln>
+        </p:spPr>
+        <p:txBody>
+          <a:bodyPr anchorCtr="0" anchor="ctr" bIns="0" lIns="0" spcFirstLastPara="1" rIns="0" wrap="square" tIns="0">
+            <a:spAutoFit/>
+          </a:bodyPr>
+          <a:lstStyle/>
+          <a:p>
+            <a:pPr indent="0" lvl="0" marL="0" marR="0" rtl="0" algn="l">
+              <a:lnSpc>
+                <a:spcPct val="110000"/>
+              </a:lnSpc>
+              <a:spcBef>
+                <a:spcPts val="0"/>
+              </a:spcBef>
+              <a:spcAft>
+                <a:spcPts val="0"/>
+              </a:spcAft>
+              <a:buClr>
+                <a:srgbClr val="000000"/>
+              </a:buClr>
+              <a:buSzPts val="1600"/>
+              <a:buFont typeface="Arial"/>
+              <a:buNone/>
+            </a:pPr>
+            <a:r>
+              <a:rPr b="0" i="0" lang="en-US" spc="0" sz="1600" u="none" cap="none" strike="noStrike">
+                <a:solidFill>
+                  <a:srgbClr val="191C1E"/>
+                </a:solidFill>
+                <a:latin typeface="Plus Jakarta Sans"/>
+                <a:ea typeface="Plus Jakarta Sans"/>
+                <a:cs typeface="Plus Jakarta Sans"/>
+                <a:sym typeface="Plus Jakarta Sans"/>
+              </a:rPr>
+              <a:t>Em uso, app nos recentes</a:t>
+            </a:r>
+            <a:endParaRPr b="0" i="0" spc="0" sz="1400" u="none" cap="none" strike="noStrike">
+              <a:solidFill>
+                <a:srgbClr val="000000"/>
+              </a:solidFill>
+              <a:latin typeface="Arial"/>
+              <a:ea typeface="Arial"/>
+              <a:cs typeface="Arial"/>
+              <a:sym typeface="Arial"/>
+            </a:endParaRPr>
+          </a:p>
+        </p:txBody>
+      </p:sp>
+      <p:sp>
+        <p:nvSpPr>
+          <p:cNvPr id="366" name="Google Shape;366;p13"/>
+          <p:cNvSpPr txBox="1"/>
+          <p:nvPr/>
+        </p:nvSpPr>
+        <p:spPr>
+          <a:xfrm>
+            <a:off x="1005840" y="4242816"/>
+            <a:ext cx="3931920" cy="548640"/>
+          </a:xfrm>
+          <a:prstGeom prst="rect">
+            <a:avLst/>
+          </a:prstGeom>
+          <a:noFill/>
+          <a:ln>
+            <a:noFill/>
+          </a:ln>
+        </p:spPr>
+        <p:txBody>
+          <a:bodyPr anchorCtr="0" anchor="ctr" bIns="0" lIns="0" spcFirstLastPara="1" rIns="0" wrap="square" tIns="0">
+            <a:spAutoFit/>
+          </a:bodyPr>
+          <a:lstStyle/>
+          <a:p>
+            <a:pPr indent="0" lvl="0" marL="0" marR="0" rtl="0" algn="l">
+              <a:lnSpc>
+                <a:spcPct val="110000"/>
+              </a:lnSpc>
+              <a:spcBef>
+                <a:spcPts val="0"/>
+              </a:spcBef>
+              <a:spcAft>
+                <a:spcPts val="0"/>
+              </a:spcAft>
+              <a:buClr>
+                <a:srgbClr val="000000"/>
+              </a:buClr>
+              <a:buSzPts val="1600"/>
+              <a:buFont typeface="Arial"/>
+              <a:buNone/>
+            </a:pPr>
+            <a:r>
+              <a:rPr b="0" i="0" lang="en-US" spc="0" sz="1600" u="none" cap="none" strike="noStrike">
+                <a:solidFill>
+                  <a:srgbClr val="191C1E"/>
+                </a:solidFill>
+                <a:latin typeface="Plus Jakarta Sans"/>
+                <a:ea typeface="Plus Jakarta Sans"/>
+                <a:cs typeface="Plus Jakarta Sans"/>
+                <a:sym typeface="Plus Jakarta Sans"/>
+              </a:rPr>
+              <a:t>Em uso, fora dos recentes</a:t>
+            </a:r>
+            <a:endParaRPr b="0" i="0" spc="0" sz="1400" u="none" cap="none" strike="noStrike">
+              <a:solidFill>
+                <a:srgbClr val="000000"/>
+              </a:solidFill>
+              <a:latin typeface="Arial"/>
+              <a:ea typeface="Arial"/>
+              <a:cs typeface="Arial"/>
+              <a:sym typeface="Arial"/>
+            </a:endParaRPr>
+          </a:p>
+        </p:txBody>
+      </p:sp>
+      <p:sp>
+        <p:nvSpPr>
+          <p:cNvPr id="367" name="Google Shape;367;p13"/>
+          <p:cNvSpPr txBox="1"/>
+          <p:nvPr/>
+        </p:nvSpPr>
+        <p:spPr>
+          <a:xfrm>
+            <a:off x="1005840" y="5001768"/>
+            <a:ext cx="3931920" cy="548640"/>
+          </a:xfrm>
+          <a:prstGeom prst="rect">
+            <a:avLst/>
+          </a:prstGeom>
+          <a:noFill/>
+          <a:ln>
+            <a:noFill/>
+          </a:ln>
+        </p:spPr>
+        <p:txBody>
+          <a:bodyPr anchorCtr="0" anchor="ctr" bIns="0" lIns="0" spcFirstLastPara="1" rIns="0" wrap="square" tIns="0">
+            <a:spAutoFit/>
+          </a:bodyPr>
+          <a:lstStyle/>
+          <a:p>
+            <a:pPr indent="0" lvl="0" marL="0" marR="0" rtl="0" algn="l">
+              <a:lnSpc>
+                <a:spcPct val="110000"/>
+              </a:lnSpc>
+              <a:spcBef>
+                <a:spcPts val="0"/>
+              </a:spcBef>
+              <a:spcAft>
+                <a:spcPts val="0"/>
+              </a:spcAft>
+              <a:buClr>
+                <a:srgbClr val="000000"/>
+              </a:buClr>
+              <a:buSzPts val="1600"/>
+              <a:buFont typeface="Arial"/>
+              <a:buNone/>
+            </a:pPr>
+            <a:r>
+              <a:rPr b="0" i="0" lang="en-US" spc="0" sz="1600" u="none" cap="none" strike="noStrike">
+                <a:solidFill>
+                  <a:srgbClr val="191C1E"/>
+                </a:solidFill>
+                <a:latin typeface="Plus Jakarta Sans"/>
+                <a:ea typeface="Plus Jakarta Sans"/>
+                <a:cs typeface="Plus Jakarta Sans"/>
+                <a:sym typeface="Plus Jakarta Sans"/>
+              </a:rPr>
+              <a:t>Após reiniciar o aparelho</a:t>
+            </a:r>
+            <a:endParaRPr b="0" i="0" spc="0" sz="1400" u="none" cap="none" strike="noStrike">
+              <a:solidFill>
+                <a:srgbClr val="000000"/>
+              </a:solidFill>
+              <a:latin typeface="Arial"/>
+              <a:ea typeface="Arial"/>
+              <a:cs typeface="Arial"/>
+              <a:sym typeface="Arial"/>
+            </a:endParaRPr>
+          </a:p>
+        </p:txBody>
+      </p:sp>
+      <p:sp>
+        <p:nvSpPr>
+          <p:cNvPr id="368" name="Google Shape;368;p13"/>
+          <p:cNvSpPr txBox="1"/>
+          <p:nvPr/>
+        </p:nvSpPr>
+        <p:spPr>
+          <a:xfrm>
+            <a:off x="685800" y="6053328"/>
+            <a:ext cx="7315200" cy="274320"/>
+          </a:xfrm>
+          <a:prstGeom prst="rect">
+            <a:avLst/>
+          </a:prstGeom>
+          <a:noFill/>
+          <a:ln>
+            <a:noFill/>
+          </a:ln>
+        </p:spPr>
+        <p:txBody>
+          <a:bodyPr anchorCtr="0" anchor="t" bIns="0" lIns="0" spcFirstLastPara="1" rIns="0" wrap="square" tIns="0">
+            <a:spAutoFit/>
+          </a:bodyPr>
+          <a:lstStyle/>
+          <a:p>
+            <a:pPr indent="0" lvl="0" marL="0" marR="0" rtl="0" algn="l">
+              <a:lnSpc>
+                <a:spcPct val="110000"/>
+              </a:lnSpc>
+              <a:spcBef>
+                <a:spcPts val="0"/>
+              </a:spcBef>
+              <a:spcAft>
+                <a:spcPts val="0"/>
+              </a:spcAft>
+              <a:buClr>
+                <a:srgbClr val="000000"/>
+              </a:buClr>
+              <a:buSzPts val="1000"/>
+              <a:buFont typeface="Arial"/>
+              <a:buNone/>
+            </a:pPr>
+            <a:r>
+              <a:rPr b="0" i="0" lang="en-US" spc="0" sz="1000" u="none" cap="none" strike="noStrike">
+                <a:solidFill>
+                  <a:srgbClr val="545F73"/>
+                </a:solidFill>
+                <a:latin typeface="Plus Jakarta Sans"/>
+                <a:ea typeface="Plus Jakarta Sans"/>
+                <a:cs typeface="Plus Jakarta Sans"/>
+                <a:sym typeface="Plus Jakarta Sans"/>
+              </a:rPr>
+              <a:t>Fonte: seção 5.3 do TCC. Xiaomi Redmi Note 14 Pro 5G, Android 16.</a:t>
+            </a:r>
+            <a:endParaRPr b="0" i="0" spc="0" sz="1400" u="none" cap="none" strike="noStrike">
+              <a:solidFill>
+                <a:srgbClr val="000000"/>
+              </a:solidFill>
+              <a:latin typeface="Arial"/>
+              <a:ea typeface="Arial"/>
+              <a:cs typeface="Arial"/>
+              <a:sym typeface="Arial"/>
+            </a:endParaRPr>
+          </a:p>
+        </p:txBody>
+      </p:sp>
+      <p:sp>
+        <p:nvSpPr>
+          <p:cNvPr id="369" name="Google Shape;369;p13"/>
+          <p:cNvSpPr/>
+          <p:nvPr/>
+        </p:nvSpPr>
+        <p:spPr>
+          <a:xfrm>
+            <a:off x="7680960" y="1783080"/>
+            <a:ext cx="3822191" cy="1920240"/>
+          </a:xfrm>
+          <a:prstGeom prst="roundRect">
+            <a:avLst>
+              <a:gd fmla="val 6666" name="adj"/>
+            </a:avLst>
+          </a:prstGeom>
+          <a:solidFill>
+            <a:srgbClr val="FFFFFF"/>
+          </a:solidFill>
+          <a:ln>
+            <a:noFill/>
+          </a:ln>
+        </p:spPr>
+        <p:txBody>
+          <a:bodyPr anchorCtr="0" anchor="ctr" bIns="45700" lIns="91425" spcFirstLastPara="1" rIns="91425" wrap="square" tIns="45700">
+            <a:noAutofit/>
+          </a:bodyPr>
+          <a:lstStyle/>
+          <a:p>
+            <a:pPr indent="0" lvl="0" marL="0" marR="0" rtl="0" algn="l">
+              <a:lnSpc>
+                <a:spcPct val="100000"/>
+              </a:lnSpc>
+              <a:spcBef>
+                <a:spcPts val="0"/>
+              </a:spcBef>
+              <a:spcAft>
+                <a:spcPts val="0"/>
+              </a:spcAft>
+              <a:buClr>
+                <a:srgbClr val="000000"/>
+              </a:buClr>
+              <a:buSzPts val="1800"/>
+              <a:buFont typeface="Arial"/>
+              <a:buNone/>
+            </a:pPr>
+            <a:r>
+              <a:t/>
+            </a:r>
+            <a:endParaRPr b="0" i="0" spc="0" sz="1800" u="none" cap="none" strike="noStrike">
+              <a:solidFill>
+                <a:schemeClr val="dk1"/>
+              </a:solidFill>
+              <a:latin typeface="Calibri"/>
+              <a:ea typeface="Calibri"/>
+              <a:cs typeface="Calibri"/>
+              <a:sym typeface="Calibri"/>
+            </a:endParaRPr>
+          </a:p>
+        </p:txBody>
+      </p:sp>
+      <p:sp>
+        <p:nvSpPr>
+          <p:cNvPr id="370" name="Google Shape;370;p13"/>
+          <p:cNvSpPr txBox="1"/>
+          <p:nvPr/>
+        </p:nvSpPr>
+        <p:spPr>
+          <a:xfrm>
+            <a:off x="7946100" y="2163580"/>
+            <a:ext cx="3291900" cy="1262100"/>
+          </a:xfrm>
+          <a:prstGeom prst="rect">
+            <a:avLst/>
+          </a:prstGeom>
+          <a:noFill/>
+          <a:ln>
+            <a:noFill/>
+          </a:ln>
+        </p:spPr>
+        <p:txBody>
+          <a:bodyPr anchorCtr="0" anchor="ctr" bIns="0" lIns="0" spcFirstLastPara="1" rIns="0" wrap="square" tIns="0">
+            <a:spAutoFit/>
+          </a:bodyPr>
+          <a:lstStyle/>
+          <a:p>
+            <a:pPr indent="0" lvl="0" marL="0" marR="0" rtl="0" algn="l">
+              <a:lnSpc>
+                <a:spcPct val="110000"/>
+              </a:lnSpc>
+              <a:spcBef>
+                <a:spcPts val="0"/>
+              </a:spcBef>
+              <a:spcAft>
+                <a:spcPts val="0"/>
+              </a:spcAft>
+              <a:buClr>
+                <a:srgbClr val="000000"/>
+              </a:buClr>
+              <a:buSzPts val="1100"/>
+              <a:buFont typeface="Arial"/>
+              <a:buNone/>
+            </a:pPr>
+            <a:r>
+              <a:rPr b="1" i="0" lang="en-US" spc="200" sz="1100" u="none" cap="none" strike="noStrike">
+                <a:solidFill>
+                  <a:srgbClr val="11803E"/>
+                </a:solidFill>
+                <a:latin typeface="Plus Jakarta Sans"/>
+                <a:ea typeface="Plus Jakarta Sans"/>
+                <a:cs typeface="Plus Jakarta Sans"/>
+                <a:sym typeface="Plus Jakarta Sans"/>
+              </a:rPr>
+              <a:t>AJUSTE DE PRIVACIDADE</a:t>
+            </a:r>
+            <a:endParaRPr b="1" i="0" spc="200" sz="1100" u="none" cap="none" strike="noStrike">
+              <a:solidFill>
+                <a:srgbClr val="11803E"/>
               </a:solidFill>
               <a:latin typeface="Plus Jakarta Sans"/>
               <a:ea typeface="Plus Jakarta Sans"/>
@@ -21802,41 +23713,121 @@
           <a:p>
             <a:pPr indent="0" lvl="0" marL="0" marR="0" rtl="0" algn="l">
               <a:lnSpc>
-                <a:spcPct val="100000"/>
-              </a:lnSpc>
-              <a:spcBef>
-                <a:spcPts val="400"/>
-              </a:spcBef>
-              <a:spcAft>
-                <a:spcPts val="0"/>
-              </a:spcAft>
-              <a:buClr>
-                <a:srgbClr val="000000"/>
-              </a:buClr>
-              <a:buSzPts val="1400"/>
-              <a:buFont typeface="Arial"/>
-              <a:buNone/>
-            </a:pPr>
-            <a:r>
-              <a:rPr b="0" i="0" lang="en-US" spc="0" sz="1400" u="none" cap="none" strike="noStrike">
-                <a:solidFill>
-                  <a:srgbClr val="545F73"/>
+                <a:spcPct val="110000"/>
+              </a:lnSpc>
+              <a:spcBef>
+                <a:spcPts val="0"/>
+              </a:spcBef>
+              <a:spcAft>
+                <a:spcPts val="0"/>
+              </a:spcAft>
+              <a:buClr>
+                <a:srgbClr val="000000"/>
+              </a:buClr>
+              <a:buSzPts val="1100"/>
+              <a:buFont typeface="Arial"/>
+              <a:buNone/>
+            </a:pPr>
+            <a:r>
+              <a:rPr b="1" i="0" lang="en-US" spc="200" sz="800" u="none" cap="none" strike="noStrike">
+                <a:solidFill>
+                  <a:srgbClr val="11803E"/>
                 </a:solidFill>
                 <a:latin typeface="Plus Jakarta Sans"/>
                 <a:ea typeface="Plus Jakarta Sans"/>
                 <a:cs typeface="Plus Jakarta Sans"/>
                 <a:sym typeface="Plus Jakarta Sans"/>
               </a:rPr>
-              <a:t>app nos recentes ou não</a:t>
-            </a:r>
-            <a:endParaRPr b="0" i="0" spc="0" sz="1400" u="none" cap="none" strike="noStrike">
+              <a:t/>
+            </a:r>
+            <a:endParaRPr b="1" i="0" spc="200" sz="1100" u="none" cap="none" strike="noStrike">
               <a:solidFill>
-                <a:srgbClr val="000000"/>
+                <a:srgbClr val="11803E"/>
               </a:solidFill>
-              <a:latin typeface="Arial"/>
-              <a:ea typeface="Arial"/>
-              <a:cs typeface="Arial"/>
-              <a:sym typeface="Arial"/>
+              <a:latin typeface="Plus Jakarta Sans"/>
+              <a:ea typeface="Plus Jakarta Sans"/>
+              <a:cs typeface="Plus Jakarta Sans"/>
+              <a:sym typeface="Plus Jakarta Sans"/>
+            </a:endParaRPr>
+          </a:p>
+          <a:p>
+            <a:pPr indent="0" lvl="0" marL="0" marR="0" rtl="0" algn="l">
+              <a:lnSpc>
+                <a:spcPct val="110000"/>
+              </a:lnSpc>
+              <a:spcBef>
+                <a:spcPts val="0"/>
+              </a:spcBef>
+              <a:spcAft>
+                <a:spcPts val="0"/>
+              </a:spcAft>
+              <a:buClr>
+                <a:srgbClr val="000000"/>
+              </a:buClr>
+              <a:buSzPts val="1100"/>
+              <a:buFont typeface="Arial"/>
+              <a:buNone/>
+            </a:pPr>
+            <a:r>
+              <a:rPr b="1" i="0" lang="en-US" spc="0" sz="1700" u="none" cap="none" strike="noStrike">
+                <a:solidFill>
+                  <a:srgbClr val="191C1E"/>
+                </a:solidFill>
+                <a:latin typeface="Plus Jakarta Sans"/>
+                <a:ea typeface="Plus Jakarta Sans"/>
+                <a:cs typeface="Plus Jakarta Sans"/>
+                <a:sym typeface="Plus Jakarta Sans"/>
+              </a:rPr>
+              <a:t>Fechar o alarme devolve o bloqueio</a:t>
+            </a:r>
+            <a:endParaRPr b="1" i="0" spc="200" sz="1100" u="none" cap="none" strike="noStrike">
+              <a:solidFill>
+                <a:srgbClr val="11803E"/>
+              </a:solidFill>
+              <a:latin typeface="Plus Jakarta Sans"/>
+              <a:ea typeface="Plus Jakarta Sans"/>
+              <a:cs typeface="Plus Jakarta Sans"/>
+              <a:sym typeface="Plus Jakarta Sans"/>
+            </a:endParaRPr>
+          </a:p>
+          <a:p>
+            <a:pPr indent="0" lvl="0" marL="0" marR="0" rtl="0" algn="l">
+              <a:lnSpc>
+                <a:spcPct val="110000"/>
+              </a:lnSpc>
+              <a:spcBef>
+                <a:spcPts val="0"/>
+              </a:spcBef>
+              <a:spcAft>
+                <a:spcPts val="0"/>
+              </a:spcAft>
+              <a:buClr>
+                <a:srgbClr val="000000"/>
+              </a:buClr>
+              <a:buSzPts val="1100"/>
+              <a:buFont typeface="Arial"/>
+              <a:buNone/>
+            </a:pPr>
+            <a:r>
+              <a:rPr b="0" i="0" lang="en-US" spc="0" sz="1400" u="none" cap="none" strike="noStrike">
+                <a:solidFill>
+                  <a:srgbClr val="545F73"/>
+                </a:solidFill>
+                <a:latin typeface="Plus Jakarta Sans"/>
+                <a:ea typeface="Plus Jakarta Sans"/>
+                <a:cs typeface="Plus Jakarta Sans"/>
+                <a:sym typeface="Plus Jakarta Sans"/>
+              </a:rPr>
+              <a:t>sem expor o resto do app</a:t>
+            </a:r>
+            <a:endParaRPr b="1" i="0" spc="200" sz="1100" u="none" cap="none" strike="noStrike">
+              <a:solidFill>
+                <a:srgbClr val="11803E"/>
+              </a:solidFill>
+              <a:latin typeface="Plus Jakarta Sans"/>
+              <a:ea typeface="Plus Jakarta Sans"/>
+              <a:cs typeface="Plus Jakarta Sans"/>
+              <a:sym typeface="Plus Jakarta Sans"/>
             </a:endParaRPr>
           </a:p>
         </p:txBody>
@@ -22031,7 +24022,7 @@
                 <a:cs typeface="Plus Jakarta Sans"/>
                 <a:sym typeface="Plus Jakarta Sans"/>
               </a:rPr>
-              <a:t>Após reiniciar, o alarme esperou o desbloqueio</a:t>
+              <a:t>Após reiniciar, esperou o desbloqueio</a:t>
             </a:r>
             <a:endParaRPr b="0" i="0" spc="0" sz="1400" u="none" cap="none" strike="noStrike">
               <a:solidFill>
@@ -22071,31 +24062,7 @@
                 <a:cs typeface="Plus Jakarta Sans"/>
                 <a:sym typeface="Plus Jakarta Sans"/>
               </a:rPr>
-              <a:t>Restrição de </a:t>
-            </a:r>
-            <a:r>
-              <a:rPr b="0" i="1" lang="en-US" spc="0" sz="1400" u="none" cap="none" strike="noStrike">
-                <a:solidFill>
-                  <a:srgbClr val="5C4A0F"/>
-                </a:solidFill>
-                <a:latin typeface="Plus Jakarta Sans"/>
-                <a:ea typeface="Plus Jakarta Sans"/>
-                <a:cs typeface="Plus Jakarta Sans"/>
-                <a:sym typeface="Plus Jakarta Sans"/>
-              </a:rPr>
-              <a:t>Autostart</a:t>
-            </a:r>
-            <a:r>
-              <a:rPr b="0" i="0" lang="en-US" spc="0" sz="1400" u="none" cap="none" strike="noStrike">
-                <a:solidFill>
-                  <a:srgbClr val="5C4A0F"/>
-                </a:solidFill>
-                <a:latin typeface="Plus Jakarta Sans"/>
-                <a:ea typeface="Plus Jakarta Sans"/>
-                <a:cs typeface="Plus Jakarta Sans"/>
-                <a:sym typeface="Plus Jakarta Sans"/>
-              </a:rPr>
-              <a:t> do fabricante</a:t>
+              <a:t>o app orienta liberar o início automático</a:t>
             </a:r>
             <a:endParaRPr b="0" i="0" spc="0" sz="1400" u="none" cap="none" strike="noStrike">
               <a:solidFill>
@@ -22187,7 +24154,7 @@
             </a:avLst>
           </a:prstGeom>
           <a:solidFill>
-            <a:srgbClr val="E3F6EA"/>
+            <a:srgbClr val="FDF3C4"/>
           </a:solidFill>
           <a:ln>
             <a:noFill/>
@@ -22469,14 +24436,14 @@
             <a:r>
               <a:rPr b="1" i="0" lang="en-US" spc="0" sz="1200" u="none" cap="none" strike="noStrike">
                 <a:solidFill>
-                  <a:srgbClr val="11803E"/>
+                  <a:srgbClr val="5C4A0F"/>
                 </a:solidFill>
                 <a:latin typeface="Plus Jakarta Sans"/>
                 <a:ea typeface="Plus Jakarta Sans"/>
                 <a:cs typeface="Plus Jakarta Sans"/>
                 <a:sym typeface="Plus Jakarta Sans"/>
               </a:rPr>
-              <a:t>Aprovado</a:t>
+              <a:t>Com ressalva</a:t>
             </a:r>
             <a:endParaRPr b="0" i="0" spc="0" sz="1400" u="none" cap="none" strike="noStrike">
               <a:solidFill>
@@ -22498,7 +24465,7 @@
 </p:sld>
 </file>
 
-<file path=ppt/slides/slide14.xml><?xml version="1.0" encoding="utf-8"?>
+<file path=ppt/slides/slide15.xml><?xml version="1.0" encoding="utf-8"?>
 <p:sld xmlns:a="http://schemas.openxmlformats.org/drawingml/2006/main" xmlns:r="http://schemas.openxmlformats.org/officeDocument/2006/relationships" xmlns:mc="http://schemas.openxmlformats.org/markup-compatibility/2006" xmlns:mv="urn:schemas-microsoft-com:mac:vml" xmlns:p="http://schemas.openxmlformats.org/presentationml/2006/main" xmlns:c="http://schemas.openxmlformats.org/drawingml/2006/chart" xmlns:dgm="http://schemas.openxmlformats.org/drawingml/2006/diagram" xmlns:o="urn:schemas-microsoft-com:office:office" xmlns:v="urn:schemas-microsoft-com:vml" xmlns:pvml="urn:schemas-microsoft-com:office:powerpoint" xmlns:com="http://schemas.openxmlformats.org/drawingml/2006/compatibility" xmlns:p14="http://schemas.microsoft.com/office/powerpoint/2010/main" xmlns:p15="http://schemas.microsoft.com/office/powerpoint/2012/main" xmlns:ahyp="http://schemas.microsoft.com/office/drawing/2018/hyperlinkcolor">
   <p:cSld>
     <p:bg>
@@ -22772,7 +24739,7 @@
                 <a:cs typeface="Plus Jakarta Sans"/>
                 <a:sym typeface="Plus Jakarta Sans"/>
               </a:rPr>
-              <a:t>14</a:t>
+              <a:t>15</a:t>
             </a:r>
             <a:endParaRPr b="0" i="0" spc="0" sz="1400" u="none" cap="none" strike="noStrike">
               <a:solidFill>
@@ -23729,7 +25696,7 @@
 </p:sld>
 </file>
 
-<file path=ppt/slides/slide15.xml><?xml version="1.0" encoding="utf-8"?>
+<file path=ppt/slides/slide16.xml><?xml version="1.0" encoding="utf-8"?>
 <p:sld xmlns:a="http://schemas.openxmlformats.org/drawingml/2006/main" xmlns:r="http://schemas.openxmlformats.org/officeDocument/2006/relationships" xmlns:mc="http://schemas.openxmlformats.org/markup-compatibility/2006" xmlns:mv="urn:schemas-microsoft-com:mac:vml" xmlns:p="http://schemas.openxmlformats.org/presentationml/2006/main" xmlns:c="http://schemas.openxmlformats.org/drawingml/2006/chart" xmlns:dgm="http://schemas.openxmlformats.org/drawingml/2006/diagram" xmlns:o="urn:schemas-microsoft-com:office:office" xmlns:v="urn:schemas-microsoft-com:vml" xmlns:pvml="urn:schemas-microsoft-com:office:powerpoint" xmlns:com="http://schemas.openxmlformats.org/drawingml/2006/compatibility" xmlns:p14="http://schemas.microsoft.com/office/powerpoint/2010/main" xmlns:p15="http://schemas.microsoft.com/office/powerpoint/2012/main" xmlns:ahyp="http://schemas.microsoft.com/office/drawing/2018/hyperlinkcolor">
   <p:cSld>
     <p:bg>
@@ -24003,7 +25970,7 @@
                 <a:cs typeface="Plus Jakarta Sans"/>
                 <a:sym typeface="Plus Jakarta Sans"/>
               </a:rPr>
-              <a:t>15</a:t>
+              <a:t>16</a:t>
             </a:r>
             <a:endParaRPr b="0" i="0" spc="0" sz="1400" u="none" cap="none" strike="noStrike">
               <a:solidFill>
@@ -25308,7 +27275,7 @@
 </p:sld>
 </file>
 
-<file path=ppt/slides/slide16.xml><?xml version="1.0" encoding="utf-8"?>
+<file path=ppt/slides/slide17.xml><?xml version="1.0" encoding="utf-8"?>
 <p:sld xmlns:a="http://schemas.openxmlformats.org/drawingml/2006/main" xmlns:r="http://schemas.openxmlformats.org/officeDocument/2006/relationships" xmlns:mc="http://schemas.openxmlformats.org/markup-compatibility/2006" xmlns:mv="urn:schemas-microsoft-com:mac:vml" xmlns:p="http://schemas.openxmlformats.org/presentationml/2006/main" xmlns:c="http://schemas.openxmlformats.org/drawingml/2006/chart" xmlns:dgm="http://schemas.openxmlformats.org/drawingml/2006/diagram" xmlns:o="urn:schemas-microsoft-com:office:office" xmlns:v="urn:schemas-microsoft-com:vml" xmlns:pvml="urn:schemas-microsoft-com:office:powerpoint" xmlns:com="http://schemas.openxmlformats.org/drawingml/2006/compatibility" xmlns:p14="http://schemas.microsoft.com/office/powerpoint/2010/main" xmlns:p15="http://schemas.microsoft.com/office/powerpoint/2012/main" xmlns:ahyp="http://schemas.microsoft.com/office/drawing/2018/hyperlinkcolor">
   <p:cSld>
     <p:bg>
@@ -25516,7 +27483,7 @@
                 <a:cs typeface="Plus Jakarta Sans"/>
                 <a:sym typeface="Plus Jakarta Sans"/>
               </a:rPr>
-              <a:t>16</a:t>
+              <a:t>17</a:t>
             </a:r>
             <a:endParaRPr b="0" i="0" spc="0" sz="1400" u="none" cap="none" strike="noStrike">
               <a:solidFill>
@@ -26334,7 +28301,7 @@
 </p:sld>
 </file>
 
-<file path=ppt/slides/slide17.xml><?xml version="1.0" encoding="utf-8"?>
+<file path=ppt/slides/slide18.xml><?xml version="1.0" encoding="utf-8"?>
 <p:sld xmlns:a="http://schemas.openxmlformats.org/drawingml/2006/main" xmlns:r="http://schemas.openxmlformats.org/officeDocument/2006/relationships" xmlns:mc="http://schemas.openxmlformats.org/markup-compatibility/2006" xmlns:mv="urn:schemas-microsoft-com:mac:vml" xmlns:p="http://schemas.openxmlformats.org/presentationml/2006/main" xmlns:c="http://schemas.openxmlformats.org/drawingml/2006/chart" xmlns:dgm="http://schemas.openxmlformats.org/drawingml/2006/diagram" xmlns:o="urn:schemas-microsoft-com:office:office" xmlns:v="urn:schemas-microsoft-com:vml" xmlns:pvml="urn:schemas-microsoft-com:office:powerpoint" xmlns:com="http://schemas.openxmlformats.org/drawingml/2006/compatibility" xmlns:p14="http://schemas.microsoft.com/office/powerpoint/2010/main" xmlns:p15="http://schemas.microsoft.com/office/powerpoint/2012/main" xmlns:ahyp="http://schemas.microsoft.com/office/drawing/2018/hyperlinkcolor">
   <p:cSld>
     <p:bg>
@@ -37201,7 +39168,7 @@
                 <a:cs typeface="Plus Jakarta Sans"/>
                 <a:sym typeface="Plus Jakarta Sans"/>
               </a:rPr>
-              <a:t>Fonte: elaborado pelo autor (2026), a partir da seção 4.4.</a:t>
+              <a:t>Fonte: elaborado pelo autor (2026), com base em Martin (2019) e na seção 4.4 do TCC.</a:t>
             </a:r>
             <a:endParaRPr b="0" i="0" spc="0" sz="1400" u="none" cap="none" strike="noStrike">
               <a:solidFill>

</xml_diff>

<commit_message>
docs(tcc): roteiro v5 alinhado aos 18 slides, notas de requisitos, alarme e demo sincronizadas
</commit_message>
<xml_diff>
--- a/docs/tcc/apresentacao-mapill.pptx
+++ b/docs/tcc/apresentacao-mapill.pptx
@@ -1315,282 +1315,66 @@
           </a:bodyPr>
           <a:lstStyle/>
           <a:p>
-            <a:pPr indent="0" lvl="0" marL="0" rtl="0" algn="l">
-              <a:lnSpc>
-                <a:spcPct val="100000"/>
-              </a:lnSpc>
-              <a:spcBef>
-                <a:spcPts val="0"/>
-              </a:spcBef>
-              <a:spcAft>
-                <a:spcPts val="0"/>
-              </a:spcAft>
-              <a:buSzPts val="1100"/>
-              <a:buNone/>
-            </a:pPr>
-            <a:r>
-              <a:rPr lang="en-US"/>
-              <a:t>[8 min]</a:t>
-            </a:r>
-            <a:endParaRPr/>
-          </a:p>
-          <a:p>
-            <a:pPr indent="0" lvl="0" marL="0" rtl="0" algn="l">
-              <a:lnSpc>
-                <a:spcPct val="100000"/>
-              </a:lnSpc>
-              <a:spcBef>
-                <a:spcPts val="0"/>
-              </a:spcBef>
-              <a:spcAft>
-                <a:spcPts val="0"/>
-              </a:spcAft>
-              <a:buSzPts val="1100"/>
-              <a:buNone/>
-            </a:pPr>
-            <a:r>
-              <a:rPr lang="en-US"/>
+            <a:r>
+              <a:t>[7 min 30 s]</a:t>
+            </a:r>
+          </a:p>
+          <a:p>
+            <a:r>
               <a:t>Agora vou mostrar o aplicativo funcionando no meu celular.</a:t>
             </a:r>
-            <a:endParaRPr/>
-          </a:p>
-          <a:p>
-            <a:pPr indent="0" lvl="0" marL="0" rtl="0" algn="l">
-              <a:lnSpc>
-                <a:spcPct val="100000"/>
-              </a:lnSpc>
-              <a:spcBef>
-                <a:spcPts val="0"/>
-              </a:spcBef>
-              <a:spcAft>
-                <a:spcPts val="0"/>
-              </a:spcAft>
-              <a:buSzPts val="1100"/>
-              <a:buNone/>
-            </a:pPr>
-            <a:r>
-              <a:t/>
-            </a:r>
-            <a:endParaRPr/>
-          </a:p>
-          <a:p>
-            <a:pPr indent="0" lvl="0" marL="0" rtl="0" algn="l">
-              <a:lnSpc>
-                <a:spcPct val="100000"/>
-              </a:lnSpc>
-              <a:spcBef>
-                <a:spcPts val="0"/>
-              </a:spcBef>
-              <a:spcAft>
-                <a:spcPts val="0"/>
-              </a:spcAft>
-              <a:buSzPts val="1100"/>
-              <a:buNone/>
-            </a:pPr>
-            <a:r>
-              <a:rPr lang="en-US"/>
+          </a:p>
+          <a:p/>
+          <a:p>
+            <a:r>
               <a:t>Caminho (detalhe no roteiro):</a:t>
             </a:r>
-            <a:endParaRPr/>
-          </a:p>
-          <a:p>
-            <a:pPr indent="0" lvl="0" marL="0" rtl="0" algn="l">
-              <a:lnSpc>
-                <a:spcPct val="100000"/>
-              </a:lnSpc>
-              <a:spcBef>
-                <a:spcPts val="0"/>
-              </a:spcBef>
-              <a:spcAft>
-                <a:spcPts val="0"/>
-              </a:spcAft>
-              <a:buSzPts val="1100"/>
-              <a:buNone/>
-            </a:pPr>
-            <a:r>
-              <a:rPr lang="en-US"/>
+          </a:p>
+          <a:p>
+            <a:r>
               <a:t>a. Cadastro por código de barras (1 min 30 s)</a:t>
             </a:r>
-            <a:endParaRPr/>
-          </a:p>
-          <a:p>
-            <a:pPr indent="0" lvl="0" marL="0" rtl="0" algn="l">
-              <a:lnSpc>
-                <a:spcPct val="100000"/>
-              </a:lnSpc>
-              <a:spcBef>
-                <a:spcPts val="0"/>
-              </a:spcBef>
-              <a:spcAft>
-                <a:spcPts val="0"/>
-              </a:spcAft>
-              <a:buSzPts val="1100"/>
-              <a:buNone/>
-            </a:pPr>
-            <a:r>
-              <a:rPr lang="en-US"/>
+          </a:p>
+          <a:p>
+            <a:r>
               <a:t>b. Tela inicial (45 s)</a:t>
             </a:r>
-            <a:endParaRPr/>
-          </a:p>
-          <a:p>
-            <a:pPr indent="0" lvl="0" marL="0" rtl="0" algn="l">
-              <a:lnSpc>
-                <a:spcPct val="100000"/>
-              </a:lnSpc>
-              <a:spcBef>
-                <a:spcPts val="0"/>
-              </a:spcBef>
-              <a:spcAft>
-                <a:spcPts val="0"/>
-              </a:spcAft>
-              <a:buSzPts val="1100"/>
-              <a:buNone/>
-            </a:pPr>
-            <a:r>
-              <a:rPr lang="en-US"/>
+          </a:p>
+          <a:p>
+            <a:r>
               <a:t>c. Alarme com o celular bloqueado (2 min)</a:t>
             </a:r>
-            <a:endParaRPr/>
-          </a:p>
-          <a:p>
-            <a:pPr indent="0" lvl="0" marL="0" rtl="0" algn="l">
-              <a:lnSpc>
-                <a:spcPct val="100000"/>
-              </a:lnSpc>
-              <a:spcBef>
-                <a:spcPts val="0"/>
-              </a:spcBef>
-              <a:spcAft>
-                <a:spcPts val="0"/>
-              </a:spcAft>
-              <a:buSzPts val="1100"/>
-              <a:buNone/>
-            </a:pPr>
-            <a:r>
-              <a:rPr lang="en-US"/>
-              <a:t>d. Adesão, calendário e correção (1 min 30 s)</a:t>
-            </a:r>
-            <a:endParaRPr/>
-          </a:p>
-          <a:p>
-            <a:pPr indent="0" lvl="0" marL="0" rtl="0" algn="l">
-              <a:lnSpc>
-                <a:spcPct val="100000"/>
-              </a:lnSpc>
-              <a:spcBef>
-                <a:spcPts val="0"/>
-              </a:spcBef>
-              <a:spcAft>
-                <a:spcPts val="0"/>
-              </a:spcAft>
-              <a:buSzPts val="1100"/>
-              <a:buNone/>
-            </a:pPr>
-            <a:r>
-              <a:rPr lang="en-US"/>
+          </a:p>
+          <a:p>
+            <a:r>
+              <a:t>d. Adesão e calendário (1 min)</a:t>
+            </a:r>
+          </a:p>
+          <a:p>
+            <a:r>
               <a:t>e. Relatório em PDF (1 min)</a:t>
             </a:r>
-            <a:endParaRPr/>
-          </a:p>
-          <a:p>
-            <a:pPr indent="0" lvl="0" marL="0" rtl="0" algn="l">
-              <a:lnSpc>
-                <a:spcPct val="100000"/>
-              </a:lnSpc>
-              <a:spcBef>
-                <a:spcPts val="0"/>
-              </a:spcBef>
-              <a:spcAft>
-                <a:spcPts val="0"/>
-              </a:spcAft>
-              <a:buSzPts val="1100"/>
-              <a:buNone/>
-            </a:pPr>
-            <a:r>
-              <a:rPr lang="en-US"/>
+          </a:p>
+          <a:p>
+            <a:r>
               <a:t>f. Temas e cores (45 s)</a:t>
             </a:r>
-            <a:endParaRPr/>
-          </a:p>
-          <a:p>
-            <a:pPr indent="0" lvl="0" marL="0" rtl="0" algn="l">
-              <a:lnSpc>
-                <a:spcPct val="100000"/>
-              </a:lnSpc>
-              <a:spcBef>
-                <a:spcPts val="0"/>
-              </a:spcBef>
-              <a:spcAft>
-                <a:spcPts val="0"/>
-              </a:spcAft>
-              <a:buSzPts val="1100"/>
-              <a:buNone/>
-            </a:pPr>
-            <a:r>
-              <a:rPr lang="en-US"/>
+          </a:p>
+          <a:p>
+            <a:r>
               <a:t>Folga de 30 s.</a:t>
             </a:r>
-            <a:endParaRPr/>
-          </a:p>
-          <a:p>
-            <a:pPr indent="0" lvl="0" marL="0" rtl="0" algn="l">
-              <a:lnSpc>
-                <a:spcPct val="100000"/>
-              </a:lnSpc>
-              <a:spcBef>
-                <a:spcPts val="0"/>
-              </a:spcBef>
-              <a:spcAft>
-                <a:spcPts val="0"/>
-              </a:spcAft>
-              <a:buSzPts val="1100"/>
-              <a:buNone/>
-            </a:pPr>
-            <a:r>
-              <a:t/>
-            </a:r>
-            <a:endParaRPr/>
-          </a:p>
-          <a:p>
-            <a:pPr indent="0" lvl="0" marL="0" rtl="0" algn="l">
-              <a:lnSpc>
-                <a:spcPct val="100000"/>
-              </a:lnSpc>
-              <a:spcBef>
-                <a:spcPts val="0"/>
-              </a:spcBef>
-              <a:spcAft>
-                <a:spcPts val="0"/>
-              </a:spcAft>
-              <a:buSzPts val="1100"/>
-              <a:buNone/>
-            </a:pPr>
-            <a:r>
-              <a:rPr lang="en-US"/>
-              <a:t>Se o espelhamento falhar, abrir o vídeo reserva no trecho correspondente. Se tudo falhar, narrar a partir das telas deste slide.</a:t>
-            </a:r>
-            <a:endParaRPr/>
-          </a:p>
-          <a:p>
-            <a:pPr indent="0" lvl="0" marL="0" rtl="0" algn="l">
-              <a:lnSpc>
-                <a:spcPct val="100000"/>
-              </a:lnSpc>
-              <a:spcBef>
-                <a:spcPts val="0"/>
-              </a:spcBef>
-              <a:spcAft>
-                <a:spcPts val="0"/>
-              </a:spcAft>
-              <a:buSzPts val="1100"/>
-              <a:buNone/>
-            </a:pPr>
-            <a:r>
-              <a:rPr lang="en-US"/>
-              <a:t>Se atrasar, cortar nesta ordem: f, depois e, depois a correção em d.</a:t>
-            </a:r>
-            <a:endParaRPr/>
+          </a:p>
+          <a:p/>
+          <a:p>
+            <a:r>
+              <a:t>Se o espelhamento falhar, ir para o slide 12 e rodar o vídeo no trecho correspondente. Se tudo falhar, narrar a partir das telas do slide 11.</a:t>
+            </a:r>
+          </a:p>
+          <a:p>
+            <a:r>
+              <a:t>Se atrasar, cortar nesta ordem: f, depois e.</a:t>
+            </a:r>
           </a:p>
         </p:txBody>
       </p:sp>
@@ -1744,282 +1528,66 @@
           </a:bodyPr>
           <a:lstStyle/>
           <a:p>
-            <a:pPr indent="0" lvl="0" marL="0" rtl="0" algn="l">
-              <a:lnSpc>
-                <a:spcPct val="100000"/>
-              </a:lnSpc>
-              <a:spcBef>
-                <a:spcPts val="0"/>
-              </a:spcBef>
-              <a:spcAft>
-                <a:spcPts val="0"/>
-              </a:spcAft>
-              <a:buSzPts val="1100"/>
-              <a:buNone/>
-            </a:pPr>
-            <a:r>
-              <a:rPr lang="en-US"/>
-              <a:t>[8 min]</a:t>
-            </a:r>
-            <a:endParaRPr/>
-          </a:p>
-          <a:p>
-            <a:pPr indent="0" lvl="0" marL="0" rtl="0" algn="l">
-              <a:lnSpc>
-                <a:spcPct val="100000"/>
-              </a:lnSpc>
-              <a:spcBef>
-                <a:spcPts val="0"/>
-              </a:spcBef>
-              <a:spcAft>
-                <a:spcPts val="0"/>
-              </a:spcAft>
-              <a:buSzPts val="1100"/>
-              <a:buNone/>
-            </a:pPr>
-            <a:r>
-              <a:rPr lang="en-US"/>
+            <a:r>
+              <a:t>[só se o espelhamento falhar]</a:t>
+            </a:r>
+          </a:p>
+          <a:p>
+            <a:r>
               <a:t>Agora vou mostrar o aplicativo funcionando no meu celular.</a:t>
             </a:r>
-            <a:endParaRPr/>
-          </a:p>
-          <a:p>
-            <a:pPr indent="0" lvl="0" marL="0" rtl="0" algn="l">
-              <a:lnSpc>
-                <a:spcPct val="100000"/>
-              </a:lnSpc>
-              <a:spcBef>
-                <a:spcPts val="0"/>
-              </a:spcBef>
-              <a:spcAft>
-                <a:spcPts val="0"/>
-              </a:spcAft>
-              <a:buSzPts val="1100"/>
-              <a:buNone/>
-            </a:pPr>
-            <a:r>
-              <a:t/>
-            </a:r>
-            <a:endParaRPr/>
-          </a:p>
-          <a:p>
-            <a:pPr indent="0" lvl="0" marL="0" rtl="0" algn="l">
-              <a:lnSpc>
-                <a:spcPct val="100000"/>
-              </a:lnSpc>
-              <a:spcBef>
-                <a:spcPts val="0"/>
-              </a:spcBef>
-              <a:spcAft>
-                <a:spcPts val="0"/>
-              </a:spcAft>
-              <a:buSzPts val="1100"/>
-              <a:buNone/>
-            </a:pPr>
-            <a:r>
-              <a:rPr lang="en-US"/>
+          </a:p>
+          <a:p/>
+          <a:p>
+            <a:r>
               <a:t>Caminho (detalhe no roteiro):</a:t>
             </a:r>
-            <a:endParaRPr/>
-          </a:p>
-          <a:p>
-            <a:pPr indent="0" lvl="0" marL="0" rtl="0" algn="l">
-              <a:lnSpc>
-                <a:spcPct val="100000"/>
-              </a:lnSpc>
-              <a:spcBef>
-                <a:spcPts val="0"/>
-              </a:spcBef>
-              <a:spcAft>
-                <a:spcPts val="0"/>
-              </a:spcAft>
-              <a:buSzPts val="1100"/>
-              <a:buNone/>
-            </a:pPr>
-            <a:r>
-              <a:rPr lang="en-US"/>
+          </a:p>
+          <a:p>
+            <a:r>
               <a:t>a. Cadastro por código de barras (1 min 30 s)</a:t>
             </a:r>
-            <a:endParaRPr/>
-          </a:p>
-          <a:p>
-            <a:pPr indent="0" lvl="0" marL="0" rtl="0" algn="l">
-              <a:lnSpc>
-                <a:spcPct val="100000"/>
-              </a:lnSpc>
-              <a:spcBef>
-                <a:spcPts val="0"/>
-              </a:spcBef>
-              <a:spcAft>
-                <a:spcPts val="0"/>
-              </a:spcAft>
-              <a:buSzPts val="1100"/>
-              <a:buNone/>
-            </a:pPr>
-            <a:r>
-              <a:rPr lang="en-US"/>
+          </a:p>
+          <a:p>
+            <a:r>
               <a:t>b. Tela inicial (45 s)</a:t>
             </a:r>
-            <a:endParaRPr/>
-          </a:p>
-          <a:p>
-            <a:pPr indent="0" lvl="0" marL="0" rtl="0" algn="l">
-              <a:lnSpc>
-                <a:spcPct val="100000"/>
-              </a:lnSpc>
-              <a:spcBef>
-                <a:spcPts val="0"/>
-              </a:spcBef>
-              <a:spcAft>
-                <a:spcPts val="0"/>
-              </a:spcAft>
-              <a:buSzPts val="1100"/>
-              <a:buNone/>
-            </a:pPr>
-            <a:r>
-              <a:rPr lang="en-US"/>
+          </a:p>
+          <a:p>
+            <a:r>
               <a:t>c. Alarme com o celular bloqueado (2 min)</a:t>
             </a:r>
-            <a:endParaRPr/>
-          </a:p>
-          <a:p>
-            <a:pPr indent="0" lvl="0" marL="0" rtl="0" algn="l">
-              <a:lnSpc>
-                <a:spcPct val="100000"/>
-              </a:lnSpc>
-              <a:spcBef>
-                <a:spcPts val="0"/>
-              </a:spcBef>
-              <a:spcAft>
-                <a:spcPts val="0"/>
-              </a:spcAft>
-              <a:buSzPts val="1100"/>
-              <a:buNone/>
-            </a:pPr>
-            <a:r>
-              <a:rPr lang="en-US"/>
-              <a:t>d. Adesão, calendário e correção (1 min 30 s)</a:t>
-            </a:r>
-            <a:endParaRPr/>
-          </a:p>
-          <a:p>
-            <a:pPr indent="0" lvl="0" marL="0" rtl="0" algn="l">
-              <a:lnSpc>
-                <a:spcPct val="100000"/>
-              </a:lnSpc>
-              <a:spcBef>
-                <a:spcPts val="0"/>
-              </a:spcBef>
-              <a:spcAft>
-                <a:spcPts val="0"/>
-              </a:spcAft>
-              <a:buSzPts val="1100"/>
-              <a:buNone/>
-            </a:pPr>
-            <a:r>
-              <a:rPr lang="en-US"/>
+          </a:p>
+          <a:p>
+            <a:r>
+              <a:t>d. Adesão e calendário (1 min)</a:t>
+            </a:r>
+          </a:p>
+          <a:p>
+            <a:r>
               <a:t>e. Relatório em PDF (1 min)</a:t>
             </a:r>
-            <a:endParaRPr/>
-          </a:p>
-          <a:p>
-            <a:pPr indent="0" lvl="0" marL="0" rtl="0" algn="l">
-              <a:lnSpc>
-                <a:spcPct val="100000"/>
-              </a:lnSpc>
-              <a:spcBef>
-                <a:spcPts val="0"/>
-              </a:spcBef>
-              <a:spcAft>
-                <a:spcPts val="0"/>
-              </a:spcAft>
-              <a:buSzPts val="1100"/>
-              <a:buNone/>
-            </a:pPr>
-            <a:r>
-              <a:rPr lang="en-US"/>
+          </a:p>
+          <a:p>
+            <a:r>
               <a:t>f. Temas e cores (45 s)</a:t>
             </a:r>
-            <a:endParaRPr/>
-          </a:p>
-          <a:p>
-            <a:pPr indent="0" lvl="0" marL="0" rtl="0" algn="l">
-              <a:lnSpc>
-                <a:spcPct val="100000"/>
-              </a:lnSpc>
-              <a:spcBef>
-                <a:spcPts val="0"/>
-              </a:spcBef>
-              <a:spcAft>
-                <a:spcPts val="0"/>
-              </a:spcAft>
-              <a:buSzPts val="1100"/>
-              <a:buNone/>
-            </a:pPr>
-            <a:r>
-              <a:rPr lang="en-US"/>
+          </a:p>
+          <a:p>
+            <a:r>
               <a:t>Folga de 30 s.</a:t>
             </a:r>
-            <a:endParaRPr/>
-          </a:p>
-          <a:p>
-            <a:pPr indent="0" lvl="0" marL="0" rtl="0" algn="l">
-              <a:lnSpc>
-                <a:spcPct val="100000"/>
-              </a:lnSpc>
-              <a:spcBef>
-                <a:spcPts val="0"/>
-              </a:spcBef>
-              <a:spcAft>
-                <a:spcPts val="0"/>
-              </a:spcAft>
-              <a:buSzPts val="1100"/>
-              <a:buNone/>
-            </a:pPr>
-            <a:r>
-              <a:t/>
-            </a:r>
-            <a:endParaRPr/>
-          </a:p>
-          <a:p>
-            <a:pPr indent="0" lvl="0" marL="0" rtl="0" algn="l">
-              <a:lnSpc>
-                <a:spcPct val="100000"/>
-              </a:lnSpc>
-              <a:spcBef>
-                <a:spcPts val="0"/>
-              </a:spcBef>
-              <a:spcAft>
-                <a:spcPts val="0"/>
-              </a:spcAft>
-              <a:buSzPts val="1100"/>
-              <a:buNone/>
-            </a:pPr>
-            <a:r>
-              <a:rPr lang="en-US"/>
-              <a:t>Se o espelhamento falhar, abrir o vídeo reserva no trecho correspondente. Se tudo falhar, narrar a partir das telas deste slide.</a:t>
-            </a:r>
-            <a:endParaRPr/>
-          </a:p>
-          <a:p>
-            <a:pPr indent="0" lvl="0" marL="0" rtl="0" algn="l">
-              <a:lnSpc>
-                <a:spcPct val="100000"/>
-              </a:lnSpc>
-              <a:spcBef>
-                <a:spcPts val="0"/>
-              </a:spcBef>
-              <a:spcAft>
-                <a:spcPts val="0"/>
-              </a:spcAft>
-              <a:buSzPts val="1100"/>
-              <a:buNone/>
-            </a:pPr>
-            <a:r>
-              <a:rPr lang="en-US"/>
-              <a:t>Se atrasar, cortar nesta ordem: f, depois e, depois a correção em d.</a:t>
-            </a:r>
-            <a:endParaRPr/>
+          </a:p>
+          <a:p/>
+          <a:p>
+            <a:r>
+              <a:t>Se o espelhamento falhar, ir para o slide 12 e rodar o vídeo no trecho correspondente. Se tudo falhar, narrar a partir das telas do slide 11.</a:t>
+            </a:r>
+          </a:p>
+          <a:p>
+            <a:r>
+              <a:t>Se atrasar, cortar nesta ordem: f, depois e.</a:t>
+            </a:r>
           </a:p>
         </p:txBody>
       </p:sp>
@@ -2394,68 +1962,14 @@
           </a:bodyPr>
           <a:lstStyle/>
           <a:p>
-            <a:pPr indent="-298450" lvl="0" marL="457200" marR="0" rtl="0" algn="l">
-              <a:lnSpc>
-                <a:spcPct val="100000"/>
-              </a:lnSpc>
-              <a:spcBef>
-                <a:spcPts val="0"/>
-              </a:spcBef>
-              <a:spcAft>
-                <a:spcPts val="0"/>
-              </a:spcAft>
-              <a:buClr>
-                <a:srgbClr val="000000"/>
-              </a:buClr>
-              <a:buSzPts val="1100"/>
-              <a:buFont typeface="Arial"/>
-              <a:buChar char="●"/>
-            </a:pPr>
-            <a:r>
-              <a:rPr b="0" i="0" lang="en-US" spc="0" sz="1100" u="none" cap="none" strike="noStrike">
-                <a:solidFill>
-                  <a:srgbClr val="000000"/>
-                </a:solidFill>
-                <a:latin typeface="Arial"/>
-                <a:ea typeface="Arial"/>
-                <a:cs typeface="Arial"/>
-                <a:sym typeface="Arial"/>
-              </a:rPr>
+            <a:r>
               <a:t>[1 min]</a:t>
             </a:r>
-            <a:endParaRPr/>
-          </a:p>
-          <a:p>
-            <a:pPr indent="-298450" lvl="0" marL="457200" marR="0" rtl="0" algn="l">
-              <a:lnSpc>
-                <a:spcPct val="100000"/>
-              </a:lnSpc>
-              <a:spcBef>
-                <a:spcPts val="0"/>
-              </a:spcBef>
-              <a:spcAft>
-                <a:spcPts val="0"/>
-              </a:spcAft>
-              <a:buClr>
-                <a:srgbClr val="000000"/>
-              </a:buClr>
-              <a:buSzPts val="1100"/>
-              <a:buFont typeface="Arial"/>
-              <a:buChar char="●"/>
-            </a:pPr>
-            <a:r>
-              <a:rPr b="0" i="0" lang="en-US" spc="0" sz="1100" u="none" cap="none" strike="noStrike">
-                <a:solidFill>
-                  <a:srgbClr val="000000"/>
-                </a:solidFill>
-                <a:latin typeface="Arial"/>
-                <a:ea typeface="Arial"/>
-                <a:cs typeface="Arial"/>
-                <a:sym typeface="Arial"/>
-              </a:rPr>
-              <a:t>O alarme, que é o centro do app, foi testado nas quatro combinações de celular bloqueado ou em uso, com o app nos recentes ou fora deles. Com o celular bloqueado, a tela do alarme apareceu por cima da tela de bloqueio. Com o celular em uso, apareceu a notificação com os botões de tomar e pular. Nos testes, percebi que a tela do alarme herdava a permissão de aparecer sobre o bloqueio que era do app inteiro, então isolei essa tela, e ao fechar o alarme o celular volta a ficar bloqueado, sem expor os outros dados. A ressalva veio depois de reiniciar o celular. O alarme só tocou quando o aparelho foi desbloqueado, por uma restrição de inicialização automática que o fabricante aplica e que o Android não deixa contornar. O app passou a orientar o paciente a liberar essa permissão.</a:t>
-            </a:r>
-            <a:endParaRPr/>
+          </a:p>
+          <a:p>
+            <a:r>
+              <a:t>O alarme, que é o centro do app, foi testado nas quatro combinações de celular bloqueado ou em uso, com o app nos recentes ou fora deles. Com o celular bloqueado, a tela do alarme apareceu por cima da tela de bloqueio, e com o celular em uso, apareceu a notificação com os botões de tomar e pular. Em todas elas, quem dispara o alarme é o agendador do próprio Android, e não o app, por isso ele toca mesmo com o aplicativo fechado. A ressalva veio depois de reiniciar o celular. O alarme só tocou quando o aparelho foi desbloqueado, por uma restrição de inicialização automática que o fabricante aplica e que o Android não deixa contornar. O app passou a orientar o paciente a liberar essa permissão.</a:t>
+            </a:r>
           </a:p>
         </p:txBody>
       </p:sp>
@@ -4703,68 +4217,14 @@
           </a:bodyPr>
           <a:lstStyle/>
           <a:p>
-            <a:pPr indent="-298450" lvl="0" marL="457200" marR="0" rtl="0" algn="l">
-              <a:lnSpc>
-                <a:spcPct val="100000"/>
-              </a:lnSpc>
-              <a:spcBef>
-                <a:spcPts val="0"/>
-              </a:spcBef>
-              <a:spcAft>
-                <a:spcPts val="0"/>
-              </a:spcAft>
-              <a:buClr>
-                <a:srgbClr val="000000"/>
-              </a:buClr>
-              <a:buSzPts val="1100"/>
-              <a:buFont typeface="Arial"/>
-              <a:buChar char="●"/>
-            </a:pPr>
-            <a:r>
-              <a:rPr b="0" i="0" lang="en-US" spc="0" sz="1100" u="none" cap="none" strike="noStrike">
-                <a:solidFill>
-                  <a:srgbClr val="000000"/>
-                </a:solidFill>
-                <a:latin typeface="Arial"/>
-                <a:ea typeface="Arial"/>
-                <a:cs typeface="Arial"/>
-                <a:sym typeface="Arial"/>
-              </a:rPr>
+            <a:r>
               <a:t>[50 s]</a:t>
             </a:r>
-            <a:endParaRPr/>
-          </a:p>
-          <a:p>
-            <a:pPr indent="-298450" lvl="0" marL="457200" marR="0" rtl="0" algn="l">
-              <a:lnSpc>
-                <a:spcPct val="100000"/>
-              </a:lnSpc>
-              <a:spcBef>
-                <a:spcPts val="0"/>
-              </a:spcBef>
-              <a:spcAft>
-                <a:spcPts val="0"/>
-              </a:spcAft>
-              <a:buClr>
-                <a:srgbClr val="000000"/>
-              </a:buClr>
-              <a:buSzPts val="1100"/>
-              <a:buFont typeface="Arial"/>
-              <a:buChar char="●"/>
-            </a:pPr>
-            <a:r>
-              <a:rPr b="0" i="0" lang="en-US" spc="0" sz="1100" u="none" cap="none" strike="noStrike">
-                <a:solidFill>
-                  <a:srgbClr val="000000"/>
-                </a:solidFill>
-                <a:latin typeface="Arial"/>
-                <a:ea typeface="Arial"/>
-                <a:cs typeface="Arial"/>
-                <a:sym typeface="Arial"/>
-              </a:rPr>
-              <a:t>Os requisitos partiram dos problemas que o paciente enfrenta. São quarenta e quatro requisitos funcionais, nove não funcionais e vinte regras de negócio, e aqui eles estão organizados pelo problema que resolvem. Para o esquecimento, o alarme toca mesmo com o app fechado, e remédios no mesmo horário geram um aviso só. Para a posologia, o cadastro aceita dez formas farmacêuticas, quatro frequências e uma dose diferente em cada horário. Para o estoque, o app desconta a dose de verdade, e não uma unidade, então quem toma dois comprimidos tem dois descontados, e com isso prevê quando o remédio vai acabar. Consultas e exames aparecem no mesmo calendário das doses, e o app avisa quando a receita está para vencer. E tudo funciona sem internet e sem conta, com o paciente podendo exportar ou apagar os próprios dados.</a:t>
-            </a:r>
-            <a:endParaRPr/>
+          </a:p>
+          <a:p>
+            <a:r>
+              <a:t>Os requisitos partiram dos problemas que o paciente enfrenta. São quarenta e quatro requisitos funcionais, nove não funcionais e vinte regras de negócio, e aqui eles estão organizados pelo problema que resolvem. Para o esquecimento, o alarme toca mesmo com o app fechado, remédios no mesmo horário geram um aviso só, e quem tomou atrasado confirma as doses de uma vez. Para a posologia, o cadastro aceita dez formas farmacêuticas, quatro frequências e uma dose diferente em cada horário. Para o estoque, o app desconta a dose de verdade, e não uma unidade, então quem toma dois comprimidos tem dois descontados, e com isso prevê quando o remédio vai acabar. Como complemento, consultas e exames ficam no mesmo calendário das doses, e o app avisa quando a receita está para vencer, mas só a dose tem alarme, porque é ela que tem consequência imediata. E tudo funciona sem internet e sem conta, com o paciente podendo exportar ou apagar os próprios dados a qualquer momento.</a:t>
+            </a:r>
           </a:p>
         </p:txBody>
       </p:sp>

</xml_diff>